<commit_message>
pushing everything to make sure its up to date
</commit_message>
<xml_diff>
--- a/draft_presentation/draft_poster.pptx
+++ b/draft_presentation/draft_poster.pptx
@@ -5,11 +5,12 @@
     <p:sldMasterId id="2147483684" r:id="rId1"/>
   </p:sldMasterIdLst>
   <p:notesMasterIdLst>
-    <p:notesMasterId r:id="rId4"/>
+    <p:notesMasterId r:id="rId5"/>
   </p:notesMasterIdLst>
   <p:sldIdLst>
     <p:sldId id="307" r:id="rId2"/>
     <p:sldId id="308" r:id="rId3"/>
+    <p:sldId id="306" r:id="rId4"/>
   </p:sldIdLst>
   <p:sldSz cx="49377600" cy="32918400"/>
   <p:notesSz cx="6858000" cy="9144000"/>
@@ -931,6 +932,234 @@
     <p:extLst>
       <p:ext uri="{BB962C8B-B14F-4D97-AF65-F5344CB8AC3E}">
         <p14:creationId xmlns:p14="http://schemas.microsoft.com/office/powerpoint/2010/main" val="1713891390"/>
+      </p:ext>
+    </p:extLst>
+  </p:cSld>
+  <p:clrMapOvr>
+    <a:masterClrMapping/>
+  </p:clrMapOvr>
+</p:notes>
+</file>
+
+<file path=ppt/notesSlides/notesSlide3.xml><?xml version="1.0" encoding="utf-8"?>
+<p:notes xmlns:a="http://schemas.openxmlformats.org/drawingml/2006/main" xmlns:r="http://schemas.openxmlformats.org/officeDocument/2006/relationships" xmlns:p="http://schemas.openxmlformats.org/presentationml/2006/main">
+  <p:cSld>
+    <p:spTree>
+      <p:nvGrpSpPr>
+        <p:cNvPr id="1" name=""/>
+        <p:cNvGrpSpPr/>
+        <p:nvPr/>
+      </p:nvGrpSpPr>
+      <p:grpSpPr>
+        <a:xfrm>
+          <a:off x="0" y="0"/>
+          <a:ext cx="0" cy="0"/>
+          <a:chOff x="0" y="0"/>
+          <a:chExt cx="0" cy="0"/>
+        </a:xfrm>
+      </p:grpSpPr>
+      <p:sp>
+        <p:nvSpPr>
+          <p:cNvPr id="2" name="Slide Image Placeholder 1"/>
+          <p:cNvSpPr>
+            <a:spLocks noGrp="1" noRot="1" noChangeAspect="1"/>
+          </p:cNvSpPr>
+          <p:nvPr>
+            <p:ph type="sldImg"/>
+          </p:nvPr>
+        </p:nvSpPr>
+        <p:spPr/>
+      </p:sp>
+      <p:sp>
+        <p:nvSpPr>
+          <p:cNvPr id="3" name="Notes Placeholder 2"/>
+          <p:cNvSpPr>
+            <a:spLocks noGrp="1"/>
+          </p:cNvSpPr>
+          <p:nvPr>
+            <p:ph type="body" idx="1"/>
+          </p:nvPr>
+        </p:nvSpPr>
+        <p:spPr/>
+        <p:txBody>
+          <a:bodyPr/>
+          <a:lstStyle/>
+          <a:p>
+            <a:r>
+              <a:rPr lang="en-US" dirty="0"/>
+              <a:t>Notes:</a:t>
+            </a:r>
+          </a:p>
+          <a:p>
+            <a:pPr marL="171450" indent="-171450">
+              <a:buFont typeface="Arial" panose="020B0604020202020204" pitchFamily="34" charset="0"/>
+              <a:buChar char="•"/>
+            </a:pPr>
+            <a:r>
+              <a:rPr lang="en-US" dirty="0"/>
+              <a:t>In </a:t>
+            </a:r>
+            <a:r>
+              <a:rPr lang="en-US" dirty="0" err="1"/>
+              <a:t>Powerpoint</a:t>
+            </a:r>
+            <a:r>
+              <a:rPr lang="en-US" dirty="0"/>
+              <a:t>, click View &gt; Guides</a:t>
+            </a:r>
+          </a:p>
+          <a:p>
+            <a:pPr marL="171450" indent="-171450">
+              <a:buFont typeface="Arial" panose="020B0604020202020204" pitchFamily="34" charset="0"/>
+              <a:buChar char="•"/>
+            </a:pPr>
+            <a:r>
+              <a:rPr lang="en-US" dirty="0"/>
+              <a:t>Keep text within gutter guides.</a:t>
+            </a:r>
+          </a:p>
+          <a:p>
+            <a:pPr marL="171450" indent="-171450">
+              <a:buFont typeface="Arial" panose="020B0604020202020204" pitchFamily="34" charset="0"/>
+              <a:buChar char="•"/>
+            </a:pPr>
+            <a:r>
+              <a:rPr lang="en-US" dirty="0"/>
+              <a:t>Author list: Don’t split names onto two lines (e.g., “Jimmy [break] Smith”). If that happens, use a new line, unless you need the space. </a:t>
+            </a:r>
+            <a:r>
+              <a:rPr lang="en-US" b="1" dirty="0"/>
+              <a:t>Bold the first names of anybody who’s presenting</a:t>
+            </a:r>
+            <a:r>
+              <a:rPr lang="en-US" dirty="0"/>
+              <a:t> in person.</a:t>
+            </a:r>
+          </a:p>
+          <a:p>
+            <a:pPr marL="171450" indent="-171450">
+              <a:buFont typeface="Arial" panose="020B0604020202020204" pitchFamily="34" charset="0"/>
+              <a:buChar char="•"/>
+            </a:pPr>
+            <a:r>
+              <a:rPr lang="en-US" dirty="0"/>
+              <a:t>Intro/methods/result: </a:t>
+            </a:r>
+            <a:r>
+              <a:rPr lang="en-US" b="1" dirty="0"/>
+              <a:t>Do not drop below font size 28</a:t>
+            </a:r>
+            <a:r>
+              <a:rPr lang="en-US" dirty="0"/>
+              <a:t>, but if you have extra space, jack up the font size until the space is full.</a:t>
+            </a:r>
+          </a:p>
+          <a:p>
+            <a:pPr marL="171450" indent="-171450">
+              <a:buFont typeface="Arial" panose="020B0604020202020204" pitchFamily="34" charset="0"/>
+              <a:buChar char="•"/>
+            </a:pPr>
+            <a:r>
+              <a:rPr lang="en-US" dirty="0"/>
+              <a:t>Do not use color in the sidebars except in graphs/figures. It’ll pull attention from the center and slow interpretation for passersby.</a:t>
+            </a:r>
+          </a:p>
+          <a:p>
+            <a:pPr marL="0" indent="0">
+              <a:buFont typeface="Arial" panose="020B0604020202020204" pitchFamily="34" charset="0"/>
+              <a:buNone/>
+            </a:pPr>
+            <a:endParaRPr lang="en-US" dirty="0"/>
+          </a:p>
+        </p:txBody>
+      </p:sp>
+      <p:sp>
+        <p:nvSpPr>
+          <p:cNvPr id="4" name="Slide Number Placeholder 3"/>
+          <p:cNvSpPr>
+            <a:spLocks noGrp="1"/>
+          </p:cNvSpPr>
+          <p:nvPr>
+            <p:ph type="sldNum" sz="quarter" idx="5"/>
+          </p:nvPr>
+        </p:nvSpPr>
+        <p:spPr/>
+        <p:txBody>
+          <a:bodyPr/>
+          <a:lstStyle/>
+          <a:p>
+            <a:pPr marL="0" marR="0" lvl="0" indent="0" algn="r" defTabSz="457200" rtl="0" eaLnBrk="1" fontAlgn="auto" latinLnBrk="0" hangingPunct="1">
+              <a:lnSpc>
+                <a:spcPct val="100000"/>
+              </a:lnSpc>
+              <a:spcBef>
+                <a:spcPts val="0"/>
+              </a:spcBef>
+              <a:spcAft>
+                <a:spcPts val="0"/>
+              </a:spcAft>
+              <a:buClrTx/>
+              <a:buSzTx/>
+              <a:buFontTx/>
+              <a:buNone/>
+              <a:tabLst/>
+              <a:defRPr/>
+            </a:pPr>
+            <a:fld id="{E26C2670-3342-473C-969D-FDFF399F2050}" type="slidenum">
+              <a:rPr kumimoji="0" lang="en-US" sz="1200" b="0" i="0" u="none" strike="noStrike" kern="1200" cap="none" spc="0" normalizeH="0" baseline="0" noProof="0" smtClean="0">
+                <a:ln>
+                  <a:noFill/>
+                </a:ln>
+                <a:solidFill>
+                  <a:prstClr val="black"/>
+                </a:solidFill>
+                <a:effectLst/>
+                <a:uLnTx/>
+                <a:uFillTx/>
+                <a:latin typeface="Calibri" panose="020F0502020204030204"/>
+                <a:ea typeface="+mn-ea"/>
+                <a:cs typeface="+mn-cs"/>
+              </a:rPr>
+              <a:pPr marL="0" marR="0" lvl="0" indent="0" algn="r" defTabSz="457200" rtl="0" eaLnBrk="1" fontAlgn="auto" latinLnBrk="0" hangingPunct="1">
+                <a:lnSpc>
+                  <a:spcPct val="100000"/>
+                </a:lnSpc>
+                <a:spcBef>
+                  <a:spcPts val="0"/>
+                </a:spcBef>
+                <a:spcAft>
+                  <a:spcPts val="0"/>
+                </a:spcAft>
+                <a:buClrTx/>
+                <a:buSzTx/>
+                <a:buFontTx/>
+                <a:buNone/>
+                <a:tabLst/>
+                <a:defRPr/>
+              </a:pPr>
+              <a:t>3</a:t>
+            </a:fld>
+            <a:endParaRPr kumimoji="0" lang="en-US" sz="1200" b="0" i="0" u="none" strike="noStrike" kern="1200" cap="none" spc="0" normalizeH="0" baseline="0" noProof="0">
+              <a:ln>
+                <a:noFill/>
+              </a:ln>
+              <a:solidFill>
+                <a:prstClr val="black"/>
+              </a:solidFill>
+              <a:effectLst/>
+              <a:uLnTx/>
+              <a:uFillTx/>
+              <a:latin typeface="Calibri" panose="020F0502020204030204"/>
+              <a:ea typeface="+mn-ea"/>
+              <a:cs typeface="+mn-cs"/>
+            </a:endParaRPr>
+          </a:p>
+        </p:txBody>
+      </p:sp>
+    </p:spTree>
+    <p:extLst>
+      <p:ext uri="{BB962C8B-B14F-4D97-AF65-F5344CB8AC3E}">
+        <p14:creationId xmlns:p14="http://schemas.microsoft.com/office/powerpoint/2010/main" val="972003836"/>
       </p:ext>
     </p:extLst>
   </p:cSld>
@@ -3953,7 +4182,7 @@
         </p:nvSpPr>
         <p:spPr>
           <a:xfrm>
-            <a:off x="35565346" y="0"/>
+            <a:off x="35565346" y="-4954"/>
             <a:ext cx="13812254" cy="32918400"/>
           </a:xfrm>
           <a:prstGeom prst="rect">
@@ -4003,7 +4232,7 @@
               <a:tabLst/>
               <a:defRPr/>
             </a:pPr>
-            <a:endParaRPr kumimoji="0" lang="en-US" sz="1800" b="0" i="0" u="none" strike="noStrike" kern="1200" cap="none" spc="0" normalizeH="0" baseline="0" noProof="0">
+            <a:endParaRPr kumimoji="0" lang="en-US" sz="1800" b="0" i="0" u="none" strike="noStrike" kern="1200" cap="none" spc="0" normalizeH="0" baseline="0" noProof="0" dirty="0">
               <a:ln>
                 <a:noFill/>
               </a:ln>
@@ -4184,8 +4413,8 @@
         </p:nvSpPr>
         <p:spPr>
           <a:xfrm>
-            <a:off x="19905935" y="30123113"/>
-            <a:ext cx="4770892" cy="2308324"/>
+            <a:off x="19048206" y="30779034"/>
+            <a:ext cx="4770892" cy="1938992"/>
           </a:xfrm>
           <a:prstGeom prst="rect">
             <a:avLst/>
@@ -4216,7 +4445,7 @@
               <a:defRPr/>
             </a:pPr>
             <a:r>
-              <a:rPr kumimoji="0" lang="en-US" sz="4800" b="0" i="0" u="none" strike="noStrike" kern="1200" cap="none" spc="0" normalizeH="0" baseline="0" noProof="0" dirty="0">
+              <a:rPr kumimoji="0" lang="en-US" sz="4000" b="0" i="0" u="none" strike="noStrike" kern="1200" cap="none" spc="0" normalizeH="0" baseline="0" noProof="0" dirty="0">
                 <a:ln>
                   <a:noFill/>
                 </a:ln>
@@ -4229,14 +4458,13 @@
                 <a:effectLst/>
                 <a:uLnTx/>
                 <a:uFillTx/>
-                <a:latin typeface="Lato Black" panose="020F0A02020204030203" pitchFamily="34" charset="0"/>
-                <a:ea typeface="+mn-ea"/>
+                <a:latin typeface="Arial" panose="020B0604020202020204" pitchFamily="34" charset="0"/>
                 <a:cs typeface="Arial" panose="020B0604020202020204" pitchFamily="34" charset="0"/>
               </a:rPr>
-              <a:t>Scan </a:t>
-            </a:r>
-            <a:r>
-              <a:rPr kumimoji="0" lang="en-US" sz="4800" b="0" i="0" u="none" strike="noStrike" kern="1200" cap="none" spc="0" normalizeH="0" baseline="0" noProof="0" dirty="0">
+              <a:t>Scan to </a:t>
+            </a:r>
+            <a:br>
+              <a:rPr kumimoji="0" lang="en-US" sz="4000" b="0" i="0" u="none" strike="noStrike" kern="1200" cap="none" spc="0" normalizeH="0" baseline="0" noProof="0" dirty="0">
                 <a:ln>
                   <a:noFill/>
                 </a:ln>
@@ -4249,14 +4477,12 @@
                 <a:effectLst/>
                 <a:uLnTx/>
                 <a:uFillTx/>
-                <a:latin typeface="Lato" panose="020F0502020204030203" pitchFamily="34" charset="0"/>
-                <a:ea typeface="+mn-ea"/>
+                <a:latin typeface="Arial" panose="020B0604020202020204" pitchFamily="34" charset="0"/>
                 <a:cs typeface="Arial" panose="020B0604020202020204" pitchFamily="34" charset="0"/>
               </a:rPr>
-              <a:t>to </a:t>
-            </a:r>
-            <a:br>
-              <a:rPr kumimoji="0" lang="en-US" sz="4800" b="0" i="0" u="none" strike="noStrike" kern="1200" cap="none" spc="0" normalizeH="0" baseline="0" noProof="0" dirty="0">
+            </a:br>
+            <a:r>
+              <a:rPr kumimoji="0" lang="en-US" sz="4000" b="0" i="0" u="none" strike="noStrike" kern="1200" cap="none" spc="0" normalizeH="0" baseline="0" noProof="0" dirty="0">
                 <a:ln>
                   <a:noFill/>
                 </a:ln>
@@ -4269,13 +4495,13 @@
                 <a:effectLst/>
                 <a:uLnTx/>
                 <a:uFillTx/>
-                <a:latin typeface="Lato" panose="020F0502020204030203" pitchFamily="34" charset="0"/>
-                <a:ea typeface="+mn-ea"/>
+                <a:latin typeface="Arial" panose="020B0604020202020204" pitchFamily="34" charset="0"/>
                 <a:cs typeface="Arial" panose="020B0604020202020204" pitchFamily="34" charset="0"/>
               </a:rPr>
-            </a:br>
-            <a:r>
-              <a:rPr kumimoji="0" lang="en-US" sz="4800" b="0" i="0" u="none" strike="noStrike" kern="1200" cap="none" spc="0" normalizeH="0" baseline="0" noProof="0" dirty="0">
+              <a:t>view the</a:t>
+            </a:r>
+            <a:r>
+              <a:rPr kumimoji="0" lang="en-US" sz="4000" b="1" i="0" u="none" strike="noStrike" kern="1200" cap="none" spc="0" normalizeH="0" baseline="0" noProof="0" dirty="0">
                 <a:ln>
                   <a:noFill/>
                 </a:ln>
@@ -4288,14 +4514,13 @@
                 <a:effectLst/>
                 <a:uLnTx/>
                 <a:uFillTx/>
-                <a:latin typeface="Lato Black" panose="020F0A02020204030203" pitchFamily="34" charset="0"/>
-                <a:ea typeface="+mn-ea"/>
+                <a:latin typeface="Arial" panose="020B0604020202020204" pitchFamily="34" charset="0"/>
                 <a:cs typeface="Arial" panose="020B0604020202020204" pitchFamily="34" charset="0"/>
               </a:rPr>
-              <a:t>view</a:t>
-            </a:r>
-            <a:r>
-              <a:rPr kumimoji="0" lang="en-US" sz="4800" b="0" i="0" u="none" strike="noStrike" kern="1200" cap="none" spc="0" normalizeH="0" baseline="0" noProof="0" dirty="0">
+              <a:t> </a:t>
+            </a:r>
+            <a:r>
+              <a:rPr kumimoji="0" lang="en-US" sz="4000" b="0" i="0" u="none" strike="noStrike" kern="1200" cap="none" spc="0" normalizeH="0" baseline="0" noProof="0" dirty="0">
                 <a:ln>
                   <a:noFill/>
                 </a:ln>
@@ -4308,48 +4533,7 @@
                 <a:effectLst/>
                 <a:uLnTx/>
                 <a:uFillTx/>
-                <a:latin typeface="Lato" panose="020F0502020204030203" pitchFamily="34" charset="0"/>
-                <a:ea typeface="+mn-ea"/>
-                <a:cs typeface="Arial" panose="020B0604020202020204" pitchFamily="34" charset="0"/>
-              </a:rPr>
-              <a:t> the</a:t>
-            </a:r>
-            <a:r>
-              <a:rPr kumimoji="0" lang="en-US" sz="4800" b="1" i="0" u="none" strike="noStrike" kern="1200" cap="none" spc="0" normalizeH="0" baseline="0" noProof="0" dirty="0">
-                <a:ln>
-                  <a:noFill/>
-                </a:ln>
-                <a:solidFill>
-                  <a:schemeClr val="tx1">
-                    <a:lumMod val="75000"/>
-                    <a:lumOff val="25000"/>
-                  </a:schemeClr>
-                </a:solidFill>
-                <a:effectLst/>
-                <a:uLnTx/>
-                <a:uFillTx/>
-                <a:latin typeface="Lato" panose="020F0502020204030203" pitchFamily="34" charset="0"/>
-                <a:ea typeface="+mn-ea"/>
-                <a:cs typeface="Arial" panose="020B0604020202020204" pitchFamily="34" charset="0"/>
-              </a:rPr>
-              <a:t> </a:t>
-            </a:r>
-            <a:r>
-              <a:rPr kumimoji="0" lang="en-US" sz="4800" b="0" i="0" u="none" strike="noStrike" kern="1200" cap="none" spc="0" normalizeH="0" baseline="0" noProof="0" dirty="0">
-                <a:ln>
-                  <a:noFill/>
-                </a:ln>
-                <a:solidFill>
-                  <a:schemeClr val="tx1">
-                    <a:lumMod val="75000"/>
-                    <a:lumOff val="25000"/>
-                  </a:schemeClr>
-                </a:solidFill>
-                <a:effectLst/>
-                <a:uLnTx/>
-                <a:uFillTx/>
-                <a:latin typeface="Lato Black" panose="020F0A02020204030203" pitchFamily="34" charset="0"/>
-                <a:ea typeface="+mn-ea"/>
+                <a:latin typeface="Arial" panose="020B0604020202020204" pitchFamily="34" charset="0"/>
                 <a:cs typeface="Arial" panose="020B0604020202020204" pitchFamily="34" charset="0"/>
               </a:rPr>
               <a:t>project on GitHub</a:t>
@@ -4373,7 +4557,7 @@
         </p:nvCxnSpPr>
         <p:spPr>
           <a:xfrm flipH="1">
-            <a:off x="18223104" y="31277275"/>
+            <a:off x="17365375" y="31933196"/>
             <a:ext cx="1297464" cy="0"/>
           </a:xfrm>
           <a:prstGeom prst="straightConnector1">
@@ -4593,377 +4777,6 @@
       </p:sp>
       <p:pic>
         <p:nvPicPr>
-          <p:cNvPr id="27" name="Graphic 26">
-            <a:extLst>
-              <a:ext uri="{FF2B5EF4-FFF2-40B4-BE49-F238E27FC236}">
-                <a16:creationId xmlns:a16="http://schemas.microsoft.com/office/drawing/2014/main" id="{B62BF9C0-8774-4458-8210-ACA4788001C5}"/>
-              </a:ext>
-            </a:extLst>
-          </p:cNvPr>
-          <p:cNvPicPr>
-            <a:picLocks noChangeAspect="1"/>
-          </p:cNvPicPr>
-          <p:nvPr/>
-        </p:nvPicPr>
-        <p:blipFill>
-          <a:blip>
-            <a:extLst>
-              <a:ext uri="{96DAC541-7B7A-43D3-8B79-37D633B846F1}">
-                <asvg:svgBlip xmlns:asvg="http://schemas.microsoft.com/office/drawing/2016/SVG/main" r:embed="rId5"/>
-              </a:ext>
-            </a:extLst>
-          </a:blip>
-          <a:stretch>
-            <a:fillRect/>
-          </a:stretch>
-        </p:blipFill>
-        <p:spPr>
-          <a:xfrm>
-            <a:off x="19410697" y="20542687"/>
-            <a:ext cx="12223692" cy="8149128"/>
-          </a:xfrm>
-          <a:prstGeom prst="rect">
-            <a:avLst/>
-          </a:prstGeom>
-        </p:spPr>
-      </p:pic>
-      <p:sp>
-        <p:nvSpPr>
-          <p:cNvPr id="23" name="Graphic 18">
-            <a:extLst>
-              <a:ext uri="{FF2B5EF4-FFF2-40B4-BE49-F238E27FC236}">
-                <a16:creationId xmlns:a16="http://schemas.microsoft.com/office/drawing/2014/main" id="{1B355378-8069-4F41-9F33-76FF52B1D680}"/>
-              </a:ext>
-            </a:extLst>
-          </p:cNvPr>
-          <p:cNvSpPr/>
-          <p:nvPr/>
-        </p:nvSpPr>
-        <p:spPr>
-          <a:xfrm>
-            <a:off x="40636456" y="25584006"/>
-            <a:ext cx="360430" cy="335196"/>
-          </a:xfrm>
-          <a:custGeom>
-            <a:avLst/>
-            <a:gdLst>
-              <a:gd name="connsiteX0" fmla="*/ 310594 w 327663"/>
-              <a:gd name="connsiteY0" fmla="*/ 219906 h 335196"/>
-              <a:gd name="connsiteX1" fmla="*/ 246568 w 327663"/>
-              <a:gd name="connsiteY1" fmla="*/ 176217 h 335196"/>
-              <a:gd name="connsiteX2" fmla="*/ 212295 w 327663"/>
-              <a:gd name="connsiteY2" fmla="*/ 176217 h 335196"/>
-              <a:gd name="connsiteX3" fmla="*/ 165217 w 327663"/>
-              <a:gd name="connsiteY3" fmla="*/ 189022 h 335196"/>
-              <a:gd name="connsiteX4" fmla="*/ 118138 w 327663"/>
-              <a:gd name="connsiteY4" fmla="*/ 176217 h 335196"/>
-              <a:gd name="connsiteX5" fmla="*/ 83866 w 327663"/>
-              <a:gd name="connsiteY5" fmla="*/ 176217 h 335196"/>
-              <a:gd name="connsiteX6" fmla="*/ 19839 w 327663"/>
-              <a:gd name="connsiteY6" fmla="*/ 219906 h 335196"/>
-              <a:gd name="connsiteX7" fmla="*/ 1385 w 327663"/>
-              <a:gd name="connsiteY7" fmla="*/ 299750 h 335196"/>
-              <a:gd name="connsiteX8" fmla="*/ 165970 w 327663"/>
-              <a:gd name="connsiteY8" fmla="*/ 335529 h 335196"/>
-              <a:gd name="connsiteX9" fmla="*/ 329802 w 327663"/>
-              <a:gd name="connsiteY9" fmla="*/ 299750 h 335196"/>
-              <a:gd name="connsiteX10" fmla="*/ 310594 w 327663"/>
-              <a:gd name="connsiteY10" fmla="*/ 219906 h 335196"/>
-              <a:gd name="connsiteX11" fmla="*/ 165593 w 327663"/>
-              <a:gd name="connsiteY11" fmla="*/ 154749 h 335196"/>
-              <a:gd name="connsiteX12" fmla="*/ 242425 w 327663"/>
-              <a:gd name="connsiteY12" fmla="*/ 77918 h 335196"/>
-              <a:gd name="connsiteX13" fmla="*/ 165593 w 327663"/>
-              <a:gd name="connsiteY13" fmla="*/ 1086 h 335196"/>
-              <a:gd name="connsiteX14" fmla="*/ 88762 w 327663"/>
-              <a:gd name="connsiteY14" fmla="*/ 77918 h 335196"/>
-              <a:gd name="connsiteX15" fmla="*/ 165593 w 327663"/>
-              <a:gd name="connsiteY15" fmla="*/ 154749 h 335196"/>
-            </a:gdLst>
-            <a:ahLst/>
-            <a:cxnLst>
-              <a:cxn ang="0">
-                <a:pos x="connsiteX0" y="connsiteY0"/>
-              </a:cxn>
-              <a:cxn ang="0">
-                <a:pos x="connsiteX1" y="connsiteY1"/>
-              </a:cxn>
-              <a:cxn ang="0">
-                <a:pos x="connsiteX2" y="connsiteY2"/>
-              </a:cxn>
-              <a:cxn ang="0">
-                <a:pos x="connsiteX3" y="connsiteY3"/>
-              </a:cxn>
-              <a:cxn ang="0">
-                <a:pos x="connsiteX4" y="connsiteY4"/>
-              </a:cxn>
-              <a:cxn ang="0">
-                <a:pos x="connsiteX5" y="connsiteY5"/>
-              </a:cxn>
-              <a:cxn ang="0">
-                <a:pos x="connsiteX6" y="connsiteY6"/>
-              </a:cxn>
-              <a:cxn ang="0">
-                <a:pos x="connsiteX7" y="connsiteY7"/>
-              </a:cxn>
-              <a:cxn ang="0">
-                <a:pos x="connsiteX8" y="connsiteY8"/>
-              </a:cxn>
-              <a:cxn ang="0">
-                <a:pos x="connsiteX9" y="connsiteY9"/>
-              </a:cxn>
-              <a:cxn ang="0">
-                <a:pos x="connsiteX10" y="connsiteY10"/>
-              </a:cxn>
-              <a:cxn ang="0">
-                <a:pos x="connsiteX11" y="connsiteY11"/>
-              </a:cxn>
-              <a:cxn ang="0">
-                <a:pos x="connsiteX12" y="connsiteY12"/>
-              </a:cxn>
-              <a:cxn ang="0">
-                <a:pos x="connsiteX13" y="connsiteY13"/>
-              </a:cxn>
-              <a:cxn ang="0">
-                <a:pos x="connsiteX14" y="connsiteY14"/>
-              </a:cxn>
-              <a:cxn ang="0">
-                <a:pos x="connsiteX15" y="connsiteY15"/>
-              </a:cxn>
-            </a:cxnLst>
-            <a:rect l="l" t="t" r="r" b="b"/>
-            <a:pathLst>
-              <a:path w="327663" h="335196">
-                <a:moveTo>
-                  <a:pt x="310594" y="219906"/>
-                </a:moveTo>
-                <a:cubicBezTo>
-                  <a:pt x="287243" y="179983"/>
-                  <a:pt x="246568" y="176217"/>
-                  <a:pt x="246568" y="176217"/>
-                </a:cubicBezTo>
-                <a:lnTo>
-                  <a:pt x="212295" y="176217"/>
-                </a:lnTo>
-                <a:cubicBezTo>
-                  <a:pt x="198360" y="184126"/>
-                  <a:pt x="182541" y="189022"/>
-                  <a:pt x="165217" y="189022"/>
-                </a:cubicBezTo>
-                <a:cubicBezTo>
-                  <a:pt x="147892" y="189022"/>
-                  <a:pt x="132074" y="184503"/>
-                  <a:pt x="118138" y="176217"/>
-                </a:cubicBezTo>
-                <a:lnTo>
-                  <a:pt x="83866" y="176217"/>
-                </a:lnTo>
-                <a:cubicBezTo>
-                  <a:pt x="83866" y="176217"/>
-                  <a:pt x="43190" y="179983"/>
-                  <a:pt x="19839" y="219906"/>
-                </a:cubicBezTo>
-                <a:cubicBezTo>
-                  <a:pt x="-2758" y="259828"/>
-                  <a:pt x="1385" y="299750"/>
-                  <a:pt x="1385" y="299750"/>
-                </a:cubicBezTo>
-                <a:cubicBezTo>
-                  <a:pt x="1385" y="299750"/>
-                  <a:pt x="37164" y="335529"/>
-                  <a:pt x="165970" y="335529"/>
-                </a:cubicBezTo>
-                <a:cubicBezTo>
-                  <a:pt x="294776" y="335529"/>
-                  <a:pt x="329802" y="299750"/>
-                  <a:pt x="329802" y="299750"/>
-                </a:cubicBezTo>
-                <a:cubicBezTo>
-                  <a:pt x="329802" y="299750"/>
-                  <a:pt x="333945" y="259828"/>
-                  <a:pt x="310594" y="219906"/>
-                </a:cubicBezTo>
-                <a:close/>
-                <a:moveTo>
-                  <a:pt x="165593" y="154749"/>
-                </a:moveTo>
-                <a:cubicBezTo>
-                  <a:pt x="208152" y="154749"/>
-                  <a:pt x="242425" y="120477"/>
-                  <a:pt x="242425" y="77918"/>
-                </a:cubicBezTo>
-                <a:cubicBezTo>
-                  <a:pt x="242425" y="35359"/>
-                  <a:pt x="208152" y="1086"/>
-                  <a:pt x="165593" y="1086"/>
-                </a:cubicBezTo>
-                <a:cubicBezTo>
-                  <a:pt x="123035" y="1086"/>
-                  <a:pt x="88762" y="35736"/>
-                  <a:pt x="88762" y="77918"/>
-                </a:cubicBezTo>
-                <a:cubicBezTo>
-                  <a:pt x="88762" y="120477"/>
-                  <a:pt x="123035" y="154749"/>
-                  <a:pt x="165593" y="154749"/>
-                </a:cubicBezTo>
-                <a:close/>
-              </a:path>
-            </a:pathLst>
-          </a:custGeom>
-          <a:solidFill>
-            <a:schemeClr val="tx1">
-              <a:lumMod val="50000"/>
-              <a:lumOff val="50000"/>
-            </a:schemeClr>
-          </a:solidFill>
-          <a:ln w="3663" cap="flat">
-            <a:noFill/>
-            <a:prstDash val="solid"/>
-            <a:miter/>
-          </a:ln>
-        </p:spPr>
-        <p:txBody>
-          <a:bodyPr rtlCol="0" anchor="ctr"/>
-          <a:lstStyle/>
-          <a:p>
-            <a:pPr marL="0" marR="0" lvl="0" indent="0" algn="l" defTabSz="457200" rtl="0" eaLnBrk="1" fontAlgn="auto" latinLnBrk="0" hangingPunct="1">
-              <a:lnSpc>
-                <a:spcPct val="100000"/>
-              </a:lnSpc>
-              <a:spcBef>
-                <a:spcPts val="0"/>
-              </a:spcBef>
-              <a:spcAft>
-                <a:spcPts val="0"/>
-              </a:spcAft>
-              <a:buClrTx/>
-              <a:buSzTx/>
-              <a:buFontTx/>
-              <a:buNone/>
-              <a:tabLst/>
-              <a:defRPr/>
-            </a:pPr>
-            <a:endParaRPr kumimoji="0" lang="en-US" sz="1800" b="0" i="0" u="none" strike="noStrike" kern="1200" cap="none" spc="0" normalizeH="0" baseline="0" noProof="0">
-              <a:ln>
-                <a:noFill/>
-              </a:ln>
-              <a:solidFill>
-                <a:prstClr val="black"/>
-              </a:solidFill>
-              <a:effectLst/>
-              <a:uLnTx/>
-              <a:uFillTx/>
-              <a:latin typeface="Calibri" panose="020F0502020204030204"/>
-              <a:ea typeface="+mn-ea"/>
-              <a:cs typeface="+mn-cs"/>
-            </a:endParaRPr>
-          </a:p>
-        </p:txBody>
-      </p:sp>
-      <p:sp>
-        <p:nvSpPr>
-          <p:cNvPr id="2" name="Rectangle 1">
-            <a:extLst>
-              <a:ext uri="{FF2B5EF4-FFF2-40B4-BE49-F238E27FC236}">
-                <a16:creationId xmlns:a16="http://schemas.microsoft.com/office/drawing/2014/main" id="{ADC988AD-FB82-4850-84BE-0F496EB3BDC0}"/>
-              </a:ext>
-            </a:extLst>
-          </p:cNvPr>
-          <p:cNvSpPr/>
-          <p:nvPr/>
-        </p:nvSpPr>
-        <p:spPr>
-          <a:xfrm>
-            <a:off x="20708991" y="29685166"/>
-            <a:ext cx="24688800" cy="1200329"/>
-          </a:xfrm>
-          <a:prstGeom prst="rect">
-            <a:avLst/>
-          </a:prstGeom>
-        </p:spPr>
-        <p:txBody>
-          <a:bodyPr>
-            <a:spAutoFit/>
-          </a:bodyPr>
-          <a:lstStyle/>
-          <a:p>
-            <a:pPr marL="0" marR="0" lvl="0" indent="0" algn="l" defTabSz="457200" rtl="0" eaLnBrk="1" fontAlgn="auto" latinLnBrk="0" hangingPunct="1">
-              <a:lnSpc>
-                <a:spcPct val="100000"/>
-              </a:lnSpc>
-              <a:spcBef>
-                <a:spcPts val="0"/>
-              </a:spcBef>
-              <a:spcAft>
-                <a:spcPts val="0"/>
-              </a:spcAft>
-              <a:buClrTx/>
-              <a:buSzTx/>
-              <a:buFontTx/>
-              <a:buNone/>
-              <a:tabLst/>
-              <a:defRPr/>
-            </a:pPr>
-            <a:r>
-              <a:rPr kumimoji="0" lang="en-US" sz="3600" b="0" i="0" u="none" strike="noStrike" kern="1200" cap="none" spc="0" normalizeH="0" baseline="0" noProof="0" dirty="0">
-                <a:ln>
-                  <a:noFill/>
-                </a:ln>
-                <a:solidFill>
-                  <a:prstClr val="white">
-                    <a:lumMod val="50000"/>
-                  </a:prstClr>
-                </a:solidFill>
-                <a:effectLst/>
-                <a:uLnTx/>
-                <a:uFillTx/>
-                <a:latin typeface="Lato" panose="020F0502020204030203" pitchFamily="34" charset="0"/>
-                <a:ea typeface="+mn-ea"/>
-                <a:cs typeface="Segoe UI" panose="020B0502040204020203" pitchFamily="34" charset="0"/>
-              </a:rPr>
-              <a:t>Visualize your findings with an image, graphic, or a key figure.</a:t>
-            </a:r>
-          </a:p>
-          <a:p>
-            <a:pPr marL="0" marR="0" lvl="0" indent="0" algn="l" defTabSz="457200" rtl="0" eaLnBrk="1" fontAlgn="auto" latinLnBrk="0" hangingPunct="1">
-              <a:lnSpc>
-                <a:spcPct val="100000"/>
-              </a:lnSpc>
-              <a:spcBef>
-                <a:spcPts val="0"/>
-              </a:spcBef>
-              <a:spcAft>
-                <a:spcPts val="0"/>
-              </a:spcAft>
-              <a:buClrTx/>
-              <a:buSzTx/>
-              <a:buFontTx/>
-              <a:buNone/>
-              <a:tabLst/>
-              <a:defRPr/>
-            </a:pPr>
-            <a:endParaRPr kumimoji="0" lang="en-US" sz="3600" b="0" i="0" u="none" strike="noStrike" kern="1200" cap="none" spc="0" normalizeH="0" baseline="0" noProof="0" dirty="0">
-              <a:ln>
-                <a:noFill/>
-              </a:ln>
-              <a:solidFill>
-                <a:prstClr val="white">
-                  <a:lumMod val="50000"/>
-                </a:prstClr>
-              </a:solidFill>
-              <a:effectLst/>
-              <a:uLnTx/>
-              <a:uFillTx/>
-              <a:latin typeface="Lato" panose="020F0502020204030203" pitchFamily="34" charset="0"/>
-              <a:ea typeface="+mn-ea"/>
-              <a:cs typeface="Segoe UI" panose="020B0502040204020203" pitchFamily="34" charset="0"/>
-            </a:endParaRPr>
-          </a:p>
-        </p:txBody>
-      </p:sp>
-      <p:pic>
-        <p:nvPicPr>
           <p:cNvPr id="1028" name="Picture 4" descr="MSU Trademarks | University Trademarks and Licensing ...">
             <a:extLst>
               <a:ext uri="{FF2B5EF4-FFF2-40B4-BE49-F238E27FC236}">
@@ -4977,7 +4790,7 @@
           <p:nvPr/>
         </p:nvPicPr>
         <p:blipFill>
-          <a:blip r:embed="rId6">
+          <a:blip r:embed="rId5">
             <a:duotone>
               <a:prstClr val="black"/>
               <a:schemeClr val="accent5">
@@ -4989,7 +4802,7 @@
             <a:extLst>
               <a:ext uri="{BEBA8EAE-BF5A-486C-A8C5-ECC9F3942E4B}">
                 <a14:imgProps xmlns:a14="http://schemas.microsoft.com/office/drawing/2010/main">
-                  <a14:imgLayer r:embed="rId7">
+                  <a14:imgLayer r:embed="rId6">
                     <a14:imgEffect>
                       <a14:backgroundRemoval t="6000" b="95667" l="3600" r="94800">
                         <a14:foregroundMark x1="30400" y1="20000" x2="30400" y2="20000"/>
@@ -5039,8 +4852,8 @@
         </p:blipFill>
         <p:spPr bwMode="auto">
           <a:xfrm>
-            <a:off x="42566588" y="27698463"/>
-            <a:ext cx="3954365" cy="4745238"/>
+            <a:off x="4850363" y="28466366"/>
+            <a:ext cx="2564777" cy="3077732"/>
           </a:xfrm>
           <a:prstGeom prst="rect">
             <a:avLst/>
@@ -5072,15 +4885,15 @@
           <p:nvPr/>
         </p:nvPicPr>
         <p:blipFill>
-          <a:blip r:embed="rId8"/>
+          <a:blip r:embed="rId7"/>
           <a:stretch>
             <a:fillRect/>
           </a:stretch>
         </p:blipFill>
         <p:spPr>
           <a:xfrm>
-            <a:off x="14050591" y="28918178"/>
-            <a:ext cx="3988781" cy="3934635"/>
+            <a:off x="14197620" y="30184072"/>
+            <a:ext cx="2767264" cy="2729700"/>
           </a:xfrm>
           <a:prstGeom prst="rect">
             <a:avLst/>
@@ -5102,7 +4915,7 @@
           <p:nvPr/>
         </p:nvPicPr>
         <p:blipFill>
-          <a:blip r:embed="rId9"/>
+          <a:blip r:embed="rId8"/>
           <a:srcRect l="6701" t="7162" r="3152" b="25229"/>
           <a:stretch>
             <a:fillRect/>
@@ -5141,13 +4954,13 @@
           <p:nvPr/>
         </p:nvPicPr>
         <p:blipFill>
-          <a:blip r:embed="rId10"/>
+          <a:blip r:embed="rId9"/>
           <a:srcRect/>
           <a:stretch/>
         </p:blipFill>
         <p:spPr>
           <a:xfrm>
-            <a:off x="260838" y="12172968"/>
+            <a:off x="70860" y="13996101"/>
             <a:ext cx="13206869" cy="6100033"/>
           </a:xfrm>
           <a:prstGeom prst="rect">
@@ -5169,8 +4982,8 @@
         </p:nvSpPr>
         <p:spPr>
           <a:xfrm>
-            <a:off x="268455" y="18745096"/>
-            <a:ext cx="13206869" cy="2400657"/>
+            <a:off x="309592" y="22241401"/>
+            <a:ext cx="13206869" cy="4401205"/>
           </a:xfrm>
           <a:prstGeom prst="rect">
             <a:avLst/>
@@ -5184,17 +4997,75 @@
           <a:lstStyle/>
           <a:p>
             <a:r>
-              <a:rPr lang="en-US" sz="5000" b="1" dirty="0">
+              <a:rPr lang="en-US" sz="7000" dirty="0">
                 <a:solidFill>
                   <a:schemeClr val="bg1">
                     <a:lumMod val="95000"/>
                   </a:schemeClr>
                 </a:solidFill>
+                <a:latin typeface="Arial" panose="020B0604020202020204" pitchFamily="34" charset="0"/>
+                <a:cs typeface="Arial" panose="020B0604020202020204" pitchFamily="34" charset="0"/>
+              </a:rPr>
+              <a:t>While</a:t>
+            </a:r>
+            <a:r>
+              <a:rPr lang="en-US" sz="7000" b="1" dirty="0">
+                <a:solidFill>
+                  <a:schemeClr val="bg1">
+                    <a:lumMod val="95000"/>
+                  </a:schemeClr>
+                </a:solidFill>
                 <a:latin typeface="Arial Rounded MT Bold" panose="020F0704030504030204" pitchFamily="34" charset="77"/>
               </a:rPr>
-              <a:t>While measles is declining globally and across Europe, the United States is seeing a renewed increase.</a:t>
-            </a:r>
-            <a:endParaRPr lang="en-US" sz="5000" dirty="0">
+              <a:t> measles is declining globally </a:t>
+            </a:r>
+            <a:r>
+              <a:rPr lang="en-US" sz="7000" dirty="0">
+                <a:solidFill>
+                  <a:schemeClr val="bg1">
+                    <a:lumMod val="95000"/>
+                  </a:schemeClr>
+                </a:solidFill>
+                <a:latin typeface="Arial" panose="020B0604020202020204" pitchFamily="34" charset="0"/>
+                <a:cs typeface="Arial" panose="020B0604020202020204" pitchFamily="34" charset="0"/>
+              </a:rPr>
+              <a:t>and across </a:t>
+            </a:r>
+            <a:r>
+              <a:rPr lang="en-US" sz="7000" b="1" dirty="0">
+                <a:solidFill>
+                  <a:schemeClr val="bg1">
+                    <a:lumMod val="95000"/>
+                  </a:schemeClr>
+                </a:solidFill>
+                <a:latin typeface="Arial Rounded MT Bold" panose="020F0704030504030204" pitchFamily="34" charset="77"/>
+              </a:rPr>
+              <a:t>Europe, the United States </a:t>
+            </a:r>
+            <a:r>
+              <a:rPr lang="en-US" sz="7000" dirty="0">
+                <a:solidFill>
+                  <a:schemeClr val="bg1">
+                    <a:lumMod val="95000"/>
+                  </a:schemeClr>
+                </a:solidFill>
+                <a:latin typeface="Arial" panose="020B0604020202020204" pitchFamily="34" charset="0"/>
+                <a:cs typeface="Arial" panose="020B0604020202020204" pitchFamily="34" charset="0"/>
+              </a:rPr>
+              <a:t>is seeing a renewed</a:t>
+            </a:r>
+            <a:r>
+              <a:rPr lang="en-US" sz="7000" b="1" dirty="0">
+                <a:solidFill>
+                  <a:schemeClr val="bg1">
+                    <a:lumMod val="95000"/>
+                  </a:schemeClr>
+                </a:solidFill>
+                <a:latin typeface="Arial Rounded MT Bold" panose="020F0704030504030204" pitchFamily="34" charset="77"/>
+              </a:rPr>
+              <a:t> increase.</a:t>
+            </a:r>
+            <a:endParaRPr lang="en-US" sz="7000" dirty="0">
               <a:solidFill>
                 <a:schemeClr val="bg1">
                   <a:lumMod val="95000"/>
@@ -5205,6 +5076,455 @@
           </a:p>
         </p:txBody>
       </p:sp>
+      <p:pic>
+        <p:nvPicPr>
+          <p:cNvPr id="32" name="Picture 31">
+            <a:extLst>
+              <a:ext uri="{FF2B5EF4-FFF2-40B4-BE49-F238E27FC236}">
+                <a16:creationId xmlns:a16="http://schemas.microsoft.com/office/drawing/2014/main" id="{4E793203-A096-D0D8-7C05-E4565779146A}"/>
+              </a:ext>
+            </a:extLst>
+          </p:cNvPr>
+          <p:cNvPicPr>
+            <a:picLocks noChangeAspect="1"/>
+          </p:cNvPicPr>
+          <p:nvPr/>
+        </p:nvPicPr>
+        <p:blipFill>
+          <a:blip r:embed="rId10">
+            <a:extLst>
+              <a:ext uri="{BEBA8EAE-BF5A-486C-A8C5-ECC9F3942E4B}">
+                <a14:imgProps xmlns:a14="http://schemas.microsoft.com/office/drawing/2010/main">
+                  <a14:imgLayer r:embed="rId11">
+                    <a14:imgEffect>
+                      <a14:backgroundRemoval t="10000" b="90000" l="10000" r="90000">
+                        <a14:backgroundMark x1="54095" y1="34067" x2="54095" y2="34067"/>
+                        <a14:backgroundMark x1="55190" y1="34733" x2="55190" y2="34733"/>
+                        <a14:backgroundMark x1="55429" y1="39533" x2="55429" y2="39533"/>
+                        <a14:backgroundMark x1="56095" y1="39200" x2="56095" y2="39200"/>
+                        <a14:backgroundMark x1="59000" y1="38000" x2="59000" y2="38000"/>
+                        <a14:backgroundMark x1="60286" y1="39067" x2="60286" y2="39067"/>
+                        <a14:backgroundMark x1="56524" y1="40000" x2="56524" y2="40000"/>
+                        <a14:backgroundMark x1="55524" y1="43133" x2="55524" y2="43133"/>
+                        <a14:backgroundMark x1="63381" y1="45133" x2="63381" y2="45133"/>
+                        <a14:backgroundMark x1="67714" y1="40933" x2="67714" y2="40933"/>
+                        <a14:backgroundMark x1="23952" y1="46800" x2="23952" y2="46800"/>
+                        <a14:backgroundMark x1="51429" y1="35067" x2="51429" y2="35067"/>
+                      </a14:backgroundRemoval>
+                    </a14:imgEffect>
+                  </a14:imgLayer>
+                </a14:imgProps>
+              </a:ext>
+            </a:extLst>
+          </a:blip>
+          <a:srcRect/>
+          <a:stretch/>
+        </p:blipFill>
+        <p:spPr>
+          <a:xfrm>
+            <a:off x="14357799" y="16989959"/>
+            <a:ext cx="20661999" cy="14758571"/>
+          </a:xfrm>
+          <a:prstGeom prst="rect">
+            <a:avLst/>
+          </a:prstGeom>
+        </p:spPr>
+      </p:pic>
+      <p:pic>
+        <p:nvPicPr>
+          <p:cNvPr id="35" name="Picture 34">
+            <a:extLst>
+              <a:ext uri="{FF2B5EF4-FFF2-40B4-BE49-F238E27FC236}">
+                <a16:creationId xmlns:a16="http://schemas.microsoft.com/office/drawing/2014/main" id="{C3FFEC99-A647-DDB8-8C6E-9DFA81747DF4}"/>
+              </a:ext>
+            </a:extLst>
+          </p:cNvPr>
+          <p:cNvPicPr>
+            <a:picLocks noChangeAspect="1"/>
+          </p:cNvPicPr>
+          <p:nvPr/>
+        </p:nvPicPr>
+        <p:blipFill>
+          <a:blip r:embed="rId12"/>
+          <a:srcRect b="9014"/>
+          <a:stretch>
+            <a:fillRect/>
+          </a:stretch>
+        </p:blipFill>
+        <p:spPr>
+          <a:xfrm>
+            <a:off x="34278362" y="1235169"/>
+            <a:ext cx="16386222" cy="6931745"/>
+          </a:xfrm>
+          <a:prstGeom prst="rect">
+            <a:avLst/>
+          </a:prstGeom>
+        </p:spPr>
+      </p:pic>
+      <p:sp>
+        <p:nvSpPr>
+          <p:cNvPr id="36" name="TextBox 35">
+            <a:extLst>
+              <a:ext uri="{FF2B5EF4-FFF2-40B4-BE49-F238E27FC236}">
+                <a16:creationId xmlns:a16="http://schemas.microsoft.com/office/drawing/2014/main" id="{DD05D4BB-C6FA-C0D0-13A5-FAB3E3C91CD2}"/>
+              </a:ext>
+            </a:extLst>
+          </p:cNvPr>
+          <p:cNvSpPr txBox="1"/>
+          <p:nvPr/>
+        </p:nvSpPr>
+        <p:spPr>
+          <a:xfrm>
+            <a:off x="35757129" y="10370913"/>
+            <a:ext cx="13206869" cy="4401205"/>
+          </a:xfrm>
+          <a:prstGeom prst="rect">
+            <a:avLst/>
+          </a:prstGeom>
+          <a:noFill/>
+        </p:spPr>
+        <p:txBody>
+          <a:bodyPr wrap="square" rtlCol="0">
+            <a:spAutoFit/>
+          </a:bodyPr>
+          <a:lstStyle/>
+          <a:p>
+            <a:pPr algn="ctr"/>
+            <a:r>
+              <a:rPr lang="en-US" sz="7000" dirty="0">
+                <a:solidFill>
+                  <a:schemeClr val="bg1">
+                    <a:lumMod val="95000"/>
+                  </a:schemeClr>
+                </a:solidFill>
+                <a:latin typeface="Arial" panose="020B0604020202020204" pitchFamily="34" charset="0"/>
+                <a:cs typeface="Arial" panose="020B0604020202020204" pitchFamily="34" charset="0"/>
+              </a:rPr>
+              <a:t>Even</a:t>
+            </a:r>
+            <a:r>
+              <a:rPr lang="en-US" sz="7000" b="1" dirty="0">
+                <a:solidFill>
+                  <a:schemeClr val="bg1">
+                    <a:lumMod val="95000"/>
+                  </a:schemeClr>
+                </a:solidFill>
+                <a:latin typeface="Arial Rounded MT Bold" panose="020F0704030504030204" pitchFamily="34" charset="77"/>
+              </a:rPr>
+              <a:t> slight drops </a:t>
+            </a:r>
+            <a:r>
+              <a:rPr lang="en-US" sz="7000" dirty="0">
+                <a:solidFill>
+                  <a:schemeClr val="bg1">
+                    <a:lumMod val="95000"/>
+                  </a:schemeClr>
+                </a:solidFill>
+                <a:latin typeface="Arial" panose="020B0604020202020204" pitchFamily="34" charset="0"/>
+                <a:cs typeface="Arial" panose="020B0604020202020204" pitchFamily="34" charset="0"/>
+              </a:rPr>
+              <a:t>in</a:t>
+            </a:r>
+            <a:r>
+              <a:rPr lang="en-US" sz="7000" b="1" dirty="0">
+                <a:solidFill>
+                  <a:schemeClr val="bg1">
+                    <a:lumMod val="95000"/>
+                  </a:schemeClr>
+                </a:solidFill>
+                <a:latin typeface="Arial Rounded MT Bold" panose="020F0704030504030204" pitchFamily="34" charset="77"/>
+              </a:rPr>
+              <a:t> vaccination coverage </a:t>
+            </a:r>
+            <a:r>
+              <a:rPr lang="en-US" sz="7000" dirty="0">
+                <a:solidFill>
+                  <a:schemeClr val="bg1">
+                    <a:lumMod val="95000"/>
+                  </a:schemeClr>
+                </a:solidFill>
+                <a:latin typeface="Arial" panose="020B0604020202020204" pitchFamily="34" charset="0"/>
+                <a:cs typeface="Arial" panose="020B0604020202020204" pitchFamily="34" charset="0"/>
+              </a:rPr>
+              <a:t>produce a rapidly </a:t>
+            </a:r>
+            <a:r>
+              <a:rPr lang="en-US" sz="7000" b="1" dirty="0">
+                <a:solidFill>
+                  <a:schemeClr val="bg1">
+                    <a:lumMod val="95000"/>
+                  </a:schemeClr>
+                </a:solidFill>
+                <a:latin typeface="Arial Rounded MT Bold" panose="020F0704030504030204" pitchFamily="34" charset="77"/>
+              </a:rPr>
+              <a:t>accumulating </a:t>
+            </a:r>
+            <a:r>
+              <a:rPr lang="en-US" sz="7000" dirty="0">
+                <a:solidFill>
+                  <a:schemeClr val="bg1">
+                    <a:lumMod val="95000"/>
+                  </a:schemeClr>
+                </a:solidFill>
+                <a:latin typeface="Arial" panose="020B0604020202020204" pitchFamily="34" charset="0"/>
+                <a:cs typeface="Arial" panose="020B0604020202020204" pitchFamily="34" charset="0"/>
+              </a:rPr>
+              <a:t>pool of </a:t>
+            </a:r>
+            <a:r>
+              <a:rPr lang="en-US" sz="7000" b="1" dirty="0">
+                <a:solidFill>
+                  <a:schemeClr val="bg1">
+                    <a:lumMod val="95000"/>
+                  </a:schemeClr>
+                </a:solidFill>
+                <a:latin typeface="Arial Rounded MT Bold" panose="020F0704030504030204" pitchFamily="34" charset="77"/>
+              </a:rPr>
+              <a:t>unvaccinated children.</a:t>
+            </a:r>
+            <a:endParaRPr lang="en-US" sz="7000" dirty="0">
+              <a:solidFill>
+                <a:schemeClr val="bg1">
+                  <a:lumMod val="95000"/>
+                </a:schemeClr>
+              </a:solidFill>
+              <a:latin typeface="Arial Rounded MT Bold" panose="020F0704030504030204" pitchFamily="34" charset="77"/>
+            </a:endParaRPr>
+          </a:p>
+        </p:txBody>
+      </p:sp>
+      <p:pic>
+        <p:nvPicPr>
+          <p:cNvPr id="38" name="Picture 37">
+            <a:extLst>
+              <a:ext uri="{FF2B5EF4-FFF2-40B4-BE49-F238E27FC236}">
+                <a16:creationId xmlns:a16="http://schemas.microsoft.com/office/drawing/2014/main" id="{99CD8F23-61F5-3A76-241D-907C747C7C52}"/>
+              </a:ext>
+            </a:extLst>
+          </p:cNvPr>
+          <p:cNvPicPr>
+            <a:picLocks noChangeAspect="1"/>
+          </p:cNvPicPr>
+          <p:nvPr/>
+        </p:nvPicPr>
+        <p:blipFill>
+          <a:blip r:embed="rId13"/>
+          <a:stretch>
+            <a:fillRect/>
+          </a:stretch>
+        </p:blipFill>
+        <p:spPr>
+          <a:xfrm>
+            <a:off x="35757128" y="17285976"/>
+            <a:ext cx="13206869" cy="6113665"/>
+          </a:xfrm>
+          <a:prstGeom prst="rect">
+            <a:avLst/>
+          </a:prstGeom>
+        </p:spPr>
+      </p:pic>
+      <p:sp>
+        <p:nvSpPr>
+          <p:cNvPr id="39" name="TextBox 38">
+            <a:extLst>
+              <a:ext uri="{FF2B5EF4-FFF2-40B4-BE49-F238E27FC236}">
+                <a16:creationId xmlns:a16="http://schemas.microsoft.com/office/drawing/2014/main" id="{3CCBC8FE-528A-21E2-90BE-17527A2CC1A7}"/>
+              </a:ext>
+            </a:extLst>
+          </p:cNvPr>
+          <p:cNvSpPr txBox="1"/>
+          <p:nvPr/>
+        </p:nvSpPr>
+        <p:spPr>
+          <a:xfrm>
+            <a:off x="35948914" y="25192889"/>
+            <a:ext cx="13206869" cy="6555641"/>
+          </a:xfrm>
+          <a:prstGeom prst="rect">
+            <a:avLst/>
+          </a:prstGeom>
+          <a:noFill/>
+        </p:spPr>
+        <p:txBody>
+          <a:bodyPr wrap="square" rtlCol="0">
+            <a:spAutoFit/>
+          </a:bodyPr>
+          <a:lstStyle/>
+          <a:p>
+            <a:pPr algn="ctr"/>
+            <a:r>
+              <a:rPr lang="en-US" sz="7000" dirty="0">
+                <a:solidFill>
+                  <a:schemeClr val="bg1">
+                    <a:lumMod val="95000"/>
+                  </a:schemeClr>
+                </a:solidFill>
+                <a:latin typeface="Arial" panose="020B0604020202020204" pitchFamily="34" charset="0"/>
+                <a:cs typeface="Arial" panose="020B0604020202020204" pitchFamily="34" charset="0"/>
+              </a:rPr>
+              <a:t>Where</a:t>
+            </a:r>
+            <a:r>
+              <a:rPr lang="en-US" sz="7000" b="1" dirty="0">
+                <a:solidFill>
+                  <a:schemeClr val="bg1">
+                    <a:lumMod val="95000"/>
+                  </a:schemeClr>
+                </a:solidFill>
+                <a:latin typeface="Arial Rounded MT Bold" panose="020F0704030504030204" pitchFamily="34" charset="77"/>
+              </a:rPr>
+              <a:t> vaccination </a:t>
+            </a:r>
+            <a:r>
+              <a:rPr lang="en-US" sz="7000" dirty="0">
+                <a:solidFill>
+                  <a:schemeClr val="bg1">
+                    <a:lumMod val="95000"/>
+                  </a:schemeClr>
+                </a:solidFill>
+                <a:latin typeface="Arial" panose="020B0604020202020204" pitchFamily="34" charset="0"/>
+                <a:cs typeface="Arial" panose="020B0604020202020204" pitchFamily="34" charset="0"/>
+              </a:rPr>
+              <a:t>requirements are </a:t>
+            </a:r>
+            <a:r>
+              <a:rPr lang="en-US" sz="7000" b="1" dirty="0">
+                <a:solidFill>
+                  <a:schemeClr val="bg1">
+                    <a:lumMod val="95000"/>
+                  </a:schemeClr>
+                </a:solidFill>
+                <a:latin typeface="Arial Rounded MT Bold" panose="020F0704030504030204" pitchFamily="34" charset="77"/>
+              </a:rPr>
+              <a:t>weaker, measles cases are higher, </a:t>
+            </a:r>
+            <a:r>
+              <a:rPr lang="en-US" sz="7000" dirty="0">
+                <a:solidFill>
+                  <a:schemeClr val="bg1">
+                    <a:lumMod val="95000"/>
+                  </a:schemeClr>
+                </a:solidFill>
+                <a:latin typeface="Arial" panose="020B0604020202020204" pitchFamily="34" charset="0"/>
+                <a:cs typeface="Arial" panose="020B0604020202020204" pitchFamily="34" charset="0"/>
+              </a:rPr>
+              <a:t>making a clear case for </a:t>
+            </a:r>
+            <a:r>
+              <a:rPr lang="en-US" sz="7000" b="1" dirty="0">
+                <a:solidFill>
+                  <a:schemeClr val="bg1">
+                    <a:lumMod val="95000"/>
+                  </a:schemeClr>
+                </a:solidFill>
+                <a:latin typeface="Arial Rounded MT Bold" panose="020F0704030504030204" pitchFamily="34" charset="77"/>
+              </a:rPr>
+              <a:t>standardized national vaccine policies.</a:t>
+            </a:r>
+            <a:endParaRPr lang="en-US" sz="7000" dirty="0">
+              <a:solidFill>
+                <a:schemeClr val="bg1">
+                  <a:lumMod val="95000"/>
+                </a:schemeClr>
+              </a:solidFill>
+              <a:latin typeface="Arial Rounded MT Bold" panose="020F0704030504030204" pitchFamily="34" charset="77"/>
+            </a:endParaRPr>
+          </a:p>
+        </p:txBody>
+      </p:sp>
+      <p:pic>
+        <p:nvPicPr>
+          <p:cNvPr id="40" name="Picture 39">
+            <a:extLst>
+              <a:ext uri="{FF2B5EF4-FFF2-40B4-BE49-F238E27FC236}">
+                <a16:creationId xmlns:a16="http://schemas.microsoft.com/office/drawing/2014/main" id="{4DEDC0F0-E854-92FE-9C6D-72D33B2B3BC5}"/>
+              </a:ext>
+            </a:extLst>
+          </p:cNvPr>
+          <p:cNvPicPr>
+            <a:picLocks noChangeAspect="1"/>
+          </p:cNvPicPr>
+          <p:nvPr/>
+        </p:nvPicPr>
+        <p:blipFill>
+          <a:blip r:embed="rId14"/>
+          <a:srcRect l="86607"/>
+          <a:stretch>
+            <a:fillRect/>
+          </a:stretch>
+        </p:blipFill>
+        <p:spPr>
+          <a:xfrm>
+            <a:off x="32252533" y="16982644"/>
+            <a:ext cx="2767264" cy="14758571"/>
+          </a:xfrm>
+          <a:prstGeom prst="rect">
+            <a:avLst/>
+          </a:prstGeom>
+        </p:spPr>
+      </p:pic>
+      <p:pic>
+        <p:nvPicPr>
+          <p:cNvPr id="41" name="Picture 40">
+            <a:extLst>
+              <a:ext uri="{FF2B5EF4-FFF2-40B4-BE49-F238E27FC236}">
+                <a16:creationId xmlns:a16="http://schemas.microsoft.com/office/drawing/2014/main" id="{BEADBCB3-CD8D-7AA3-C297-09967A80A0CB}"/>
+              </a:ext>
+            </a:extLst>
+          </p:cNvPr>
+          <p:cNvPicPr>
+            <a:picLocks noChangeAspect="1"/>
+          </p:cNvPicPr>
+          <p:nvPr/>
+        </p:nvPicPr>
+        <p:blipFill>
+          <a:blip r:embed="rId14"/>
+          <a:srcRect l="1724" r="54205" b="86862"/>
+          <a:stretch>
+            <a:fillRect/>
+          </a:stretch>
+        </p:blipFill>
+        <p:spPr>
+          <a:xfrm>
+            <a:off x="14713368" y="16975329"/>
+            <a:ext cx="9105730" cy="1938993"/>
+          </a:xfrm>
+          <a:prstGeom prst="rect">
+            <a:avLst/>
+          </a:prstGeom>
+        </p:spPr>
+      </p:pic>
+      <p:pic>
+        <p:nvPicPr>
+          <p:cNvPr id="42" name="Picture 41">
+            <a:extLst>
+              <a:ext uri="{FF2B5EF4-FFF2-40B4-BE49-F238E27FC236}">
+                <a16:creationId xmlns:a16="http://schemas.microsoft.com/office/drawing/2014/main" id="{4E9EB63B-EFA3-563C-DE61-6BF5EE38F9FB}"/>
+              </a:ext>
+            </a:extLst>
+          </p:cNvPr>
+          <p:cNvPicPr>
+            <a:picLocks noChangeAspect="1"/>
+          </p:cNvPicPr>
+          <p:nvPr/>
+        </p:nvPicPr>
+        <p:blipFill>
+          <a:blip r:embed="rId12"/>
+          <a:srcRect t="91311"/>
+          <a:stretch>
+            <a:fillRect/>
+          </a:stretch>
+        </p:blipFill>
+        <p:spPr>
+          <a:xfrm>
+            <a:off x="35558717" y="8540625"/>
+            <a:ext cx="13590438" cy="549043"/>
+          </a:xfrm>
+          <a:prstGeom prst="rect">
+            <a:avLst/>
+          </a:prstGeom>
+        </p:spPr>
+      </p:pic>
     </p:spTree>
     <p:extLst>
       <p:ext uri="{BB962C8B-B14F-4D97-AF65-F5344CB8AC3E}">
@@ -5397,7 +5717,7 @@
         </p:nvSpPr>
         <p:spPr>
           <a:xfrm>
-            <a:off x="-1" y="1508760"/>
+            <a:off x="-852" y="872"/>
             <a:ext cx="11571511" cy="32918400"/>
           </a:xfrm>
           <a:prstGeom prst="rect">
@@ -8221,6 +8541,3538 @@
     <p:extLst>
       <p:ext uri="{BB962C8B-B14F-4D97-AF65-F5344CB8AC3E}">
         <p14:creationId xmlns:p14="http://schemas.microsoft.com/office/powerpoint/2010/main" val="366415117"/>
+      </p:ext>
+    </p:extLst>
+  </p:cSld>
+  <p:clrMapOvr>
+    <a:masterClrMapping/>
+  </p:clrMapOvr>
+</p:sld>
+</file>
+
+<file path=ppt/slides/slide3.xml><?xml version="1.0" encoding="utf-8"?>
+<p:sld xmlns:a="http://schemas.openxmlformats.org/drawingml/2006/main" xmlns:r="http://schemas.openxmlformats.org/officeDocument/2006/relationships" xmlns:p="http://schemas.openxmlformats.org/presentationml/2006/main">
+  <p:cSld>
+    <p:bg>
+      <p:bgPr>
+        <a:solidFill>
+          <a:schemeClr val="tx1">
+            <a:lumMod val="85000"/>
+            <a:lumOff val="15000"/>
+          </a:schemeClr>
+        </a:solidFill>
+        <a:effectLst/>
+      </p:bgPr>
+    </p:bg>
+    <p:spTree>
+      <p:nvGrpSpPr>
+        <p:cNvPr id="1" name=""/>
+        <p:cNvGrpSpPr/>
+        <p:nvPr/>
+      </p:nvGrpSpPr>
+      <p:grpSpPr>
+        <a:xfrm>
+          <a:off x="0" y="0"/>
+          <a:ext cx="0" cy="0"/>
+          <a:chOff x="0" y="0"/>
+          <a:chExt cx="0" cy="0"/>
+        </a:xfrm>
+      </p:grpSpPr>
+      <p:sp>
+        <p:nvSpPr>
+          <p:cNvPr id="16" name="Rectangle 15">
+            <a:extLst>
+              <a:ext uri="{FF2B5EF4-FFF2-40B4-BE49-F238E27FC236}">
+                <a16:creationId xmlns:a16="http://schemas.microsoft.com/office/drawing/2014/main" id="{678733BE-059C-47B7-9415-5ADF2F3024F1}"/>
+              </a:ext>
+            </a:extLst>
+          </p:cNvPr>
+          <p:cNvSpPr/>
+          <p:nvPr/>
+        </p:nvSpPr>
+        <p:spPr>
+          <a:xfrm>
+            <a:off x="39474939" y="0"/>
+            <a:ext cx="9985073" cy="32918400"/>
+          </a:xfrm>
+          <a:prstGeom prst="rect">
+            <a:avLst/>
+          </a:prstGeom>
+          <a:solidFill>
+            <a:schemeClr val="bg1"/>
+          </a:solidFill>
+          <a:ln>
+            <a:noFill/>
+          </a:ln>
+        </p:spPr>
+        <p:style>
+          <a:lnRef idx="2">
+            <a:schemeClr val="accent1">
+              <a:shade val="50000"/>
+            </a:schemeClr>
+          </a:lnRef>
+          <a:fillRef idx="1">
+            <a:schemeClr val="accent1"/>
+          </a:fillRef>
+          <a:effectRef idx="0">
+            <a:schemeClr val="accent1"/>
+          </a:effectRef>
+          <a:fontRef idx="minor">
+            <a:schemeClr val="lt1"/>
+          </a:fontRef>
+        </p:style>
+        <p:txBody>
+          <a:bodyPr rtlCol="0" anchor="ctr"/>
+          <a:lstStyle/>
+          <a:p>
+            <a:pPr marL="0" marR="0" lvl="0" indent="0" algn="l" defTabSz="457200" rtl="0" eaLnBrk="1" fontAlgn="auto" latinLnBrk="0" hangingPunct="1">
+              <a:lnSpc>
+                <a:spcPct val="100000"/>
+              </a:lnSpc>
+              <a:spcBef>
+                <a:spcPts val="0"/>
+              </a:spcBef>
+              <a:spcAft>
+                <a:spcPts val="0"/>
+              </a:spcAft>
+              <a:buClrTx/>
+              <a:buSzTx/>
+              <a:buFontTx/>
+              <a:buNone/>
+              <a:tabLst/>
+              <a:defRPr/>
+            </a:pPr>
+            <a:r>
+              <a:rPr kumimoji="0" lang="en-US" sz="1800" b="1" i="1" u="none" strike="noStrike" kern="1200" cap="none" spc="0" normalizeH="0" baseline="0" noProof="0" dirty="0">
+                <a:ln>
+                  <a:noFill/>
+                </a:ln>
+                <a:solidFill>
+                  <a:prstClr val="white"/>
+                </a:solidFill>
+                <a:effectLst/>
+                <a:uLnTx/>
+                <a:uFillTx/>
+                <a:latin typeface="Lato" panose="020F0502020204030203" pitchFamily="34" charset="0"/>
+                <a:ea typeface="+mn-ea"/>
+                <a:cs typeface="Lato" panose="020F0502020204030203" pitchFamily="34" charset="0"/>
+              </a:rPr>
+              <a:t>Non-Cognitive Predictors of Student Success:</a:t>
+            </a:r>
+            <a:br>
+              <a:rPr kumimoji="0" lang="en-US" sz="1800" b="0" i="1" u="none" strike="noStrike" kern="1200" cap="none" spc="0" normalizeH="0" baseline="0" noProof="0" dirty="0">
+                <a:ln>
+                  <a:noFill/>
+                </a:ln>
+                <a:solidFill>
+                  <a:prstClr val="white"/>
+                </a:solidFill>
+                <a:effectLst/>
+                <a:uLnTx/>
+                <a:uFillTx/>
+                <a:latin typeface="Lato" panose="020F0502020204030203" pitchFamily="34" charset="0"/>
+                <a:ea typeface="+mn-ea"/>
+                <a:cs typeface="Lato" panose="020F0502020204030203" pitchFamily="34" charset="0"/>
+              </a:rPr>
+            </a:br>
+            <a:r>
+              <a:rPr kumimoji="0" lang="en-US" sz="1800" b="0" i="1" u="none" strike="noStrike" kern="1200" cap="none" spc="0" normalizeH="0" baseline="0" noProof="0" dirty="0">
+                <a:ln>
+                  <a:noFill/>
+                </a:ln>
+                <a:solidFill>
+                  <a:prstClr val="white"/>
+                </a:solidFill>
+                <a:effectLst/>
+                <a:uLnTx/>
+                <a:uFillTx/>
+                <a:latin typeface="Lato" panose="020F0502020204030203" pitchFamily="34" charset="0"/>
+                <a:ea typeface="+mn-ea"/>
+                <a:cs typeface="Lato" panose="020F0502020204030203" pitchFamily="34" charset="0"/>
+              </a:rPr>
+              <a:t>A Predictive Validity Comparison Between Domestic and International Students</a:t>
+            </a:r>
+          </a:p>
+        </p:txBody>
+      </p:sp>
+      <p:sp>
+        <p:nvSpPr>
+          <p:cNvPr id="12" name="silent presenter">
+            <a:extLst>
+              <a:ext uri="{FF2B5EF4-FFF2-40B4-BE49-F238E27FC236}">
+                <a16:creationId xmlns:a16="http://schemas.microsoft.com/office/drawing/2014/main" id="{EC86DA8B-8163-4552-8FA4-435C18CFF2A9}"/>
+              </a:ext>
+            </a:extLst>
+          </p:cNvPr>
+          <p:cNvSpPr/>
+          <p:nvPr/>
+        </p:nvSpPr>
+        <p:spPr>
+          <a:xfrm>
+            <a:off x="-1" y="0"/>
+            <a:ext cx="11571511" cy="32918400"/>
+          </a:xfrm>
+          <a:prstGeom prst="rect">
+            <a:avLst/>
+          </a:prstGeom>
+          <a:solidFill>
+            <a:schemeClr val="bg1"/>
+          </a:solidFill>
+          <a:ln>
+            <a:noFill/>
+          </a:ln>
+        </p:spPr>
+        <p:style>
+          <a:lnRef idx="2">
+            <a:schemeClr val="accent1">
+              <a:shade val="50000"/>
+            </a:schemeClr>
+          </a:lnRef>
+          <a:fillRef idx="1">
+            <a:schemeClr val="accent1"/>
+          </a:fillRef>
+          <a:effectRef idx="0">
+            <a:schemeClr val="accent1"/>
+          </a:effectRef>
+          <a:fontRef idx="minor">
+            <a:schemeClr val="lt1"/>
+          </a:fontRef>
+        </p:style>
+        <p:txBody>
+          <a:bodyPr rtlCol="0" anchor="ctr"/>
+          <a:lstStyle/>
+          <a:p>
+            <a:pPr marL="0" marR="0" lvl="0" indent="0" algn="ctr" defTabSz="457200" rtl="0" eaLnBrk="1" fontAlgn="auto" latinLnBrk="0" hangingPunct="1">
+              <a:lnSpc>
+                <a:spcPct val="100000"/>
+              </a:lnSpc>
+              <a:spcBef>
+                <a:spcPts val="0"/>
+              </a:spcBef>
+              <a:spcAft>
+                <a:spcPts val="0"/>
+              </a:spcAft>
+              <a:buClrTx/>
+              <a:buSzTx/>
+              <a:buFontTx/>
+              <a:buNone/>
+              <a:tabLst/>
+              <a:defRPr/>
+            </a:pPr>
+            <a:endParaRPr kumimoji="0" lang="en-US" sz="1800" b="0" i="0" u="none" strike="noStrike" kern="1200" cap="none" spc="0" normalizeH="0" baseline="0" noProof="0">
+              <a:ln>
+                <a:noFill/>
+              </a:ln>
+              <a:solidFill>
+                <a:prstClr val="white"/>
+              </a:solidFill>
+              <a:effectLst/>
+              <a:uLnTx/>
+              <a:uFillTx/>
+              <a:latin typeface="Calibri" panose="020F0502020204030204"/>
+              <a:ea typeface="+mn-ea"/>
+              <a:cs typeface="+mn-cs"/>
+            </a:endParaRPr>
+          </a:p>
+        </p:txBody>
+      </p:sp>
+      <p:sp>
+        <p:nvSpPr>
+          <p:cNvPr id="5" name="Title 4">
+            <a:extLst>
+              <a:ext uri="{FF2B5EF4-FFF2-40B4-BE49-F238E27FC236}">
+                <a16:creationId xmlns:a16="http://schemas.microsoft.com/office/drawing/2014/main" id="{DDC4359A-7BBB-495A-96DE-65574C0C88E6}"/>
+              </a:ext>
+            </a:extLst>
+          </p:cNvPr>
+          <p:cNvSpPr>
+            <a:spLocks noGrp="1"/>
+          </p:cNvSpPr>
+          <p:nvPr>
+            <p:ph type="ctrTitle"/>
+          </p:nvPr>
+        </p:nvSpPr>
+        <p:spPr>
+          <a:xfrm>
+            <a:off x="12991018" y="2094383"/>
+            <a:ext cx="25976634" cy="10767172"/>
+          </a:xfrm>
+        </p:spPr>
+        <p:txBody>
+          <a:bodyPr anchor="t">
+            <a:noAutofit/>
+          </a:bodyPr>
+          <a:lstStyle/>
+          <a:p>
+            <a:pPr algn="l">
+              <a:lnSpc>
+                <a:spcPct val="150000"/>
+              </a:lnSpc>
+            </a:pPr>
+            <a:r>
+              <a:rPr lang="en-US" sz="12500" dirty="0">
+                <a:solidFill>
+                  <a:schemeClr val="bg1"/>
+                </a:solidFill>
+                <a:latin typeface="Lato Black" panose="020F0A02020204030203" pitchFamily="34" charset="0"/>
+                <a:ea typeface="Segoe UI Black" panose="020B0A02040204020203" pitchFamily="34" charset="0"/>
+                <a:cs typeface="Segoe UI" panose="020B0502040204020203" pitchFamily="34" charset="0"/>
+              </a:rPr>
+              <a:t>Main finding</a:t>
+            </a:r>
+            <a:r>
+              <a:rPr lang="en-US" sz="12500" dirty="0">
+                <a:solidFill>
+                  <a:schemeClr val="bg1"/>
+                </a:solidFill>
+                <a:latin typeface="Lato" panose="020F0502020204030203" pitchFamily="34" charset="0"/>
+                <a:ea typeface="Segoe UI Black" panose="020B0A02040204020203" pitchFamily="34" charset="0"/>
+                <a:cs typeface="Segoe UI" panose="020B0502040204020203" pitchFamily="34" charset="0"/>
+              </a:rPr>
+              <a:t> goes here</a:t>
+            </a:r>
+            <a:r>
+              <a:rPr lang="en-US" sz="12500" dirty="0">
+                <a:solidFill>
+                  <a:schemeClr val="bg1"/>
+                </a:solidFill>
+                <a:latin typeface="Lato" panose="020F0502020204030203" pitchFamily="34" charset="0"/>
+                <a:ea typeface="Roboto" panose="02000000000000000000" pitchFamily="2" charset="0"/>
+                <a:cs typeface="Segoe UI" panose="020B0502040204020203" pitchFamily="34" charset="0"/>
+              </a:rPr>
+              <a:t>, translated into </a:t>
+            </a:r>
+            <a:r>
+              <a:rPr lang="en-US" sz="12500" dirty="0">
+                <a:solidFill>
+                  <a:schemeClr val="bg1"/>
+                </a:solidFill>
+                <a:latin typeface="Lato Black" panose="020F0A02020204030203" pitchFamily="34" charset="0"/>
+                <a:ea typeface="Segoe UI Black" panose="020B0A02040204020203" pitchFamily="34" charset="0"/>
+                <a:cs typeface="Segoe UI" panose="020B0502040204020203" pitchFamily="34" charset="0"/>
+              </a:rPr>
+              <a:t>plain English</a:t>
+            </a:r>
+            <a:r>
+              <a:rPr lang="en-US" sz="12500" dirty="0">
+                <a:solidFill>
+                  <a:schemeClr val="bg1"/>
+                </a:solidFill>
+                <a:latin typeface="Lato" panose="020F0502020204030203" pitchFamily="34" charset="0"/>
+                <a:ea typeface="Roboto" panose="02000000000000000000" pitchFamily="2" charset="0"/>
+                <a:cs typeface="Segoe UI" panose="020B0502040204020203" pitchFamily="34" charset="0"/>
+              </a:rPr>
+              <a:t>. </a:t>
+            </a:r>
+            <a:r>
+              <a:rPr lang="en-US" sz="12500" dirty="0">
+                <a:solidFill>
+                  <a:schemeClr val="bg1"/>
+                </a:solidFill>
+                <a:latin typeface="Lato Black" panose="020F0A02020204030203" pitchFamily="34" charset="0"/>
+                <a:ea typeface="Segoe UI Black" panose="020B0A02040204020203" pitchFamily="34" charset="0"/>
+                <a:cs typeface="Segoe UI" panose="020B0502040204020203" pitchFamily="34" charset="0"/>
+              </a:rPr>
+              <a:t>Emphasize</a:t>
+            </a:r>
+            <a:r>
+              <a:rPr lang="en-US" sz="12500" dirty="0">
+                <a:solidFill>
+                  <a:schemeClr val="bg1"/>
+                </a:solidFill>
+                <a:latin typeface="Lato" panose="020F0502020204030203" pitchFamily="34" charset="0"/>
+                <a:ea typeface="Roboto" panose="02000000000000000000" pitchFamily="2" charset="0"/>
+                <a:cs typeface="Segoe UI" panose="020B0502040204020203" pitchFamily="34" charset="0"/>
+              </a:rPr>
+              <a:t> the important words.</a:t>
+            </a:r>
+          </a:p>
+        </p:txBody>
+      </p:sp>
+      <p:sp>
+        <p:nvSpPr>
+          <p:cNvPr id="3" name="TextBox 2">
+            <a:extLst>
+              <a:ext uri="{FF2B5EF4-FFF2-40B4-BE49-F238E27FC236}">
+                <a16:creationId xmlns:a16="http://schemas.microsoft.com/office/drawing/2014/main" id="{8E35B311-3C19-412C-ADE6-EB2E4158F366}"/>
+              </a:ext>
+            </a:extLst>
+          </p:cNvPr>
+          <p:cNvSpPr txBox="1"/>
+          <p:nvPr/>
+        </p:nvSpPr>
+        <p:spPr>
+          <a:xfrm>
+            <a:off x="1010509" y="5926681"/>
+            <a:ext cx="9563989" cy="19974571"/>
+          </a:xfrm>
+          <a:prstGeom prst="rect">
+            <a:avLst/>
+          </a:prstGeom>
+          <a:noFill/>
+        </p:spPr>
+        <p:txBody>
+          <a:bodyPr wrap="square" rtlCol="0">
+            <a:spAutoFit/>
+          </a:bodyPr>
+          <a:lstStyle/>
+          <a:p>
+            <a:pPr marL="0" marR="0" lvl="0" indent="0" algn="l" defTabSz="457200" rtl="0" eaLnBrk="1" fontAlgn="auto" latinLnBrk="0" hangingPunct="1">
+              <a:lnSpc>
+                <a:spcPct val="120000"/>
+              </a:lnSpc>
+              <a:spcBef>
+                <a:spcPts val="0"/>
+              </a:spcBef>
+              <a:spcAft>
+                <a:spcPts val="0"/>
+              </a:spcAft>
+              <a:buClrTx/>
+              <a:buSzTx/>
+              <a:buFontTx/>
+              <a:buNone/>
+              <a:tabLst/>
+              <a:defRPr/>
+            </a:pPr>
+            <a:r>
+              <a:rPr kumimoji="0" lang="en-US" sz="3600" b="1" i="0" u="none" strike="noStrike" kern="1200" cap="none" spc="0" normalizeH="0" baseline="0" noProof="0" dirty="0">
+                <a:ln>
+                  <a:noFill/>
+                </a:ln>
+                <a:solidFill>
+                  <a:prstClr val="black"/>
+                </a:solidFill>
+                <a:effectLst/>
+                <a:uLnTx/>
+                <a:uFillTx/>
+                <a:latin typeface="Lato" panose="020F0502020204030203" pitchFamily="34" charset="0"/>
+                <a:ea typeface="+mn-ea"/>
+                <a:cs typeface="Segoe UI" panose="020B0502040204020203" pitchFamily="34" charset="0"/>
+              </a:rPr>
+              <a:t>BACKGROUND: Who cares?</a:t>
+            </a:r>
+            <a:r>
+              <a:rPr kumimoji="0" lang="en-US" sz="3600" b="0" i="0" u="none" strike="noStrike" kern="1200" cap="none" spc="0" normalizeH="0" baseline="0" noProof="0" dirty="0">
+                <a:ln>
+                  <a:noFill/>
+                </a:ln>
+                <a:solidFill>
+                  <a:prstClr val="black"/>
+                </a:solidFill>
+                <a:effectLst/>
+                <a:uLnTx/>
+                <a:uFillTx/>
+                <a:latin typeface="Lato" panose="020F0502020204030203" pitchFamily="34" charset="0"/>
+                <a:ea typeface="+mn-ea"/>
+                <a:cs typeface="Segoe UI" panose="020B0502040204020203" pitchFamily="34" charset="0"/>
+              </a:rPr>
+              <a:t> Explain why your study matters in the fastest, most brutal way possible (feel free to add graphics!).</a:t>
+            </a:r>
+            <a:endParaRPr kumimoji="0" lang="en-US" sz="3600" b="1" i="0" u="none" strike="noStrike" kern="1200" cap="none" spc="0" normalizeH="0" baseline="0" noProof="0" dirty="0">
+              <a:ln>
+                <a:noFill/>
+              </a:ln>
+              <a:solidFill>
+                <a:prstClr val="black"/>
+              </a:solidFill>
+              <a:effectLst/>
+              <a:uLnTx/>
+              <a:uFillTx/>
+              <a:latin typeface="Lato" panose="020F0502020204030203" pitchFamily="34" charset="0"/>
+              <a:ea typeface="+mn-ea"/>
+              <a:cs typeface="Segoe UI" panose="020B0502040204020203" pitchFamily="34" charset="0"/>
+            </a:endParaRPr>
+          </a:p>
+          <a:p>
+            <a:pPr marL="0" marR="0" lvl="0" indent="0" algn="l" defTabSz="457200" rtl="0" eaLnBrk="1" fontAlgn="auto" latinLnBrk="0" hangingPunct="1">
+              <a:lnSpc>
+                <a:spcPct val="120000"/>
+              </a:lnSpc>
+              <a:spcBef>
+                <a:spcPts val="0"/>
+              </a:spcBef>
+              <a:spcAft>
+                <a:spcPts val="0"/>
+              </a:spcAft>
+              <a:buClrTx/>
+              <a:buSzTx/>
+              <a:buFontTx/>
+              <a:buNone/>
+              <a:tabLst/>
+              <a:defRPr/>
+            </a:pPr>
+            <a:endParaRPr kumimoji="0" lang="en-US" sz="3600" b="1" i="0" u="none" strike="noStrike" kern="1200" cap="none" spc="0" normalizeH="0" baseline="0" noProof="0" dirty="0">
+              <a:ln>
+                <a:noFill/>
+              </a:ln>
+              <a:solidFill>
+                <a:srgbClr val="8C1616"/>
+              </a:solidFill>
+              <a:effectLst/>
+              <a:uLnTx/>
+              <a:uFillTx/>
+              <a:latin typeface="Lato" panose="020F0502020204030203" pitchFamily="34" charset="0"/>
+              <a:ea typeface="+mn-ea"/>
+              <a:cs typeface="Segoe UI" panose="020B0502040204020203" pitchFamily="34" charset="0"/>
+            </a:endParaRPr>
+          </a:p>
+          <a:p>
+            <a:pPr marL="0" marR="0" lvl="0" indent="0" algn="l" defTabSz="457200" rtl="0" eaLnBrk="1" fontAlgn="auto" latinLnBrk="0" hangingPunct="1">
+              <a:lnSpc>
+                <a:spcPct val="120000"/>
+              </a:lnSpc>
+              <a:spcBef>
+                <a:spcPts val="0"/>
+              </a:spcBef>
+              <a:spcAft>
+                <a:spcPts val="0"/>
+              </a:spcAft>
+              <a:buClrTx/>
+              <a:buSzTx/>
+              <a:buFontTx/>
+              <a:buNone/>
+              <a:tabLst/>
+              <a:defRPr/>
+            </a:pPr>
+            <a:endParaRPr kumimoji="0" lang="en-US" sz="3600" b="1" i="0" u="none" strike="noStrike" kern="1200" cap="none" spc="0" normalizeH="0" baseline="0" noProof="0" dirty="0">
+              <a:ln>
+                <a:noFill/>
+              </a:ln>
+              <a:solidFill>
+                <a:srgbClr val="8C1616"/>
+              </a:solidFill>
+              <a:effectLst/>
+              <a:uLnTx/>
+              <a:uFillTx/>
+              <a:latin typeface="Lato" panose="020F0502020204030203" pitchFamily="34" charset="0"/>
+              <a:ea typeface="+mn-ea"/>
+              <a:cs typeface="Segoe UI" panose="020B0502040204020203" pitchFamily="34" charset="0"/>
+            </a:endParaRPr>
+          </a:p>
+          <a:p>
+            <a:pPr marL="0" marR="0" lvl="0" indent="0" algn="l" defTabSz="457200" rtl="0" eaLnBrk="1" fontAlgn="auto" latinLnBrk="0" hangingPunct="1">
+              <a:lnSpc>
+                <a:spcPct val="120000"/>
+              </a:lnSpc>
+              <a:spcBef>
+                <a:spcPts val="0"/>
+              </a:spcBef>
+              <a:spcAft>
+                <a:spcPts val="0"/>
+              </a:spcAft>
+              <a:buClrTx/>
+              <a:buSzTx/>
+              <a:buFontTx/>
+              <a:buNone/>
+              <a:tabLst/>
+              <a:defRPr/>
+            </a:pPr>
+            <a:r>
+              <a:rPr kumimoji="0" lang="en-US" sz="3600" b="1" i="0" u="none" strike="noStrike" kern="1200" cap="none" spc="0" normalizeH="0" baseline="0" noProof="0" dirty="0">
+                <a:ln>
+                  <a:noFill/>
+                </a:ln>
+                <a:solidFill>
+                  <a:srgbClr val="8C1616"/>
+                </a:solidFill>
+                <a:effectLst/>
+                <a:uLnTx/>
+                <a:uFillTx/>
+                <a:latin typeface="Lato" panose="020F0502020204030203" pitchFamily="34" charset="0"/>
+                <a:ea typeface="+mn-ea"/>
+                <a:cs typeface="Segoe UI" panose="020B0502040204020203" pitchFamily="34" charset="0"/>
+              </a:rPr>
+              <a:t>METHODS</a:t>
+            </a:r>
+          </a:p>
+          <a:p>
+            <a:pPr marL="742950" marR="0" lvl="0" indent="-742950" algn="l" defTabSz="457200" rtl="0" eaLnBrk="1" fontAlgn="auto" latinLnBrk="0" hangingPunct="1">
+              <a:lnSpc>
+                <a:spcPct val="120000"/>
+              </a:lnSpc>
+              <a:spcBef>
+                <a:spcPts val="0"/>
+              </a:spcBef>
+              <a:spcAft>
+                <a:spcPts val="0"/>
+              </a:spcAft>
+              <a:buClrTx/>
+              <a:buSzTx/>
+              <a:buFont typeface="+mj-lt"/>
+              <a:buAutoNum type="arabicPeriod"/>
+              <a:tabLst/>
+              <a:defRPr/>
+            </a:pPr>
+            <a:r>
+              <a:rPr kumimoji="0" lang="en-US" sz="3600" b="0" i="0" u="none" strike="noStrike" kern="1200" cap="none" spc="0" normalizeH="0" baseline="0" noProof="0" dirty="0">
+                <a:ln>
+                  <a:noFill/>
+                </a:ln>
+                <a:solidFill>
+                  <a:prstClr val="black"/>
+                </a:solidFill>
+                <a:effectLst/>
+                <a:uLnTx/>
+                <a:uFillTx/>
+                <a:latin typeface="Lato" panose="020F0502020204030203" pitchFamily="34" charset="0"/>
+                <a:ea typeface="+mn-ea"/>
+                <a:cs typeface="Segoe UI" panose="020B0502040204020203" pitchFamily="34" charset="0"/>
+              </a:rPr>
+              <a:t>Collected [what] from [population]</a:t>
+            </a:r>
+          </a:p>
+          <a:p>
+            <a:pPr marL="742950" marR="0" lvl="0" indent="-742950" algn="l" defTabSz="457200" rtl="0" eaLnBrk="1" fontAlgn="auto" latinLnBrk="0" hangingPunct="1">
+              <a:lnSpc>
+                <a:spcPct val="120000"/>
+              </a:lnSpc>
+              <a:spcBef>
+                <a:spcPts val="0"/>
+              </a:spcBef>
+              <a:spcAft>
+                <a:spcPts val="0"/>
+              </a:spcAft>
+              <a:buClrTx/>
+              <a:buSzTx/>
+              <a:buFont typeface="+mj-lt"/>
+              <a:buAutoNum type="arabicPeriod"/>
+              <a:tabLst/>
+              <a:defRPr/>
+            </a:pPr>
+            <a:r>
+              <a:rPr kumimoji="0" lang="en-US" sz="3600" b="0" i="0" u="none" strike="noStrike" kern="1200" cap="none" spc="0" normalizeH="0" baseline="0" noProof="0" dirty="0">
+                <a:ln>
+                  <a:noFill/>
+                </a:ln>
+                <a:solidFill>
+                  <a:prstClr val="black"/>
+                </a:solidFill>
+                <a:effectLst/>
+                <a:uLnTx/>
+                <a:uFillTx/>
+                <a:latin typeface="Lato" panose="020F0502020204030203" pitchFamily="34" charset="0"/>
+                <a:ea typeface="+mn-ea"/>
+                <a:cs typeface="Segoe UI" panose="020B0502040204020203" pitchFamily="34" charset="0"/>
+              </a:rPr>
+              <a:t>Tested it with X process.</a:t>
+            </a:r>
+          </a:p>
+          <a:p>
+            <a:pPr marL="742950" marR="0" lvl="0" indent="-742950" algn="l" defTabSz="457200" rtl="0" eaLnBrk="1" fontAlgn="auto" latinLnBrk="0" hangingPunct="1">
+              <a:lnSpc>
+                <a:spcPct val="120000"/>
+              </a:lnSpc>
+              <a:spcBef>
+                <a:spcPts val="0"/>
+              </a:spcBef>
+              <a:spcAft>
+                <a:spcPts val="0"/>
+              </a:spcAft>
+              <a:buClrTx/>
+              <a:buSzTx/>
+              <a:buFont typeface="+mj-lt"/>
+              <a:buAutoNum type="arabicPeriod"/>
+              <a:tabLst/>
+              <a:defRPr/>
+            </a:pPr>
+            <a:r>
+              <a:rPr kumimoji="0" lang="en-US" sz="3600" b="0" i="0" u="none" strike="noStrike" kern="1200" cap="none" spc="0" normalizeH="0" baseline="0" noProof="0" dirty="0">
+                <a:ln>
+                  <a:noFill/>
+                </a:ln>
+                <a:solidFill>
+                  <a:prstClr val="black"/>
+                </a:solidFill>
+                <a:effectLst/>
+                <a:uLnTx/>
+                <a:uFillTx/>
+                <a:latin typeface="Lato" panose="020F0502020204030203" pitchFamily="34" charset="0"/>
+                <a:ea typeface="+mn-ea"/>
+                <a:cs typeface="Segoe UI" panose="020B0502040204020203" pitchFamily="34" charset="0"/>
+              </a:rPr>
+              <a:t>Illustrate your methods if you can.</a:t>
+            </a:r>
+          </a:p>
+          <a:p>
+            <a:pPr marL="742950" marR="0" lvl="0" indent="-742950" algn="l" defTabSz="457200" rtl="0" eaLnBrk="1" fontAlgn="auto" latinLnBrk="0" hangingPunct="1">
+              <a:lnSpc>
+                <a:spcPct val="120000"/>
+              </a:lnSpc>
+              <a:spcBef>
+                <a:spcPts val="0"/>
+              </a:spcBef>
+              <a:spcAft>
+                <a:spcPts val="0"/>
+              </a:spcAft>
+              <a:buClrTx/>
+              <a:buSzTx/>
+              <a:buFont typeface="+mj-lt"/>
+              <a:buAutoNum type="arabicPeriod"/>
+              <a:tabLst/>
+              <a:defRPr/>
+            </a:pPr>
+            <a:r>
+              <a:rPr kumimoji="0" lang="en-US" sz="3600" b="1" i="0" u="none" strike="noStrike" kern="1200" cap="none" spc="0" normalizeH="0" baseline="0" noProof="0" dirty="0">
+                <a:ln>
+                  <a:noFill/>
+                </a:ln>
+                <a:solidFill>
+                  <a:prstClr val="black"/>
+                </a:solidFill>
+                <a:effectLst/>
+                <a:uLnTx/>
+                <a:uFillTx/>
+                <a:latin typeface="Lato" panose="020F0502020204030203" pitchFamily="34" charset="0"/>
+                <a:ea typeface="+mn-ea"/>
+                <a:cs typeface="Segoe UI" panose="020B0502040204020203" pitchFamily="34" charset="0"/>
+              </a:rPr>
+              <a:t>Try a flowchart!</a:t>
+            </a:r>
+          </a:p>
+          <a:p>
+            <a:pPr marL="0" marR="0" lvl="0" indent="0" algn="l" defTabSz="457200" rtl="0" eaLnBrk="1" fontAlgn="auto" latinLnBrk="0" hangingPunct="1">
+              <a:lnSpc>
+                <a:spcPct val="120000"/>
+              </a:lnSpc>
+              <a:spcBef>
+                <a:spcPts val="0"/>
+              </a:spcBef>
+              <a:spcAft>
+                <a:spcPts val="0"/>
+              </a:spcAft>
+              <a:buClrTx/>
+              <a:buSzTx/>
+              <a:buFontTx/>
+              <a:buNone/>
+              <a:tabLst/>
+              <a:defRPr/>
+            </a:pPr>
+            <a:endParaRPr kumimoji="0" lang="en-US" sz="3600" b="1" i="0" u="none" strike="noStrike" kern="1200" cap="none" spc="0" normalizeH="0" baseline="0" noProof="0" dirty="0">
+              <a:ln>
+                <a:noFill/>
+              </a:ln>
+              <a:solidFill>
+                <a:prstClr val="black"/>
+              </a:solidFill>
+              <a:effectLst/>
+              <a:uLnTx/>
+              <a:uFillTx/>
+              <a:latin typeface="Lato" panose="020F0502020204030203" pitchFamily="34" charset="0"/>
+              <a:ea typeface="+mn-ea"/>
+              <a:cs typeface="Segoe UI" panose="020B0502040204020203" pitchFamily="34" charset="0"/>
+            </a:endParaRPr>
+          </a:p>
+          <a:p>
+            <a:pPr marL="0" marR="0" lvl="0" indent="0" algn="l" defTabSz="457200" rtl="0" eaLnBrk="1" fontAlgn="auto" latinLnBrk="0" hangingPunct="1">
+              <a:lnSpc>
+                <a:spcPct val="120000"/>
+              </a:lnSpc>
+              <a:spcBef>
+                <a:spcPts val="0"/>
+              </a:spcBef>
+              <a:spcAft>
+                <a:spcPts val="0"/>
+              </a:spcAft>
+              <a:buClrTx/>
+              <a:buSzTx/>
+              <a:buFontTx/>
+              <a:buNone/>
+              <a:tabLst/>
+              <a:defRPr/>
+            </a:pPr>
+            <a:endParaRPr kumimoji="0" lang="en-US" sz="3600" b="1" i="0" u="none" strike="noStrike" kern="1200" cap="none" spc="0" normalizeH="0" baseline="0" noProof="0" dirty="0">
+              <a:ln>
+                <a:noFill/>
+              </a:ln>
+              <a:solidFill>
+                <a:prstClr val="black"/>
+              </a:solidFill>
+              <a:effectLst/>
+              <a:uLnTx/>
+              <a:uFillTx/>
+              <a:latin typeface="Lato" panose="020F0502020204030203" pitchFamily="34" charset="0"/>
+              <a:ea typeface="+mn-ea"/>
+              <a:cs typeface="Segoe UI" panose="020B0502040204020203" pitchFamily="34" charset="0"/>
+            </a:endParaRPr>
+          </a:p>
+          <a:p>
+            <a:pPr marL="0" marR="0" lvl="0" indent="0" algn="l" defTabSz="457200" rtl="0" eaLnBrk="1" fontAlgn="auto" latinLnBrk="0" hangingPunct="1">
+              <a:lnSpc>
+                <a:spcPct val="120000"/>
+              </a:lnSpc>
+              <a:spcBef>
+                <a:spcPts val="0"/>
+              </a:spcBef>
+              <a:spcAft>
+                <a:spcPts val="0"/>
+              </a:spcAft>
+              <a:buClrTx/>
+              <a:buSzTx/>
+              <a:buFontTx/>
+              <a:buNone/>
+              <a:tabLst/>
+              <a:defRPr/>
+            </a:pPr>
+            <a:endParaRPr kumimoji="0" lang="en-US" sz="3600" b="1" i="0" u="none" strike="noStrike" kern="1200" cap="none" spc="0" normalizeH="0" baseline="0" noProof="0" dirty="0">
+              <a:ln>
+                <a:noFill/>
+              </a:ln>
+              <a:solidFill>
+                <a:prstClr val="black"/>
+              </a:solidFill>
+              <a:effectLst/>
+              <a:uLnTx/>
+              <a:uFillTx/>
+              <a:latin typeface="Lato" panose="020F0502020204030203" pitchFamily="34" charset="0"/>
+              <a:ea typeface="+mn-ea"/>
+              <a:cs typeface="Segoe UI" panose="020B0502040204020203" pitchFamily="34" charset="0"/>
+            </a:endParaRPr>
+          </a:p>
+          <a:p>
+            <a:pPr marL="0" marR="0" lvl="0" indent="0" algn="l" defTabSz="457200" rtl="0" eaLnBrk="1" fontAlgn="auto" latinLnBrk="0" hangingPunct="1">
+              <a:lnSpc>
+                <a:spcPct val="120000"/>
+              </a:lnSpc>
+              <a:spcBef>
+                <a:spcPts val="0"/>
+              </a:spcBef>
+              <a:spcAft>
+                <a:spcPts val="0"/>
+              </a:spcAft>
+              <a:buClrTx/>
+              <a:buSzTx/>
+              <a:buFontTx/>
+              <a:buNone/>
+              <a:tabLst/>
+              <a:defRPr/>
+            </a:pPr>
+            <a:endParaRPr kumimoji="0" lang="en-US" sz="3600" b="1" i="0" u="none" strike="noStrike" kern="1200" cap="none" spc="0" normalizeH="0" baseline="0" noProof="0" dirty="0">
+              <a:ln>
+                <a:noFill/>
+              </a:ln>
+              <a:solidFill>
+                <a:prstClr val="black"/>
+              </a:solidFill>
+              <a:effectLst/>
+              <a:uLnTx/>
+              <a:uFillTx/>
+              <a:latin typeface="Lato" panose="020F0502020204030203" pitchFamily="34" charset="0"/>
+              <a:ea typeface="+mn-ea"/>
+              <a:cs typeface="Segoe UI" panose="020B0502040204020203" pitchFamily="34" charset="0"/>
+            </a:endParaRPr>
+          </a:p>
+          <a:p>
+            <a:pPr marL="0" marR="0" lvl="0" indent="0" algn="l" defTabSz="457200" rtl="0" eaLnBrk="1" fontAlgn="auto" latinLnBrk="0" hangingPunct="1">
+              <a:lnSpc>
+                <a:spcPct val="120000"/>
+              </a:lnSpc>
+              <a:spcBef>
+                <a:spcPts val="0"/>
+              </a:spcBef>
+              <a:spcAft>
+                <a:spcPts val="0"/>
+              </a:spcAft>
+              <a:buClrTx/>
+              <a:buSzTx/>
+              <a:buFontTx/>
+              <a:buNone/>
+              <a:tabLst/>
+              <a:defRPr/>
+            </a:pPr>
+            <a:endParaRPr kumimoji="0" lang="en-US" sz="3600" b="1" i="0" u="none" strike="noStrike" kern="1200" cap="none" spc="0" normalizeH="0" baseline="0" noProof="0" dirty="0">
+              <a:ln>
+                <a:noFill/>
+              </a:ln>
+              <a:solidFill>
+                <a:prstClr val="black"/>
+              </a:solidFill>
+              <a:effectLst/>
+              <a:uLnTx/>
+              <a:uFillTx/>
+              <a:latin typeface="Lato" panose="020F0502020204030203" pitchFamily="34" charset="0"/>
+              <a:ea typeface="+mn-ea"/>
+              <a:cs typeface="Segoe UI" panose="020B0502040204020203" pitchFamily="34" charset="0"/>
+            </a:endParaRPr>
+          </a:p>
+          <a:p>
+            <a:pPr marL="0" marR="0" lvl="0" indent="0" algn="l" defTabSz="457200" rtl="0" eaLnBrk="1" fontAlgn="auto" latinLnBrk="0" hangingPunct="1">
+              <a:lnSpc>
+                <a:spcPct val="120000"/>
+              </a:lnSpc>
+              <a:spcBef>
+                <a:spcPts val="0"/>
+              </a:spcBef>
+              <a:spcAft>
+                <a:spcPts val="0"/>
+              </a:spcAft>
+              <a:buClrTx/>
+              <a:buSzTx/>
+              <a:buFontTx/>
+              <a:buNone/>
+              <a:tabLst/>
+              <a:defRPr/>
+            </a:pPr>
+            <a:endParaRPr kumimoji="0" lang="en-US" sz="3600" b="1" i="0" u="none" strike="noStrike" kern="1200" cap="none" spc="0" normalizeH="0" baseline="0" noProof="0" dirty="0">
+              <a:ln>
+                <a:noFill/>
+              </a:ln>
+              <a:solidFill>
+                <a:prstClr val="black"/>
+              </a:solidFill>
+              <a:effectLst/>
+              <a:uLnTx/>
+              <a:uFillTx/>
+              <a:latin typeface="Lato" panose="020F0502020204030203" pitchFamily="34" charset="0"/>
+              <a:ea typeface="+mn-ea"/>
+              <a:cs typeface="Segoe UI" panose="020B0502040204020203" pitchFamily="34" charset="0"/>
+            </a:endParaRPr>
+          </a:p>
+          <a:p>
+            <a:pPr marL="0" marR="0" lvl="0" indent="0" algn="l" defTabSz="457200" rtl="0" eaLnBrk="1" fontAlgn="auto" latinLnBrk="0" hangingPunct="1">
+              <a:lnSpc>
+                <a:spcPct val="120000"/>
+              </a:lnSpc>
+              <a:spcBef>
+                <a:spcPts val="0"/>
+              </a:spcBef>
+              <a:spcAft>
+                <a:spcPts val="0"/>
+              </a:spcAft>
+              <a:buClrTx/>
+              <a:buSzTx/>
+              <a:buFontTx/>
+              <a:buNone/>
+              <a:tabLst/>
+              <a:defRPr/>
+            </a:pPr>
+            <a:endParaRPr kumimoji="0" lang="en-US" sz="3600" b="1" i="0" u="none" strike="noStrike" kern="1200" cap="none" spc="0" normalizeH="0" baseline="0" noProof="0" dirty="0">
+              <a:ln>
+                <a:noFill/>
+              </a:ln>
+              <a:solidFill>
+                <a:prstClr val="black"/>
+              </a:solidFill>
+              <a:effectLst/>
+              <a:uLnTx/>
+              <a:uFillTx/>
+              <a:latin typeface="Lato" panose="020F0502020204030203" pitchFamily="34" charset="0"/>
+              <a:ea typeface="+mn-ea"/>
+              <a:cs typeface="Segoe UI" panose="020B0502040204020203" pitchFamily="34" charset="0"/>
+            </a:endParaRPr>
+          </a:p>
+          <a:p>
+            <a:pPr marL="0" marR="0" lvl="0" indent="0" algn="l" defTabSz="457200" rtl="0" eaLnBrk="1" fontAlgn="auto" latinLnBrk="0" hangingPunct="1">
+              <a:lnSpc>
+                <a:spcPct val="120000"/>
+              </a:lnSpc>
+              <a:spcBef>
+                <a:spcPts val="0"/>
+              </a:spcBef>
+              <a:spcAft>
+                <a:spcPts val="0"/>
+              </a:spcAft>
+              <a:buClrTx/>
+              <a:buSzTx/>
+              <a:buFontTx/>
+              <a:buNone/>
+              <a:tabLst/>
+              <a:defRPr/>
+            </a:pPr>
+            <a:r>
+              <a:rPr kumimoji="0" lang="en-US" sz="3600" b="1" i="0" u="none" strike="noStrike" kern="1200" cap="none" spc="0" normalizeH="0" baseline="0" noProof="0" dirty="0">
+                <a:ln>
+                  <a:noFill/>
+                </a:ln>
+                <a:solidFill>
+                  <a:prstClr val="black"/>
+                </a:solidFill>
+                <a:effectLst/>
+                <a:uLnTx/>
+                <a:uFillTx/>
+                <a:latin typeface="Lato" panose="020F0502020204030203" pitchFamily="34" charset="0"/>
+                <a:ea typeface="+mn-ea"/>
+                <a:cs typeface="Segoe UI" panose="020B0502040204020203" pitchFamily="34" charset="0"/>
+              </a:rPr>
+              <a:t>RESULTS</a:t>
+            </a:r>
+          </a:p>
+          <a:p>
+            <a:pPr marL="571500" marR="0" lvl="0" indent="-571500" algn="l" defTabSz="457200" rtl="0" eaLnBrk="1" fontAlgn="auto" latinLnBrk="0" hangingPunct="1">
+              <a:lnSpc>
+                <a:spcPct val="120000"/>
+              </a:lnSpc>
+              <a:spcBef>
+                <a:spcPts val="0"/>
+              </a:spcBef>
+              <a:spcAft>
+                <a:spcPts val="0"/>
+              </a:spcAft>
+              <a:buClrTx/>
+              <a:buSzTx/>
+              <a:buFont typeface="Arial" panose="020B0604020202020204" pitchFamily="34" charset="0"/>
+              <a:buChar char="•"/>
+              <a:tabLst/>
+              <a:defRPr/>
+            </a:pPr>
+            <a:r>
+              <a:rPr kumimoji="0" lang="en-US" sz="3600" b="0" i="0" u="none" strike="noStrike" kern="1200" cap="none" spc="0" normalizeH="0" baseline="0" noProof="0" dirty="0">
+                <a:ln>
+                  <a:noFill/>
+                </a:ln>
+                <a:solidFill>
+                  <a:prstClr val="black"/>
+                </a:solidFill>
+                <a:effectLst/>
+                <a:uLnTx/>
+                <a:uFillTx/>
+                <a:latin typeface="Lato" panose="020F0502020204030203" pitchFamily="34" charset="0"/>
+                <a:ea typeface="+mn-ea"/>
+                <a:cs typeface="Segoe UI" panose="020B0502040204020203" pitchFamily="34" charset="0"/>
+              </a:rPr>
+              <a:t>Graph/table with </a:t>
+            </a:r>
+            <a:r>
+              <a:rPr kumimoji="0" lang="en-US" sz="3600" b="1" i="0" u="none" strike="noStrike" kern="1200" cap="none" spc="0" normalizeH="0" baseline="0" noProof="0" dirty="0">
+                <a:ln>
+                  <a:noFill/>
+                </a:ln>
+                <a:solidFill>
+                  <a:prstClr val="black"/>
+                </a:solidFill>
+                <a:effectLst/>
+                <a:uLnTx/>
+                <a:uFillTx/>
+                <a:latin typeface="Lato" panose="020F0502020204030203" pitchFamily="34" charset="0"/>
+                <a:ea typeface="+mn-ea"/>
+                <a:cs typeface="Segoe UI" panose="020B0502040204020203" pitchFamily="34" charset="0"/>
+              </a:rPr>
+              <a:t>essential results only</a:t>
+            </a:r>
+            <a:r>
+              <a:rPr kumimoji="0" lang="en-US" sz="3600" b="0" i="0" u="none" strike="noStrike" kern="1200" cap="none" spc="0" normalizeH="0" baseline="0" noProof="0" dirty="0">
+                <a:ln>
+                  <a:noFill/>
+                </a:ln>
+                <a:solidFill>
+                  <a:prstClr val="black"/>
+                </a:solidFill>
+                <a:effectLst/>
+                <a:uLnTx/>
+                <a:uFillTx/>
+                <a:latin typeface="Lato" panose="020F0502020204030203" pitchFamily="34" charset="0"/>
+                <a:ea typeface="+mn-ea"/>
+                <a:cs typeface="Segoe UI" panose="020B0502040204020203" pitchFamily="34" charset="0"/>
+              </a:rPr>
+              <a:t>.</a:t>
+            </a:r>
+          </a:p>
+          <a:p>
+            <a:pPr marL="571500" marR="0" lvl="0" indent="-571500" algn="l" defTabSz="457200" rtl="0" eaLnBrk="1" fontAlgn="auto" latinLnBrk="0" hangingPunct="1">
+              <a:lnSpc>
+                <a:spcPct val="120000"/>
+              </a:lnSpc>
+              <a:spcBef>
+                <a:spcPts val="0"/>
+              </a:spcBef>
+              <a:spcAft>
+                <a:spcPts val="0"/>
+              </a:spcAft>
+              <a:buClrTx/>
+              <a:buSzTx/>
+              <a:buFont typeface="Arial" panose="020B0604020202020204" pitchFamily="34" charset="0"/>
+              <a:buChar char="•"/>
+              <a:tabLst/>
+              <a:defRPr/>
+            </a:pPr>
+            <a:r>
+              <a:rPr kumimoji="0" lang="en-US" sz="3600" b="0" i="0" u="none" strike="noStrike" kern="1200" cap="none" spc="0" normalizeH="0" baseline="0" noProof="0" dirty="0">
+                <a:ln>
+                  <a:noFill/>
+                </a:ln>
+                <a:solidFill>
+                  <a:prstClr val="black"/>
+                </a:solidFill>
+                <a:effectLst/>
+                <a:uLnTx/>
+                <a:uFillTx/>
+                <a:latin typeface="Lato" panose="020F0502020204030203" pitchFamily="34" charset="0"/>
+                <a:ea typeface="+mn-ea"/>
+                <a:cs typeface="Segoe UI" panose="020B0502040204020203" pitchFamily="34" charset="0"/>
+              </a:rPr>
+              <a:t>All the other correlations in the ammo bar.</a:t>
+            </a:r>
+          </a:p>
+          <a:p>
+            <a:pPr marL="571500" marR="0" lvl="0" indent="-571500" algn="l" defTabSz="457200" rtl="0" eaLnBrk="1" fontAlgn="auto" latinLnBrk="0" hangingPunct="1">
+              <a:lnSpc>
+                <a:spcPct val="120000"/>
+              </a:lnSpc>
+              <a:spcBef>
+                <a:spcPts val="0"/>
+              </a:spcBef>
+              <a:spcAft>
+                <a:spcPts val="0"/>
+              </a:spcAft>
+              <a:buClrTx/>
+              <a:buSzTx/>
+              <a:buFont typeface="Arial" panose="020B0604020202020204" pitchFamily="34" charset="0"/>
+              <a:buChar char="•"/>
+              <a:tabLst/>
+              <a:defRPr/>
+            </a:pPr>
+            <a:endParaRPr kumimoji="0" lang="en-US" sz="3600" b="0" i="0" u="none" strike="noStrike" kern="1200" cap="none" spc="0" normalizeH="0" baseline="0" noProof="0" dirty="0">
+              <a:ln>
+                <a:noFill/>
+              </a:ln>
+              <a:solidFill>
+                <a:prstClr val="black"/>
+              </a:solidFill>
+              <a:effectLst/>
+              <a:uLnTx/>
+              <a:uFillTx/>
+              <a:latin typeface="Lato" panose="020F0502020204030203" pitchFamily="34" charset="0"/>
+              <a:ea typeface="+mn-ea"/>
+              <a:cs typeface="Segoe UI" panose="020B0502040204020203" pitchFamily="34" charset="0"/>
+            </a:endParaRPr>
+          </a:p>
+          <a:p>
+            <a:pPr marL="571500" marR="0" lvl="0" indent="-571500" algn="l" defTabSz="457200" rtl="0" eaLnBrk="1" fontAlgn="auto" latinLnBrk="0" hangingPunct="1">
+              <a:lnSpc>
+                <a:spcPct val="120000"/>
+              </a:lnSpc>
+              <a:spcBef>
+                <a:spcPts val="0"/>
+              </a:spcBef>
+              <a:spcAft>
+                <a:spcPts val="0"/>
+              </a:spcAft>
+              <a:buClrTx/>
+              <a:buSzTx/>
+              <a:buFont typeface="Arial" panose="020B0604020202020204" pitchFamily="34" charset="0"/>
+              <a:buChar char="•"/>
+              <a:tabLst/>
+              <a:defRPr/>
+            </a:pPr>
+            <a:endParaRPr kumimoji="0" lang="en-US" sz="3600" b="0" i="0" u="none" strike="noStrike" kern="1200" cap="none" spc="0" normalizeH="0" baseline="0" noProof="0" dirty="0">
+              <a:ln>
+                <a:noFill/>
+              </a:ln>
+              <a:solidFill>
+                <a:prstClr val="black"/>
+              </a:solidFill>
+              <a:effectLst/>
+              <a:uLnTx/>
+              <a:uFillTx/>
+              <a:latin typeface="Lato" panose="020F0502020204030203" pitchFamily="34" charset="0"/>
+              <a:ea typeface="+mn-ea"/>
+              <a:cs typeface="Segoe UI" panose="020B0502040204020203" pitchFamily="34" charset="0"/>
+            </a:endParaRPr>
+          </a:p>
+          <a:p>
+            <a:pPr marL="0" marR="0" lvl="0" indent="0" algn="l" defTabSz="457200" rtl="0" eaLnBrk="1" fontAlgn="auto" latinLnBrk="0" hangingPunct="1">
+              <a:lnSpc>
+                <a:spcPct val="120000"/>
+              </a:lnSpc>
+              <a:spcBef>
+                <a:spcPts val="0"/>
+              </a:spcBef>
+              <a:spcAft>
+                <a:spcPts val="0"/>
+              </a:spcAft>
+              <a:buClrTx/>
+              <a:buSzTx/>
+              <a:buFontTx/>
+              <a:buNone/>
+              <a:tabLst/>
+              <a:defRPr/>
+            </a:pPr>
+            <a:endParaRPr kumimoji="0" lang="en-US" sz="3600" b="0" i="0" u="none" strike="noStrike" kern="1200" cap="none" spc="0" normalizeH="0" baseline="0" noProof="0" dirty="0">
+              <a:ln>
+                <a:noFill/>
+              </a:ln>
+              <a:solidFill>
+                <a:prstClr val="black"/>
+              </a:solidFill>
+              <a:effectLst/>
+              <a:uLnTx/>
+              <a:uFillTx/>
+              <a:latin typeface="Lato" panose="020F0502020204030203" pitchFamily="34" charset="0"/>
+              <a:ea typeface="+mn-ea"/>
+              <a:cs typeface="Segoe UI" panose="020B0502040204020203" pitchFamily="34" charset="0"/>
+            </a:endParaRPr>
+          </a:p>
+          <a:p>
+            <a:pPr marL="0" marR="0" lvl="0" indent="0" algn="l" defTabSz="457200" rtl="0" eaLnBrk="1" fontAlgn="auto" latinLnBrk="0" hangingPunct="1">
+              <a:lnSpc>
+                <a:spcPct val="120000"/>
+              </a:lnSpc>
+              <a:spcBef>
+                <a:spcPts val="0"/>
+              </a:spcBef>
+              <a:spcAft>
+                <a:spcPts val="0"/>
+              </a:spcAft>
+              <a:buClrTx/>
+              <a:buSzTx/>
+              <a:buFontTx/>
+              <a:buNone/>
+              <a:tabLst/>
+              <a:defRPr/>
+            </a:pPr>
+            <a:endParaRPr kumimoji="0" lang="en-US" sz="3600" b="0" i="0" u="none" strike="noStrike" kern="1200" cap="none" spc="0" normalizeH="0" baseline="0" noProof="0" dirty="0">
+              <a:ln>
+                <a:noFill/>
+              </a:ln>
+              <a:solidFill>
+                <a:prstClr val="black"/>
+              </a:solidFill>
+              <a:effectLst/>
+              <a:uLnTx/>
+              <a:uFillTx/>
+              <a:latin typeface="Lato" panose="020F0502020204030203" pitchFamily="34" charset="0"/>
+              <a:ea typeface="+mn-ea"/>
+              <a:cs typeface="Segoe UI" panose="020B0502040204020203" pitchFamily="34" charset="0"/>
+            </a:endParaRPr>
+          </a:p>
+          <a:p>
+            <a:pPr marL="0" marR="0" lvl="0" indent="0" algn="l" defTabSz="457200" rtl="0" eaLnBrk="1" fontAlgn="auto" latinLnBrk="0" hangingPunct="1">
+              <a:lnSpc>
+                <a:spcPct val="120000"/>
+              </a:lnSpc>
+              <a:spcBef>
+                <a:spcPts val="0"/>
+              </a:spcBef>
+              <a:spcAft>
+                <a:spcPts val="0"/>
+              </a:spcAft>
+              <a:buClrTx/>
+              <a:buSzTx/>
+              <a:buFontTx/>
+              <a:buNone/>
+              <a:tabLst/>
+              <a:defRPr/>
+            </a:pPr>
+            <a:endParaRPr kumimoji="0" lang="en-US" sz="3600" b="0" i="0" u="none" strike="noStrike" kern="1200" cap="none" spc="0" normalizeH="0" baseline="0" noProof="0" dirty="0">
+              <a:ln>
+                <a:noFill/>
+              </a:ln>
+              <a:solidFill>
+                <a:prstClr val="black"/>
+              </a:solidFill>
+              <a:effectLst/>
+              <a:uLnTx/>
+              <a:uFillTx/>
+              <a:latin typeface="Lato" panose="020F0502020204030203" pitchFamily="34" charset="0"/>
+              <a:ea typeface="+mn-ea"/>
+              <a:cs typeface="Segoe UI" panose="020B0502040204020203" pitchFamily="34" charset="0"/>
+            </a:endParaRPr>
+          </a:p>
+          <a:p>
+            <a:pPr marL="0" marR="0" lvl="0" indent="0" algn="l" defTabSz="457200" rtl="0" eaLnBrk="1" fontAlgn="auto" latinLnBrk="0" hangingPunct="1">
+              <a:lnSpc>
+                <a:spcPct val="120000"/>
+              </a:lnSpc>
+              <a:spcBef>
+                <a:spcPts val="0"/>
+              </a:spcBef>
+              <a:spcAft>
+                <a:spcPts val="0"/>
+              </a:spcAft>
+              <a:buClrTx/>
+              <a:buSzTx/>
+              <a:buFontTx/>
+              <a:buNone/>
+              <a:tabLst/>
+              <a:defRPr/>
+            </a:pPr>
+            <a:endParaRPr kumimoji="0" lang="en-US" sz="3600" b="0" i="0" u="none" strike="noStrike" kern="1200" cap="none" spc="0" normalizeH="0" baseline="0" noProof="0" dirty="0">
+              <a:ln>
+                <a:noFill/>
+              </a:ln>
+              <a:solidFill>
+                <a:prstClr val="black"/>
+              </a:solidFill>
+              <a:effectLst/>
+              <a:uLnTx/>
+              <a:uFillTx/>
+              <a:latin typeface="Lato" panose="020F0502020204030203" pitchFamily="34" charset="0"/>
+              <a:ea typeface="+mn-ea"/>
+              <a:cs typeface="Segoe UI" panose="020B0502040204020203" pitchFamily="34" charset="0"/>
+            </a:endParaRPr>
+          </a:p>
+          <a:p>
+            <a:pPr marL="0" marR="0" lvl="0" indent="0" algn="l" defTabSz="457200" rtl="0" eaLnBrk="1" fontAlgn="auto" latinLnBrk="0" hangingPunct="1">
+              <a:lnSpc>
+                <a:spcPct val="120000"/>
+              </a:lnSpc>
+              <a:spcBef>
+                <a:spcPts val="0"/>
+              </a:spcBef>
+              <a:spcAft>
+                <a:spcPts val="0"/>
+              </a:spcAft>
+              <a:buClrTx/>
+              <a:buSzTx/>
+              <a:buFontTx/>
+              <a:buNone/>
+              <a:tabLst/>
+              <a:defRPr/>
+            </a:pPr>
+            <a:endParaRPr kumimoji="0" lang="en-US" sz="3600" b="0" i="0" u="none" strike="noStrike" kern="1200" cap="none" spc="0" normalizeH="0" baseline="0" noProof="0" dirty="0">
+              <a:ln>
+                <a:noFill/>
+              </a:ln>
+              <a:solidFill>
+                <a:prstClr val="black"/>
+              </a:solidFill>
+              <a:effectLst/>
+              <a:uLnTx/>
+              <a:uFillTx/>
+              <a:latin typeface="Lato" panose="020F0502020204030203" pitchFamily="34" charset="0"/>
+              <a:ea typeface="+mn-ea"/>
+              <a:cs typeface="Segoe UI" panose="020B0502040204020203" pitchFamily="34" charset="0"/>
+            </a:endParaRPr>
+          </a:p>
+          <a:p>
+            <a:pPr marL="0" marR="0" lvl="0" indent="0" algn="l" defTabSz="457200" rtl="0" eaLnBrk="1" fontAlgn="auto" latinLnBrk="0" hangingPunct="1">
+              <a:lnSpc>
+                <a:spcPct val="120000"/>
+              </a:lnSpc>
+              <a:spcBef>
+                <a:spcPts val="0"/>
+              </a:spcBef>
+              <a:spcAft>
+                <a:spcPts val="0"/>
+              </a:spcAft>
+              <a:buClrTx/>
+              <a:buSzTx/>
+              <a:buFontTx/>
+              <a:buNone/>
+              <a:tabLst/>
+              <a:defRPr/>
+            </a:pPr>
+            <a:endParaRPr kumimoji="0" lang="en-US" sz="3600" b="0" i="0" u="none" strike="noStrike" kern="1200" cap="none" spc="0" normalizeH="0" baseline="0" noProof="0" dirty="0">
+              <a:ln>
+                <a:noFill/>
+              </a:ln>
+              <a:solidFill>
+                <a:prstClr val="black"/>
+              </a:solidFill>
+              <a:effectLst/>
+              <a:uLnTx/>
+              <a:uFillTx/>
+              <a:latin typeface="Lato" panose="020F0502020204030203" pitchFamily="34" charset="0"/>
+              <a:ea typeface="+mn-ea"/>
+              <a:cs typeface="Segoe UI" panose="020B0502040204020203" pitchFamily="34" charset="0"/>
+            </a:endParaRPr>
+          </a:p>
+          <a:p>
+            <a:pPr marL="0" marR="0" lvl="0" indent="0" algn="l" defTabSz="457200" rtl="0" eaLnBrk="1" fontAlgn="auto" latinLnBrk="0" hangingPunct="1">
+              <a:lnSpc>
+                <a:spcPct val="120000"/>
+              </a:lnSpc>
+              <a:spcBef>
+                <a:spcPts val="0"/>
+              </a:spcBef>
+              <a:spcAft>
+                <a:spcPts val="0"/>
+              </a:spcAft>
+              <a:buClrTx/>
+              <a:buSzTx/>
+              <a:buFontTx/>
+              <a:buNone/>
+              <a:tabLst/>
+              <a:defRPr/>
+            </a:pPr>
+            <a:endParaRPr kumimoji="0" lang="en-US" sz="3600" b="0" i="0" u="none" strike="noStrike" kern="1200" cap="none" spc="0" normalizeH="0" baseline="0" noProof="0" dirty="0">
+              <a:ln>
+                <a:noFill/>
+              </a:ln>
+              <a:solidFill>
+                <a:prstClr val="black"/>
+              </a:solidFill>
+              <a:effectLst/>
+              <a:uLnTx/>
+              <a:uFillTx/>
+              <a:latin typeface="Lato" panose="020F0502020204030203" pitchFamily="34" charset="0"/>
+              <a:ea typeface="+mn-ea"/>
+              <a:cs typeface="Segoe UI" panose="020B0502040204020203" pitchFamily="34" charset="0"/>
+            </a:endParaRPr>
+          </a:p>
+          <a:p>
+            <a:pPr marL="0" marR="0" lvl="0" indent="0" algn="l" defTabSz="457200" rtl="0" eaLnBrk="1" fontAlgn="auto" latinLnBrk="0" hangingPunct="1">
+              <a:lnSpc>
+                <a:spcPct val="120000"/>
+              </a:lnSpc>
+              <a:spcBef>
+                <a:spcPts val="0"/>
+              </a:spcBef>
+              <a:spcAft>
+                <a:spcPts val="0"/>
+              </a:spcAft>
+              <a:buClrTx/>
+              <a:buSzTx/>
+              <a:buFontTx/>
+              <a:buNone/>
+              <a:tabLst/>
+              <a:defRPr/>
+            </a:pPr>
+            <a:endParaRPr kumimoji="0" lang="en-US" sz="3600" b="0" i="0" u="none" strike="noStrike" kern="1200" cap="none" spc="0" normalizeH="0" baseline="0" noProof="0" dirty="0">
+              <a:ln>
+                <a:noFill/>
+              </a:ln>
+              <a:solidFill>
+                <a:prstClr val="black"/>
+              </a:solidFill>
+              <a:effectLst/>
+              <a:uLnTx/>
+              <a:uFillTx/>
+              <a:latin typeface="Lato" panose="020F0502020204030203" pitchFamily="34" charset="0"/>
+              <a:ea typeface="+mn-ea"/>
+              <a:cs typeface="Segoe UI" panose="020B0502040204020203" pitchFamily="34" charset="0"/>
+            </a:endParaRPr>
+          </a:p>
+        </p:txBody>
+      </p:sp>
+      <p:sp>
+        <p:nvSpPr>
+          <p:cNvPr id="7" name="TextBox 6">
+            <a:extLst>
+              <a:ext uri="{FF2B5EF4-FFF2-40B4-BE49-F238E27FC236}">
+                <a16:creationId xmlns:a16="http://schemas.microsoft.com/office/drawing/2014/main" id="{FCAC4B58-8623-4DBE-951A-DDF821787031}"/>
+              </a:ext>
+            </a:extLst>
+          </p:cNvPr>
+          <p:cNvSpPr txBox="1"/>
+          <p:nvPr/>
+        </p:nvSpPr>
+        <p:spPr>
+          <a:xfrm>
+            <a:off x="40636456" y="1831671"/>
+            <a:ext cx="7662037" cy="9879628"/>
+          </a:xfrm>
+          <a:prstGeom prst="rect">
+            <a:avLst/>
+          </a:prstGeom>
+          <a:noFill/>
+        </p:spPr>
+        <p:txBody>
+          <a:bodyPr wrap="square" rtlCol="0">
+            <a:spAutoFit/>
+          </a:bodyPr>
+          <a:lstStyle/>
+          <a:p>
+            <a:pPr marL="0" marR="0" lvl="0" indent="0" algn="l" defTabSz="457200" rtl="0" eaLnBrk="1" fontAlgn="auto" latinLnBrk="0" hangingPunct="1">
+              <a:lnSpc>
+                <a:spcPct val="100000"/>
+              </a:lnSpc>
+              <a:spcBef>
+                <a:spcPts val="0"/>
+              </a:spcBef>
+              <a:spcAft>
+                <a:spcPts val="0"/>
+              </a:spcAft>
+              <a:buClrTx/>
+              <a:buSzTx/>
+              <a:buFontTx/>
+              <a:buNone/>
+              <a:tabLst/>
+              <a:defRPr/>
+            </a:pPr>
+            <a:r>
+              <a:rPr kumimoji="0" lang="en-US" sz="5400" b="1" i="0" u="none" strike="noStrike" kern="1200" cap="none" spc="0" normalizeH="0" baseline="0" noProof="0" dirty="0">
+                <a:ln>
+                  <a:noFill/>
+                </a:ln>
+                <a:solidFill>
+                  <a:prstClr val="black"/>
+                </a:solidFill>
+                <a:effectLst/>
+                <a:uLnTx/>
+                <a:uFillTx/>
+                <a:latin typeface="Lato" panose="020F0502020204030203" pitchFamily="34" charset="0"/>
+                <a:ea typeface="+mn-ea"/>
+                <a:cs typeface="Segoe UI" panose="020B0502040204020203" pitchFamily="34" charset="0"/>
+              </a:rPr>
+              <a:t>AMMO BAR</a:t>
+            </a:r>
+          </a:p>
+          <a:p>
+            <a:pPr marL="0" marR="0" lvl="0" indent="0" algn="l" defTabSz="457200" rtl="0" eaLnBrk="1" fontAlgn="auto" latinLnBrk="0" hangingPunct="1">
+              <a:lnSpc>
+                <a:spcPct val="100000"/>
+              </a:lnSpc>
+              <a:spcBef>
+                <a:spcPts val="0"/>
+              </a:spcBef>
+              <a:spcAft>
+                <a:spcPts val="0"/>
+              </a:spcAft>
+              <a:buClrTx/>
+              <a:buSzTx/>
+              <a:buFontTx/>
+              <a:buNone/>
+              <a:tabLst/>
+              <a:defRPr/>
+            </a:pPr>
+            <a:endParaRPr kumimoji="0" lang="en-US" sz="5400" b="1" i="0" u="none" strike="noStrike" kern="1200" cap="none" spc="0" normalizeH="0" baseline="0" noProof="0" dirty="0">
+              <a:ln>
+                <a:noFill/>
+              </a:ln>
+              <a:solidFill>
+                <a:prstClr val="black"/>
+              </a:solidFill>
+              <a:effectLst/>
+              <a:uLnTx/>
+              <a:uFillTx/>
+              <a:latin typeface="Lato" panose="020F0502020204030203" pitchFamily="34" charset="0"/>
+              <a:ea typeface="+mn-ea"/>
+              <a:cs typeface="Segoe UI" panose="020B0502040204020203" pitchFamily="34" charset="0"/>
+            </a:endParaRPr>
+          </a:p>
+          <a:p>
+            <a:pPr marL="0" marR="0" lvl="0" indent="0" algn="l" defTabSz="457200" rtl="0" eaLnBrk="1" fontAlgn="auto" latinLnBrk="0" hangingPunct="1">
+              <a:lnSpc>
+                <a:spcPct val="100000"/>
+              </a:lnSpc>
+              <a:spcBef>
+                <a:spcPts val="0"/>
+              </a:spcBef>
+              <a:spcAft>
+                <a:spcPts val="0"/>
+              </a:spcAft>
+              <a:buClrTx/>
+              <a:buSzTx/>
+              <a:buFontTx/>
+              <a:buNone/>
+              <a:tabLst/>
+              <a:defRPr/>
+            </a:pPr>
+            <a:r>
+              <a:rPr kumimoji="0" lang="en-US" sz="4800" b="1" i="0" u="none" strike="noStrike" kern="1200" cap="none" spc="0" normalizeH="0" baseline="0" noProof="0" dirty="0">
+                <a:ln>
+                  <a:noFill/>
+                </a:ln>
+                <a:solidFill>
+                  <a:prstClr val="black"/>
+                </a:solidFill>
+                <a:effectLst/>
+                <a:uLnTx/>
+                <a:uFillTx/>
+                <a:latin typeface="Lato" panose="020F0502020204030203" pitchFamily="34" charset="0"/>
+                <a:ea typeface="+mn-ea"/>
+                <a:cs typeface="Segoe UI" panose="020B0502040204020203" pitchFamily="34" charset="0"/>
+              </a:rPr>
+              <a:t>Delete this and replace it with your…</a:t>
+            </a:r>
+          </a:p>
+          <a:p>
+            <a:pPr marL="1143000" marR="0" lvl="0" indent="-1143000" algn="l" defTabSz="457200" rtl="0" eaLnBrk="1" fontAlgn="auto" latinLnBrk="0" hangingPunct="1">
+              <a:lnSpc>
+                <a:spcPct val="100000"/>
+              </a:lnSpc>
+              <a:spcBef>
+                <a:spcPts val="0"/>
+              </a:spcBef>
+              <a:spcAft>
+                <a:spcPts val="0"/>
+              </a:spcAft>
+              <a:buClrTx/>
+              <a:buSzTx/>
+              <a:buFont typeface="Arial" panose="020B0604020202020204" pitchFamily="34" charset="0"/>
+              <a:buChar char="•"/>
+              <a:tabLst/>
+              <a:defRPr/>
+            </a:pPr>
+            <a:r>
+              <a:rPr kumimoji="0" lang="en-US" sz="4800" b="0" i="0" u="none" strike="noStrike" kern="1200" cap="none" spc="0" normalizeH="0" baseline="0" noProof="0" dirty="0">
+                <a:ln>
+                  <a:noFill/>
+                </a:ln>
+                <a:solidFill>
+                  <a:prstClr val="black"/>
+                </a:solidFill>
+                <a:effectLst/>
+                <a:uLnTx/>
+                <a:uFillTx/>
+                <a:latin typeface="Lato" panose="020F0502020204030203" pitchFamily="34" charset="0"/>
+                <a:ea typeface="+mn-ea"/>
+                <a:cs typeface="Segoe UI" panose="020B0502040204020203" pitchFamily="34" charset="0"/>
+              </a:rPr>
+              <a:t>Extra Graphs</a:t>
+            </a:r>
+          </a:p>
+          <a:p>
+            <a:pPr marL="1143000" marR="0" lvl="0" indent="-1143000" algn="l" defTabSz="457200" rtl="0" eaLnBrk="1" fontAlgn="auto" latinLnBrk="0" hangingPunct="1">
+              <a:lnSpc>
+                <a:spcPct val="100000"/>
+              </a:lnSpc>
+              <a:spcBef>
+                <a:spcPts val="0"/>
+              </a:spcBef>
+              <a:spcAft>
+                <a:spcPts val="0"/>
+              </a:spcAft>
+              <a:buClrTx/>
+              <a:buSzTx/>
+              <a:buFont typeface="Arial" panose="020B0604020202020204" pitchFamily="34" charset="0"/>
+              <a:buChar char="•"/>
+              <a:tabLst/>
+              <a:defRPr/>
+            </a:pPr>
+            <a:r>
+              <a:rPr kumimoji="0" lang="en-US" sz="4800" b="0" i="0" u="none" strike="noStrike" kern="1200" cap="none" spc="0" normalizeH="0" baseline="0" noProof="0" dirty="0">
+                <a:ln>
+                  <a:noFill/>
+                </a:ln>
+                <a:solidFill>
+                  <a:prstClr val="black"/>
+                </a:solidFill>
+                <a:effectLst/>
+                <a:uLnTx/>
+                <a:uFillTx/>
+                <a:latin typeface="Lato" panose="020F0502020204030203" pitchFamily="34" charset="0"/>
+                <a:ea typeface="+mn-ea"/>
+                <a:cs typeface="Segoe UI" panose="020B0502040204020203" pitchFamily="34" charset="0"/>
+              </a:rPr>
+              <a:t>Extra Correlation tables</a:t>
+            </a:r>
+          </a:p>
+          <a:p>
+            <a:pPr marL="1143000" marR="0" lvl="0" indent="-1143000" algn="l" defTabSz="457200" rtl="0" eaLnBrk="1" fontAlgn="auto" latinLnBrk="0" hangingPunct="1">
+              <a:lnSpc>
+                <a:spcPct val="100000"/>
+              </a:lnSpc>
+              <a:spcBef>
+                <a:spcPts val="0"/>
+              </a:spcBef>
+              <a:spcAft>
+                <a:spcPts val="0"/>
+              </a:spcAft>
+              <a:buClrTx/>
+              <a:buSzTx/>
+              <a:buFont typeface="Arial" panose="020B0604020202020204" pitchFamily="34" charset="0"/>
+              <a:buChar char="•"/>
+              <a:tabLst/>
+              <a:defRPr/>
+            </a:pPr>
+            <a:r>
+              <a:rPr kumimoji="0" lang="en-US" sz="4800" b="0" i="0" u="none" strike="noStrike" kern="1200" cap="none" spc="0" normalizeH="0" baseline="0" noProof="0" dirty="0">
+                <a:ln>
+                  <a:noFill/>
+                </a:ln>
+                <a:solidFill>
+                  <a:prstClr val="black"/>
+                </a:solidFill>
+                <a:effectLst/>
+                <a:uLnTx/>
+                <a:uFillTx/>
+                <a:latin typeface="Lato" panose="020F0502020204030203" pitchFamily="34" charset="0"/>
+                <a:ea typeface="+mn-ea"/>
+                <a:cs typeface="Segoe UI" panose="020B0502040204020203" pitchFamily="34" charset="0"/>
+              </a:rPr>
+              <a:t>Extra Figures</a:t>
+            </a:r>
+          </a:p>
+          <a:p>
+            <a:pPr marL="1143000" marR="0" lvl="0" indent="-1143000" algn="l" defTabSz="457200" rtl="0" eaLnBrk="1" fontAlgn="auto" latinLnBrk="0" hangingPunct="1">
+              <a:lnSpc>
+                <a:spcPct val="100000"/>
+              </a:lnSpc>
+              <a:spcBef>
+                <a:spcPts val="0"/>
+              </a:spcBef>
+              <a:spcAft>
+                <a:spcPts val="0"/>
+              </a:spcAft>
+              <a:buClrTx/>
+              <a:buSzTx/>
+              <a:buFont typeface="Arial" panose="020B0604020202020204" pitchFamily="34" charset="0"/>
+              <a:buChar char="•"/>
+              <a:tabLst/>
+              <a:defRPr/>
+            </a:pPr>
+            <a:r>
+              <a:rPr kumimoji="0" lang="en-US" sz="4800" b="0" i="0" u="none" strike="noStrike" kern="1200" cap="none" spc="0" normalizeH="0" baseline="0" noProof="0" dirty="0">
+                <a:ln>
+                  <a:noFill/>
+                </a:ln>
+                <a:solidFill>
+                  <a:prstClr val="black"/>
+                </a:solidFill>
+                <a:effectLst/>
+                <a:uLnTx/>
+                <a:uFillTx/>
+                <a:latin typeface="Lato" panose="020F0502020204030203" pitchFamily="34" charset="0"/>
+                <a:ea typeface="+mn-ea"/>
+                <a:cs typeface="Segoe UI" panose="020B0502040204020203" pitchFamily="34" charset="0"/>
+              </a:rPr>
+              <a:t>Extra nuance that you’re worried about leaving out.</a:t>
+            </a:r>
+          </a:p>
+          <a:p>
+            <a:pPr marL="1143000" marR="0" lvl="0" indent="-1143000" algn="l" defTabSz="457200" rtl="0" eaLnBrk="1" fontAlgn="auto" latinLnBrk="0" hangingPunct="1">
+              <a:lnSpc>
+                <a:spcPct val="100000"/>
+              </a:lnSpc>
+              <a:spcBef>
+                <a:spcPts val="0"/>
+              </a:spcBef>
+              <a:spcAft>
+                <a:spcPts val="0"/>
+              </a:spcAft>
+              <a:buClrTx/>
+              <a:buSzTx/>
+              <a:buFont typeface="Arial" panose="020B0604020202020204" pitchFamily="34" charset="0"/>
+              <a:buChar char="•"/>
+              <a:tabLst/>
+              <a:defRPr/>
+            </a:pPr>
+            <a:r>
+              <a:rPr kumimoji="0" lang="en-US" sz="4800" b="1" i="0" u="none" strike="noStrike" kern="1200" cap="none" spc="0" normalizeH="0" baseline="0" noProof="0" dirty="0">
+                <a:ln>
+                  <a:noFill/>
+                </a:ln>
+                <a:solidFill>
+                  <a:prstClr val="black"/>
+                </a:solidFill>
+                <a:effectLst/>
+                <a:uLnTx/>
+                <a:uFillTx/>
+                <a:latin typeface="Lato" panose="020F0502020204030203" pitchFamily="34" charset="0"/>
+                <a:ea typeface="+mn-ea"/>
+                <a:cs typeface="Segoe UI" panose="020B0502040204020203" pitchFamily="34" charset="0"/>
+              </a:rPr>
+              <a:t>Keep it messy!</a:t>
+            </a:r>
+            <a:r>
+              <a:rPr kumimoji="0" lang="en-US" sz="4800" b="0" i="0" u="none" strike="noStrike" kern="1200" cap="none" spc="0" normalizeH="0" baseline="0" noProof="0" dirty="0">
+                <a:ln>
+                  <a:noFill/>
+                </a:ln>
+                <a:solidFill>
+                  <a:prstClr val="black"/>
+                </a:solidFill>
+                <a:effectLst/>
+                <a:uLnTx/>
+                <a:uFillTx/>
+                <a:latin typeface="Lato" panose="020F0502020204030203" pitchFamily="34" charset="0"/>
+                <a:ea typeface="+mn-ea"/>
+                <a:cs typeface="Segoe UI" panose="020B0502040204020203" pitchFamily="34" charset="0"/>
+              </a:rPr>
+              <a:t> This section is just for you.</a:t>
+            </a:r>
+          </a:p>
+        </p:txBody>
+      </p:sp>
+      <p:sp>
+        <p:nvSpPr>
+          <p:cNvPr id="9" name="Graphic 7">
+            <a:extLst>
+              <a:ext uri="{FF2B5EF4-FFF2-40B4-BE49-F238E27FC236}">
+                <a16:creationId xmlns:a16="http://schemas.microsoft.com/office/drawing/2014/main" id="{9914F9AF-0FB9-4924-8DCA-B46EEB713FE9}"/>
+              </a:ext>
+            </a:extLst>
+          </p:cNvPr>
+          <p:cNvSpPr/>
+          <p:nvPr/>
+        </p:nvSpPr>
+        <p:spPr>
+          <a:xfrm>
+            <a:off x="18329346" y="28402488"/>
+            <a:ext cx="1256803" cy="2173929"/>
+          </a:xfrm>
+          <a:custGeom>
+            <a:avLst/>
+            <a:gdLst>
+              <a:gd name="connsiteX0" fmla="*/ 321256 w 2089376"/>
+              <a:gd name="connsiteY0" fmla="*/ 0 h 3614056"/>
+              <a:gd name="connsiteX1" fmla="*/ 0 w 2089376"/>
+              <a:gd name="connsiteY1" fmla="*/ 321256 h 3614056"/>
+              <a:gd name="connsiteX2" fmla="*/ 0 w 2089376"/>
+              <a:gd name="connsiteY2" fmla="*/ 3292801 h 3614056"/>
+              <a:gd name="connsiteX3" fmla="*/ 321256 w 2089376"/>
+              <a:gd name="connsiteY3" fmla="*/ 3614057 h 3614056"/>
+              <a:gd name="connsiteX4" fmla="*/ 1815047 w 2089376"/>
+              <a:gd name="connsiteY4" fmla="*/ 3614057 h 3614056"/>
+              <a:gd name="connsiteX5" fmla="*/ 2136303 w 2089376"/>
+              <a:gd name="connsiteY5" fmla="*/ 3292801 h 3614056"/>
+              <a:gd name="connsiteX6" fmla="*/ 2136303 w 2089376"/>
+              <a:gd name="connsiteY6" fmla="*/ 321256 h 3614056"/>
+              <a:gd name="connsiteX7" fmla="*/ 1815047 w 2089376"/>
+              <a:gd name="connsiteY7" fmla="*/ 0 h 3614056"/>
+              <a:gd name="connsiteX8" fmla="*/ 321256 w 2089376"/>
+              <a:gd name="connsiteY8" fmla="*/ 0 h 3614056"/>
+              <a:gd name="connsiteX9" fmla="*/ 889115 w 2089376"/>
+              <a:gd name="connsiteY9" fmla="*/ 309397 h 3614056"/>
+              <a:gd name="connsiteX10" fmla="*/ 1247302 w 2089376"/>
+              <a:gd name="connsiteY10" fmla="*/ 309397 h 3614056"/>
+              <a:gd name="connsiteX11" fmla="*/ 1289936 w 2089376"/>
+              <a:gd name="connsiteY11" fmla="*/ 369650 h 3614056"/>
+              <a:gd name="connsiteX12" fmla="*/ 1247302 w 2089376"/>
+              <a:gd name="connsiteY12" fmla="*/ 429903 h 3614056"/>
+              <a:gd name="connsiteX13" fmla="*/ 889115 w 2089376"/>
+              <a:gd name="connsiteY13" fmla="*/ 429903 h 3614056"/>
+              <a:gd name="connsiteX14" fmla="*/ 846480 w 2089376"/>
+              <a:gd name="connsiteY14" fmla="*/ 369650 h 3614056"/>
+              <a:gd name="connsiteX15" fmla="*/ 889115 w 2089376"/>
+              <a:gd name="connsiteY15" fmla="*/ 309397 h 3614056"/>
+              <a:gd name="connsiteX16" fmla="*/ 176468 w 2089376"/>
+              <a:gd name="connsiteY16" fmla="*/ 738905 h 3614056"/>
+              <a:gd name="connsiteX17" fmla="*/ 1959892 w 2089376"/>
+              <a:gd name="connsiteY17" fmla="*/ 738905 h 3614056"/>
+              <a:gd name="connsiteX18" fmla="*/ 1959892 w 2089376"/>
+              <a:gd name="connsiteY18" fmla="*/ 2875208 h 3614056"/>
+              <a:gd name="connsiteX19" fmla="*/ 176468 w 2089376"/>
+              <a:gd name="connsiteY19" fmla="*/ 2875208 h 3614056"/>
+              <a:gd name="connsiteX20" fmla="*/ 176468 w 2089376"/>
+              <a:gd name="connsiteY20" fmla="*/ 738905 h 3614056"/>
+              <a:gd name="connsiteX21" fmla="*/ 1068180 w 2089376"/>
+              <a:gd name="connsiteY21" fmla="*/ 3045747 h 3614056"/>
+              <a:gd name="connsiteX22" fmla="*/ 1068180 w 2089376"/>
+              <a:gd name="connsiteY22" fmla="*/ 3045747 h 3614056"/>
+              <a:gd name="connsiteX23" fmla="*/ 1267066 w 2089376"/>
+              <a:gd name="connsiteY23" fmla="*/ 3244633 h 3614056"/>
+              <a:gd name="connsiteX24" fmla="*/ 1267066 w 2089376"/>
+              <a:gd name="connsiteY24" fmla="*/ 3244633 h 3614056"/>
+              <a:gd name="connsiteX25" fmla="*/ 1267066 w 2089376"/>
+              <a:gd name="connsiteY25" fmla="*/ 3244633 h 3614056"/>
+              <a:gd name="connsiteX26" fmla="*/ 1267066 w 2089376"/>
+              <a:gd name="connsiteY26" fmla="*/ 3244633 h 3614056"/>
+              <a:gd name="connsiteX27" fmla="*/ 1068180 w 2089376"/>
+              <a:gd name="connsiteY27" fmla="*/ 3443519 h 3614056"/>
+              <a:gd name="connsiteX28" fmla="*/ 1068180 w 2089376"/>
+              <a:gd name="connsiteY28" fmla="*/ 3443519 h 3614056"/>
+              <a:gd name="connsiteX29" fmla="*/ 1068180 w 2089376"/>
+              <a:gd name="connsiteY29" fmla="*/ 3443519 h 3614056"/>
+              <a:gd name="connsiteX30" fmla="*/ 1068180 w 2089376"/>
+              <a:gd name="connsiteY30" fmla="*/ 3443519 h 3614056"/>
+              <a:gd name="connsiteX31" fmla="*/ 869294 w 2089376"/>
+              <a:gd name="connsiteY31" fmla="*/ 3244633 h 3614056"/>
+              <a:gd name="connsiteX32" fmla="*/ 869294 w 2089376"/>
+              <a:gd name="connsiteY32" fmla="*/ 3244633 h 3614056"/>
+              <a:gd name="connsiteX33" fmla="*/ 869294 w 2089376"/>
+              <a:gd name="connsiteY33" fmla="*/ 3244633 h 3614056"/>
+              <a:gd name="connsiteX34" fmla="*/ 869294 w 2089376"/>
+              <a:gd name="connsiteY34" fmla="*/ 3244633 h 3614056"/>
+              <a:gd name="connsiteX35" fmla="*/ 1068180 w 2089376"/>
+              <a:gd name="connsiteY35" fmla="*/ 3045747 h 3614056"/>
+              <a:gd name="connsiteX36" fmla="*/ 1068180 w 2089376"/>
+              <a:gd name="connsiteY36" fmla="*/ 3045747 h 3614056"/>
+              <a:gd name="connsiteX37" fmla="*/ 1068180 w 2089376"/>
+              <a:gd name="connsiteY37" fmla="*/ 3045747 h 3614056"/>
+            </a:gdLst>
+            <a:ahLst/>
+            <a:cxnLst>
+              <a:cxn ang="0">
+                <a:pos x="connsiteX0" y="connsiteY0"/>
+              </a:cxn>
+              <a:cxn ang="0">
+                <a:pos x="connsiteX1" y="connsiteY1"/>
+              </a:cxn>
+              <a:cxn ang="0">
+                <a:pos x="connsiteX2" y="connsiteY2"/>
+              </a:cxn>
+              <a:cxn ang="0">
+                <a:pos x="connsiteX3" y="connsiteY3"/>
+              </a:cxn>
+              <a:cxn ang="0">
+                <a:pos x="connsiteX4" y="connsiteY4"/>
+              </a:cxn>
+              <a:cxn ang="0">
+                <a:pos x="connsiteX5" y="connsiteY5"/>
+              </a:cxn>
+              <a:cxn ang="0">
+                <a:pos x="connsiteX6" y="connsiteY6"/>
+              </a:cxn>
+              <a:cxn ang="0">
+                <a:pos x="connsiteX7" y="connsiteY7"/>
+              </a:cxn>
+              <a:cxn ang="0">
+                <a:pos x="connsiteX8" y="connsiteY8"/>
+              </a:cxn>
+              <a:cxn ang="0">
+                <a:pos x="connsiteX9" y="connsiteY9"/>
+              </a:cxn>
+              <a:cxn ang="0">
+                <a:pos x="connsiteX10" y="connsiteY10"/>
+              </a:cxn>
+              <a:cxn ang="0">
+                <a:pos x="connsiteX11" y="connsiteY11"/>
+              </a:cxn>
+              <a:cxn ang="0">
+                <a:pos x="connsiteX12" y="connsiteY12"/>
+              </a:cxn>
+              <a:cxn ang="0">
+                <a:pos x="connsiteX13" y="connsiteY13"/>
+              </a:cxn>
+              <a:cxn ang="0">
+                <a:pos x="connsiteX14" y="connsiteY14"/>
+              </a:cxn>
+              <a:cxn ang="0">
+                <a:pos x="connsiteX15" y="connsiteY15"/>
+              </a:cxn>
+              <a:cxn ang="0">
+                <a:pos x="connsiteX16" y="connsiteY16"/>
+              </a:cxn>
+              <a:cxn ang="0">
+                <a:pos x="connsiteX17" y="connsiteY17"/>
+              </a:cxn>
+              <a:cxn ang="0">
+                <a:pos x="connsiteX18" y="connsiteY18"/>
+              </a:cxn>
+              <a:cxn ang="0">
+                <a:pos x="connsiteX19" y="connsiteY19"/>
+              </a:cxn>
+              <a:cxn ang="0">
+                <a:pos x="connsiteX20" y="connsiteY20"/>
+              </a:cxn>
+              <a:cxn ang="0">
+                <a:pos x="connsiteX21" y="connsiteY21"/>
+              </a:cxn>
+              <a:cxn ang="0">
+                <a:pos x="connsiteX22" y="connsiteY22"/>
+              </a:cxn>
+              <a:cxn ang="0">
+                <a:pos x="connsiteX23" y="connsiteY23"/>
+              </a:cxn>
+              <a:cxn ang="0">
+                <a:pos x="connsiteX24" y="connsiteY24"/>
+              </a:cxn>
+              <a:cxn ang="0">
+                <a:pos x="connsiteX25" y="connsiteY25"/>
+              </a:cxn>
+              <a:cxn ang="0">
+                <a:pos x="connsiteX26" y="connsiteY26"/>
+              </a:cxn>
+              <a:cxn ang="0">
+                <a:pos x="connsiteX27" y="connsiteY27"/>
+              </a:cxn>
+              <a:cxn ang="0">
+                <a:pos x="connsiteX28" y="connsiteY28"/>
+              </a:cxn>
+              <a:cxn ang="0">
+                <a:pos x="connsiteX29" y="connsiteY29"/>
+              </a:cxn>
+              <a:cxn ang="0">
+                <a:pos x="connsiteX30" y="connsiteY30"/>
+              </a:cxn>
+              <a:cxn ang="0">
+                <a:pos x="connsiteX31" y="connsiteY31"/>
+              </a:cxn>
+              <a:cxn ang="0">
+                <a:pos x="connsiteX32" y="connsiteY32"/>
+              </a:cxn>
+              <a:cxn ang="0">
+                <a:pos x="connsiteX33" y="connsiteY33"/>
+              </a:cxn>
+              <a:cxn ang="0">
+                <a:pos x="connsiteX34" y="connsiteY34"/>
+              </a:cxn>
+              <a:cxn ang="0">
+                <a:pos x="connsiteX35" y="connsiteY35"/>
+              </a:cxn>
+              <a:cxn ang="0">
+                <a:pos x="connsiteX36" y="connsiteY36"/>
+              </a:cxn>
+              <a:cxn ang="0">
+                <a:pos x="connsiteX37" y="connsiteY37"/>
+              </a:cxn>
+            </a:cxnLst>
+            <a:rect l="l" t="t" r="r" b="b"/>
+            <a:pathLst>
+              <a:path w="2089376" h="3614056">
+                <a:moveTo>
+                  <a:pt x="321256" y="0"/>
+                </a:moveTo>
+                <a:cubicBezTo>
+                  <a:pt x="144562" y="0"/>
+                  <a:pt x="0" y="144562"/>
+                  <a:pt x="0" y="321256"/>
+                </a:cubicBezTo>
+                <a:lnTo>
+                  <a:pt x="0" y="3292801"/>
+                </a:lnTo>
+                <a:cubicBezTo>
+                  <a:pt x="0" y="3469495"/>
+                  <a:pt x="144562" y="3614057"/>
+                  <a:pt x="321256" y="3614057"/>
+                </a:cubicBezTo>
+                <a:lnTo>
+                  <a:pt x="1815047" y="3614057"/>
+                </a:lnTo>
+                <a:cubicBezTo>
+                  <a:pt x="1991741" y="3614057"/>
+                  <a:pt x="2136303" y="3469495"/>
+                  <a:pt x="2136303" y="3292801"/>
+                </a:cubicBezTo>
+                <a:lnTo>
+                  <a:pt x="2136303" y="321256"/>
+                </a:lnTo>
+                <a:cubicBezTo>
+                  <a:pt x="2136303" y="144562"/>
+                  <a:pt x="1991741" y="0"/>
+                  <a:pt x="1815047" y="0"/>
+                </a:cubicBezTo>
+                <a:lnTo>
+                  <a:pt x="321256" y="0"/>
+                </a:lnTo>
+                <a:close/>
+                <a:moveTo>
+                  <a:pt x="889115" y="309397"/>
+                </a:moveTo>
+                <a:lnTo>
+                  <a:pt x="1247302" y="309397"/>
+                </a:lnTo>
+                <a:cubicBezTo>
+                  <a:pt x="1270849" y="309397"/>
+                  <a:pt x="1289936" y="336390"/>
+                  <a:pt x="1289936" y="369650"/>
+                </a:cubicBezTo>
+                <a:cubicBezTo>
+                  <a:pt x="1289936" y="402911"/>
+                  <a:pt x="1270849" y="429903"/>
+                  <a:pt x="1247302" y="429903"/>
+                </a:cubicBezTo>
+                <a:lnTo>
+                  <a:pt x="889115" y="429903"/>
+                </a:lnTo>
+                <a:cubicBezTo>
+                  <a:pt x="865567" y="429903"/>
+                  <a:pt x="846480" y="402911"/>
+                  <a:pt x="846480" y="369650"/>
+                </a:cubicBezTo>
+                <a:cubicBezTo>
+                  <a:pt x="846480" y="336390"/>
+                  <a:pt x="865567" y="309397"/>
+                  <a:pt x="889115" y="309397"/>
+                </a:cubicBezTo>
+                <a:close/>
+                <a:moveTo>
+                  <a:pt x="176468" y="738905"/>
+                </a:moveTo>
+                <a:lnTo>
+                  <a:pt x="1959892" y="738905"/>
+                </a:lnTo>
+                <a:lnTo>
+                  <a:pt x="1959892" y="2875208"/>
+                </a:lnTo>
+                <a:lnTo>
+                  <a:pt x="176468" y="2875208"/>
+                </a:lnTo>
+                <a:lnTo>
+                  <a:pt x="176468" y="738905"/>
+                </a:lnTo>
+                <a:close/>
+                <a:moveTo>
+                  <a:pt x="1068180" y="3045747"/>
+                </a:moveTo>
+                <a:cubicBezTo>
+                  <a:pt x="1068180" y="3045747"/>
+                  <a:pt x="1068180" y="3045747"/>
+                  <a:pt x="1068180" y="3045747"/>
+                </a:cubicBezTo>
+                <a:cubicBezTo>
+                  <a:pt x="1178013" y="3045747"/>
+                  <a:pt x="1267066" y="3134799"/>
+                  <a:pt x="1267066" y="3244633"/>
+                </a:cubicBezTo>
+                <a:cubicBezTo>
+                  <a:pt x="1267066" y="3244633"/>
+                  <a:pt x="1267066" y="3244633"/>
+                  <a:pt x="1267066" y="3244633"/>
+                </a:cubicBezTo>
+                <a:lnTo>
+                  <a:pt x="1267066" y="3244633"/>
+                </a:lnTo>
+                <a:cubicBezTo>
+                  <a:pt x="1267066" y="3244633"/>
+                  <a:pt x="1267066" y="3244633"/>
+                  <a:pt x="1267066" y="3244633"/>
+                </a:cubicBezTo>
+                <a:cubicBezTo>
+                  <a:pt x="1267066" y="3354466"/>
+                  <a:pt x="1178013" y="3443519"/>
+                  <a:pt x="1068180" y="3443519"/>
+                </a:cubicBezTo>
+                <a:cubicBezTo>
+                  <a:pt x="1068180" y="3443519"/>
+                  <a:pt x="1068180" y="3443519"/>
+                  <a:pt x="1068180" y="3443519"/>
+                </a:cubicBezTo>
+                <a:lnTo>
+                  <a:pt x="1068180" y="3443519"/>
+                </a:lnTo>
+                <a:cubicBezTo>
+                  <a:pt x="1068180" y="3443519"/>
+                  <a:pt x="1068180" y="3443519"/>
+                  <a:pt x="1068180" y="3443519"/>
+                </a:cubicBezTo>
+                <a:cubicBezTo>
+                  <a:pt x="958346" y="3443519"/>
+                  <a:pt x="869294" y="3354466"/>
+                  <a:pt x="869294" y="3244633"/>
+                </a:cubicBezTo>
+                <a:cubicBezTo>
+                  <a:pt x="869294" y="3244633"/>
+                  <a:pt x="869294" y="3244633"/>
+                  <a:pt x="869294" y="3244633"/>
+                </a:cubicBezTo>
+                <a:lnTo>
+                  <a:pt x="869294" y="3244633"/>
+                </a:lnTo>
+                <a:cubicBezTo>
+                  <a:pt x="869294" y="3244633"/>
+                  <a:pt x="869294" y="3244633"/>
+                  <a:pt x="869294" y="3244633"/>
+                </a:cubicBezTo>
+                <a:cubicBezTo>
+                  <a:pt x="869294" y="3134799"/>
+                  <a:pt x="958346" y="3045747"/>
+                  <a:pt x="1068180" y="3045747"/>
+                </a:cubicBezTo>
+                <a:cubicBezTo>
+                  <a:pt x="1068180" y="3045747"/>
+                  <a:pt x="1068180" y="3045747"/>
+                  <a:pt x="1068180" y="3045747"/>
+                </a:cubicBezTo>
+                <a:lnTo>
+                  <a:pt x="1068180" y="3045747"/>
+                </a:lnTo>
+                <a:close/>
+              </a:path>
+            </a:pathLst>
+          </a:custGeom>
+          <a:solidFill>
+            <a:srgbClr val="CDCDCD"/>
+          </a:solidFill>
+          <a:ln w="56406" cap="flat">
+            <a:noFill/>
+            <a:prstDash val="solid"/>
+            <a:miter/>
+          </a:ln>
+        </p:spPr>
+        <p:txBody>
+          <a:bodyPr rtlCol="0" anchor="ctr"/>
+          <a:lstStyle/>
+          <a:p>
+            <a:pPr marL="0" marR="0" lvl="0" indent="0" algn="l" defTabSz="457200" rtl="0" eaLnBrk="1" fontAlgn="auto" latinLnBrk="0" hangingPunct="1">
+              <a:lnSpc>
+                <a:spcPct val="100000"/>
+              </a:lnSpc>
+              <a:spcBef>
+                <a:spcPts val="0"/>
+              </a:spcBef>
+              <a:spcAft>
+                <a:spcPts val="0"/>
+              </a:spcAft>
+              <a:buClrTx/>
+              <a:buSzTx/>
+              <a:buFontTx/>
+              <a:buNone/>
+              <a:tabLst/>
+              <a:defRPr/>
+            </a:pPr>
+            <a:endParaRPr kumimoji="0" lang="en-US" sz="1800" b="0" i="0" u="none" strike="noStrike" kern="1200" cap="none" spc="0" normalizeH="0" baseline="0" noProof="0">
+              <a:ln>
+                <a:noFill/>
+              </a:ln>
+              <a:solidFill>
+                <a:prstClr val="white">
+                  <a:lumMod val="85000"/>
+                </a:prstClr>
+              </a:solidFill>
+              <a:effectLst/>
+              <a:uLnTx/>
+              <a:uFillTx/>
+              <a:latin typeface="Calibri" panose="020F0502020204030204"/>
+              <a:ea typeface="+mn-ea"/>
+              <a:cs typeface="+mn-cs"/>
+            </a:endParaRPr>
+          </a:p>
+        </p:txBody>
+      </p:sp>
+      <p:sp>
+        <p:nvSpPr>
+          <p:cNvPr id="19" name="TextBox 18">
+            <a:extLst>
+              <a:ext uri="{FF2B5EF4-FFF2-40B4-BE49-F238E27FC236}">
+                <a16:creationId xmlns:a16="http://schemas.microsoft.com/office/drawing/2014/main" id="{315520EB-0F65-403D-A973-B17B2A4C2E9D}"/>
+              </a:ext>
+            </a:extLst>
+          </p:cNvPr>
+          <p:cNvSpPr txBox="1"/>
+          <p:nvPr/>
+        </p:nvSpPr>
+        <p:spPr>
+          <a:xfrm>
+            <a:off x="20010311" y="28501422"/>
+            <a:ext cx="8077384" cy="1569660"/>
+          </a:xfrm>
+          <a:prstGeom prst="rect">
+            <a:avLst/>
+          </a:prstGeom>
+          <a:noFill/>
+        </p:spPr>
+        <p:txBody>
+          <a:bodyPr wrap="square" rtlCol="0">
+            <a:spAutoFit/>
+          </a:bodyPr>
+          <a:lstStyle/>
+          <a:p>
+            <a:pPr marL="0" marR="0" lvl="0" indent="0" algn="l" defTabSz="457200" rtl="0" eaLnBrk="1" fontAlgn="auto" latinLnBrk="0" hangingPunct="1">
+              <a:lnSpc>
+                <a:spcPct val="100000"/>
+              </a:lnSpc>
+              <a:spcBef>
+                <a:spcPts val="0"/>
+              </a:spcBef>
+              <a:spcAft>
+                <a:spcPts val="0"/>
+              </a:spcAft>
+              <a:buClrTx/>
+              <a:buSzTx/>
+              <a:buFontTx/>
+              <a:buNone/>
+              <a:tabLst/>
+              <a:defRPr/>
+            </a:pPr>
+            <a:r>
+              <a:rPr kumimoji="0" lang="en-US" sz="4800" b="0" i="0" u="none" strike="noStrike" kern="1200" cap="none" spc="0" normalizeH="0" baseline="0" noProof="0" dirty="0">
+                <a:ln>
+                  <a:noFill/>
+                </a:ln>
+                <a:solidFill>
+                  <a:srgbClr val="CDCDCD"/>
+                </a:solidFill>
+                <a:effectLst/>
+                <a:uLnTx/>
+                <a:uFillTx/>
+                <a:latin typeface="Lato Black" panose="020F0A02020204030203" pitchFamily="34" charset="0"/>
+                <a:ea typeface="+mn-ea"/>
+                <a:cs typeface="Arial" panose="020B0604020202020204" pitchFamily="34" charset="0"/>
+              </a:rPr>
+              <a:t>Take a picture</a:t>
+            </a:r>
+            <a:r>
+              <a:rPr kumimoji="0" lang="en-US" sz="4800" b="0" i="0" u="none" strike="noStrike" kern="1200" cap="none" spc="0" normalizeH="0" baseline="0" noProof="0" dirty="0">
+                <a:ln>
+                  <a:noFill/>
+                </a:ln>
+                <a:solidFill>
+                  <a:srgbClr val="CDCDCD"/>
+                </a:solidFill>
+                <a:effectLst/>
+                <a:uLnTx/>
+                <a:uFillTx/>
+                <a:latin typeface="Lato" panose="020F0502020204030203" pitchFamily="34" charset="0"/>
+                <a:ea typeface="+mn-ea"/>
+                <a:cs typeface="Arial" panose="020B0604020202020204" pitchFamily="34" charset="0"/>
+              </a:rPr>
+              <a:t> to </a:t>
+            </a:r>
+            <a:br>
+              <a:rPr kumimoji="0" lang="en-US" sz="4800" b="0" i="0" u="none" strike="noStrike" kern="1200" cap="none" spc="0" normalizeH="0" baseline="0" noProof="0" dirty="0">
+                <a:ln>
+                  <a:noFill/>
+                </a:ln>
+                <a:solidFill>
+                  <a:srgbClr val="CDCDCD"/>
+                </a:solidFill>
+                <a:effectLst/>
+                <a:uLnTx/>
+                <a:uFillTx/>
+                <a:latin typeface="Lato" panose="020F0502020204030203" pitchFamily="34" charset="0"/>
+                <a:ea typeface="+mn-ea"/>
+                <a:cs typeface="Arial" panose="020B0604020202020204" pitchFamily="34" charset="0"/>
+              </a:rPr>
+            </a:br>
+            <a:r>
+              <a:rPr kumimoji="0" lang="en-US" sz="4800" b="0" i="0" u="none" strike="noStrike" kern="1200" cap="none" spc="0" normalizeH="0" baseline="0" noProof="0" dirty="0">
+                <a:ln>
+                  <a:noFill/>
+                </a:ln>
+                <a:solidFill>
+                  <a:srgbClr val="CDCDCD"/>
+                </a:solidFill>
+                <a:effectLst/>
+                <a:uLnTx/>
+                <a:uFillTx/>
+                <a:latin typeface="Lato Black" panose="020F0A02020204030203" pitchFamily="34" charset="0"/>
+                <a:ea typeface="+mn-ea"/>
+                <a:cs typeface="Arial" panose="020B0604020202020204" pitchFamily="34" charset="0"/>
+              </a:rPr>
+              <a:t>download</a:t>
+            </a:r>
+            <a:r>
+              <a:rPr kumimoji="0" lang="en-US" sz="4800" b="0" i="0" u="none" strike="noStrike" kern="1200" cap="none" spc="0" normalizeH="0" baseline="0" noProof="0" dirty="0">
+                <a:ln>
+                  <a:noFill/>
+                </a:ln>
+                <a:solidFill>
+                  <a:srgbClr val="CDCDCD"/>
+                </a:solidFill>
+                <a:effectLst/>
+                <a:uLnTx/>
+                <a:uFillTx/>
+                <a:latin typeface="Lato" panose="020F0502020204030203" pitchFamily="34" charset="0"/>
+                <a:ea typeface="+mn-ea"/>
+                <a:cs typeface="Arial" panose="020B0604020202020204" pitchFamily="34" charset="0"/>
+              </a:rPr>
+              <a:t> the</a:t>
+            </a:r>
+            <a:r>
+              <a:rPr kumimoji="0" lang="en-US" sz="4800" b="1" i="0" u="none" strike="noStrike" kern="1200" cap="none" spc="0" normalizeH="0" baseline="0" noProof="0" dirty="0">
+                <a:ln>
+                  <a:noFill/>
+                </a:ln>
+                <a:solidFill>
+                  <a:srgbClr val="CDCDCD"/>
+                </a:solidFill>
+                <a:effectLst/>
+                <a:uLnTx/>
+                <a:uFillTx/>
+                <a:latin typeface="Lato" panose="020F0502020204030203" pitchFamily="34" charset="0"/>
+                <a:ea typeface="+mn-ea"/>
+                <a:cs typeface="Arial" panose="020B0604020202020204" pitchFamily="34" charset="0"/>
+              </a:rPr>
+              <a:t> </a:t>
+            </a:r>
+            <a:r>
+              <a:rPr kumimoji="0" lang="en-US" sz="4800" b="0" i="0" u="none" strike="noStrike" kern="1200" cap="none" spc="0" normalizeH="0" baseline="0" noProof="0" dirty="0">
+                <a:ln>
+                  <a:noFill/>
+                </a:ln>
+                <a:solidFill>
+                  <a:srgbClr val="CDCDCD"/>
+                </a:solidFill>
+                <a:effectLst/>
+                <a:uLnTx/>
+                <a:uFillTx/>
+                <a:latin typeface="Lato Black" panose="020F0A02020204030203" pitchFamily="34" charset="0"/>
+                <a:ea typeface="+mn-ea"/>
+                <a:cs typeface="Arial" panose="020B0604020202020204" pitchFamily="34" charset="0"/>
+              </a:rPr>
+              <a:t>full paper</a:t>
+            </a:r>
+          </a:p>
+        </p:txBody>
+      </p:sp>
+      <p:sp>
+        <p:nvSpPr>
+          <p:cNvPr id="10" name="Rectangle 9">
+            <a:extLst>
+              <a:ext uri="{FF2B5EF4-FFF2-40B4-BE49-F238E27FC236}">
+                <a16:creationId xmlns:a16="http://schemas.microsoft.com/office/drawing/2014/main" id="{F33A7B10-D6D9-4BF7-9A8B-B3113FDC3D80}"/>
+              </a:ext>
+            </a:extLst>
+          </p:cNvPr>
+          <p:cNvSpPr/>
+          <p:nvPr/>
+        </p:nvSpPr>
+        <p:spPr>
+          <a:xfrm>
+            <a:off x="1169537" y="3212650"/>
+            <a:ext cx="1670876" cy="1590801"/>
+          </a:xfrm>
+          <a:prstGeom prst="rect">
+            <a:avLst/>
+          </a:prstGeom>
+          <a:solidFill>
+            <a:srgbClr val="262626"/>
+          </a:solidFill>
+          <a:ln>
+            <a:noFill/>
+          </a:ln>
+        </p:spPr>
+        <p:style>
+          <a:lnRef idx="2">
+            <a:schemeClr val="accent1">
+              <a:shade val="50000"/>
+            </a:schemeClr>
+          </a:lnRef>
+          <a:fillRef idx="1">
+            <a:schemeClr val="accent1"/>
+          </a:fillRef>
+          <a:effectRef idx="0">
+            <a:schemeClr val="accent1"/>
+          </a:effectRef>
+          <a:fontRef idx="minor">
+            <a:schemeClr val="lt1"/>
+          </a:fontRef>
+        </p:style>
+        <p:txBody>
+          <a:bodyPr rtlCol="0" anchor="ctr"/>
+          <a:lstStyle/>
+          <a:p>
+            <a:pPr marL="0" marR="0" lvl="0" indent="0" algn="ctr" defTabSz="457200" rtl="0" eaLnBrk="1" fontAlgn="auto" latinLnBrk="0" hangingPunct="1">
+              <a:lnSpc>
+                <a:spcPct val="100000"/>
+              </a:lnSpc>
+              <a:spcBef>
+                <a:spcPts val="0"/>
+              </a:spcBef>
+              <a:spcAft>
+                <a:spcPts val="0"/>
+              </a:spcAft>
+              <a:buClrTx/>
+              <a:buSzTx/>
+              <a:buFontTx/>
+              <a:buNone/>
+              <a:tabLst/>
+              <a:defRPr/>
+            </a:pPr>
+            <a:endParaRPr kumimoji="0" lang="en-US" sz="1800" b="0" i="0" u="none" strike="noStrike" kern="1200" cap="none" spc="0" normalizeH="0" baseline="0" noProof="0" dirty="0">
+              <a:ln>
+                <a:noFill/>
+              </a:ln>
+              <a:solidFill>
+                <a:prstClr val="white"/>
+              </a:solidFill>
+              <a:effectLst/>
+              <a:uLnTx/>
+              <a:uFillTx/>
+              <a:latin typeface="Calibri" panose="020F0502020204030204"/>
+              <a:ea typeface="+mn-ea"/>
+              <a:cs typeface="+mn-cs"/>
+            </a:endParaRPr>
+          </a:p>
+        </p:txBody>
+      </p:sp>
+      <p:pic>
+        <p:nvPicPr>
+          <p:cNvPr id="13" name="Picture 12">
+            <a:extLst>
+              <a:ext uri="{FF2B5EF4-FFF2-40B4-BE49-F238E27FC236}">
+                <a16:creationId xmlns:a16="http://schemas.microsoft.com/office/drawing/2014/main" id="{CDB5C0A9-48EF-4957-80A2-585367894178}"/>
+              </a:ext>
+            </a:extLst>
+          </p:cNvPr>
+          <p:cNvPicPr>
+            <a:picLocks noChangeAspect="1"/>
+          </p:cNvPicPr>
+          <p:nvPr/>
+        </p:nvPicPr>
+        <p:blipFill>
+          <a:blip r:embed="rId3"/>
+          <a:stretch>
+            <a:fillRect/>
+          </a:stretch>
+        </p:blipFill>
+        <p:spPr>
+          <a:xfrm>
+            <a:off x="42886324" y="28807176"/>
+            <a:ext cx="3162300" cy="2581275"/>
+          </a:xfrm>
+          <a:prstGeom prst="rect">
+            <a:avLst/>
+          </a:prstGeom>
+        </p:spPr>
+      </p:pic>
+      <p:cxnSp>
+        <p:nvCxnSpPr>
+          <p:cNvPr id="24" name="Straight Arrow Connector 23">
+            <a:extLst>
+              <a:ext uri="{FF2B5EF4-FFF2-40B4-BE49-F238E27FC236}">
+                <a16:creationId xmlns:a16="http://schemas.microsoft.com/office/drawing/2014/main" id="{32B70FBA-A2DF-453C-9792-CA6E8DB0D343}"/>
+              </a:ext>
+            </a:extLst>
+          </p:cNvPr>
+          <p:cNvCxnSpPr>
+            <a:cxnSpLocks/>
+          </p:cNvCxnSpPr>
+          <p:nvPr/>
+        </p:nvCxnSpPr>
+        <p:spPr>
+          <a:xfrm flipH="1">
+            <a:off x="16936172" y="29408785"/>
+            <a:ext cx="1297464" cy="0"/>
+          </a:xfrm>
+          <a:prstGeom prst="straightConnector1">
+            <a:avLst/>
+          </a:prstGeom>
+          <a:ln w="66675">
+            <a:solidFill>
+              <a:schemeClr val="bg1"/>
+            </a:solidFill>
+            <a:prstDash val="sysDot"/>
+            <a:tailEnd type="triangle"/>
+          </a:ln>
+        </p:spPr>
+        <p:style>
+          <a:lnRef idx="1">
+            <a:schemeClr val="accent1"/>
+          </a:lnRef>
+          <a:fillRef idx="0">
+            <a:schemeClr val="accent1"/>
+          </a:fillRef>
+          <a:effectRef idx="0">
+            <a:schemeClr val="accent1"/>
+          </a:effectRef>
+          <a:fontRef idx="minor">
+            <a:schemeClr val="tx1"/>
+          </a:fontRef>
+        </p:style>
+      </p:cxnSp>
+      <p:sp>
+        <p:nvSpPr>
+          <p:cNvPr id="17" name="Graphic 18">
+            <a:extLst>
+              <a:ext uri="{FF2B5EF4-FFF2-40B4-BE49-F238E27FC236}">
+                <a16:creationId xmlns:a16="http://schemas.microsoft.com/office/drawing/2014/main" id="{C1210836-80D5-470E-883D-041B85957069}"/>
+              </a:ext>
+            </a:extLst>
+          </p:cNvPr>
+          <p:cNvSpPr/>
+          <p:nvPr/>
+        </p:nvSpPr>
+        <p:spPr>
+          <a:xfrm>
+            <a:off x="1568455" y="3652878"/>
+            <a:ext cx="794104" cy="738508"/>
+          </a:xfrm>
+          <a:custGeom>
+            <a:avLst/>
+            <a:gdLst>
+              <a:gd name="connsiteX0" fmla="*/ 310594 w 327663"/>
+              <a:gd name="connsiteY0" fmla="*/ 219906 h 335196"/>
+              <a:gd name="connsiteX1" fmla="*/ 246568 w 327663"/>
+              <a:gd name="connsiteY1" fmla="*/ 176217 h 335196"/>
+              <a:gd name="connsiteX2" fmla="*/ 212295 w 327663"/>
+              <a:gd name="connsiteY2" fmla="*/ 176217 h 335196"/>
+              <a:gd name="connsiteX3" fmla="*/ 165217 w 327663"/>
+              <a:gd name="connsiteY3" fmla="*/ 189022 h 335196"/>
+              <a:gd name="connsiteX4" fmla="*/ 118138 w 327663"/>
+              <a:gd name="connsiteY4" fmla="*/ 176217 h 335196"/>
+              <a:gd name="connsiteX5" fmla="*/ 83866 w 327663"/>
+              <a:gd name="connsiteY5" fmla="*/ 176217 h 335196"/>
+              <a:gd name="connsiteX6" fmla="*/ 19839 w 327663"/>
+              <a:gd name="connsiteY6" fmla="*/ 219906 h 335196"/>
+              <a:gd name="connsiteX7" fmla="*/ 1385 w 327663"/>
+              <a:gd name="connsiteY7" fmla="*/ 299750 h 335196"/>
+              <a:gd name="connsiteX8" fmla="*/ 165970 w 327663"/>
+              <a:gd name="connsiteY8" fmla="*/ 335529 h 335196"/>
+              <a:gd name="connsiteX9" fmla="*/ 329802 w 327663"/>
+              <a:gd name="connsiteY9" fmla="*/ 299750 h 335196"/>
+              <a:gd name="connsiteX10" fmla="*/ 310594 w 327663"/>
+              <a:gd name="connsiteY10" fmla="*/ 219906 h 335196"/>
+              <a:gd name="connsiteX11" fmla="*/ 165593 w 327663"/>
+              <a:gd name="connsiteY11" fmla="*/ 154749 h 335196"/>
+              <a:gd name="connsiteX12" fmla="*/ 242425 w 327663"/>
+              <a:gd name="connsiteY12" fmla="*/ 77918 h 335196"/>
+              <a:gd name="connsiteX13" fmla="*/ 165593 w 327663"/>
+              <a:gd name="connsiteY13" fmla="*/ 1086 h 335196"/>
+              <a:gd name="connsiteX14" fmla="*/ 88762 w 327663"/>
+              <a:gd name="connsiteY14" fmla="*/ 77918 h 335196"/>
+              <a:gd name="connsiteX15" fmla="*/ 165593 w 327663"/>
+              <a:gd name="connsiteY15" fmla="*/ 154749 h 335196"/>
+            </a:gdLst>
+            <a:ahLst/>
+            <a:cxnLst>
+              <a:cxn ang="0">
+                <a:pos x="connsiteX0" y="connsiteY0"/>
+              </a:cxn>
+              <a:cxn ang="0">
+                <a:pos x="connsiteX1" y="connsiteY1"/>
+              </a:cxn>
+              <a:cxn ang="0">
+                <a:pos x="connsiteX2" y="connsiteY2"/>
+              </a:cxn>
+              <a:cxn ang="0">
+                <a:pos x="connsiteX3" y="connsiteY3"/>
+              </a:cxn>
+              <a:cxn ang="0">
+                <a:pos x="connsiteX4" y="connsiteY4"/>
+              </a:cxn>
+              <a:cxn ang="0">
+                <a:pos x="connsiteX5" y="connsiteY5"/>
+              </a:cxn>
+              <a:cxn ang="0">
+                <a:pos x="connsiteX6" y="connsiteY6"/>
+              </a:cxn>
+              <a:cxn ang="0">
+                <a:pos x="connsiteX7" y="connsiteY7"/>
+              </a:cxn>
+              <a:cxn ang="0">
+                <a:pos x="connsiteX8" y="connsiteY8"/>
+              </a:cxn>
+              <a:cxn ang="0">
+                <a:pos x="connsiteX9" y="connsiteY9"/>
+              </a:cxn>
+              <a:cxn ang="0">
+                <a:pos x="connsiteX10" y="connsiteY10"/>
+              </a:cxn>
+              <a:cxn ang="0">
+                <a:pos x="connsiteX11" y="connsiteY11"/>
+              </a:cxn>
+              <a:cxn ang="0">
+                <a:pos x="connsiteX12" y="connsiteY12"/>
+              </a:cxn>
+              <a:cxn ang="0">
+                <a:pos x="connsiteX13" y="connsiteY13"/>
+              </a:cxn>
+              <a:cxn ang="0">
+                <a:pos x="connsiteX14" y="connsiteY14"/>
+              </a:cxn>
+              <a:cxn ang="0">
+                <a:pos x="connsiteX15" y="connsiteY15"/>
+              </a:cxn>
+            </a:cxnLst>
+            <a:rect l="l" t="t" r="r" b="b"/>
+            <a:pathLst>
+              <a:path w="327663" h="335196">
+                <a:moveTo>
+                  <a:pt x="310594" y="219906"/>
+                </a:moveTo>
+                <a:cubicBezTo>
+                  <a:pt x="287243" y="179983"/>
+                  <a:pt x="246568" y="176217"/>
+                  <a:pt x="246568" y="176217"/>
+                </a:cubicBezTo>
+                <a:lnTo>
+                  <a:pt x="212295" y="176217"/>
+                </a:lnTo>
+                <a:cubicBezTo>
+                  <a:pt x="198360" y="184126"/>
+                  <a:pt x="182541" y="189022"/>
+                  <a:pt x="165217" y="189022"/>
+                </a:cubicBezTo>
+                <a:cubicBezTo>
+                  <a:pt x="147892" y="189022"/>
+                  <a:pt x="132074" y="184503"/>
+                  <a:pt x="118138" y="176217"/>
+                </a:cubicBezTo>
+                <a:lnTo>
+                  <a:pt x="83866" y="176217"/>
+                </a:lnTo>
+                <a:cubicBezTo>
+                  <a:pt x="83866" y="176217"/>
+                  <a:pt x="43190" y="179983"/>
+                  <a:pt x="19839" y="219906"/>
+                </a:cubicBezTo>
+                <a:cubicBezTo>
+                  <a:pt x="-2758" y="259828"/>
+                  <a:pt x="1385" y="299750"/>
+                  <a:pt x="1385" y="299750"/>
+                </a:cubicBezTo>
+                <a:cubicBezTo>
+                  <a:pt x="1385" y="299750"/>
+                  <a:pt x="37164" y="335529"/>
+                  <a:pt x="165970" y="335529"/>
+                </a:cubicBezTo>
+                <a:cubicBezTo>
+                  <a:pt x="294776" y="335529"/>
+                  <a:pt x="329802" y="299750"/>
+                  <a:pt x="329802" y="299750"/>
+                </a:cubicBezTo>
+                <a:cubicBezTo>
+                  <a:pt x="329802" y="299750"/>
+                  <a:pt x="333945" y="259828"/>
+                  <a:pt x="310594" y="219906"/>
+                </a:cubicBezTo>
+                <a:close/>
+                <a:moveTo>
+                  <a:pt x="165593" y="154749"/>
+                </a:moveTo>
+                <a:cubicBezTo>
+                  <a:pt x="208152" y="154749"/>
+                  <a:pt x="242425" y="120477"/>
+                  <a:pt x="242425" y="77918"/>
+                </a:cubicBezTo>
+                <a:cubicBezTo>
+                  <a:pt x="242425" y="35359"/>
+                  <a:pt x="208152" y="1086"/>
+                  <a:pt x="165593" y="1086"/>
+                </a:cubicBezTo>
+                <a:cubicBezTo>
+                  <a:pt x="123035" y="1086"/>
+                  <a:pt x="88762" y="35736"/>
+                  <a:pt x="88762" y="77918"/>
+                </a:cubicBezTo>
+                <a:cubicBezTo>
+                  <a:pt x="88762" y="120477"/>
+                  <a:pt x="123035" y="154749"/>
+                  <a:pt x="165593" y="154749"/>
+                </a:cubicBezTo>
+                <a:close/>
+              </a:path>
+            </a:pathLst>
+          </a:custGeom>
+          <a:solidFill>
+            <a:schemeClr val="bg1"/>
+          </a:solidFill>
+          <a:ln w="3663" cap="flat">
+            <a:noFill/>
+            <a:prstDash val="solid"/>
+            <a:miter/>
+          </a:ln>
+        </p:spPr>
+        <p:txBody>
+          <a:bodyPr rtlCol="0" anchor="ctr"/>
+          <a:lstStyle/>
+          <a:p>
+            <a:pPr marL="0" marR="0" lvl="0" indent="0" algn="l" defTabSz="457200" rtl="0" eaLnBrk="1" fontAlgn="auto" latinLnBrk="0" hangingPunct="1">
+              <a:lnSpc>
+                <a:spcPct val="100000"/>
+              </a:lnSpc>
+              <a:spcBef>
+                <a:spcPts val="0"/>
+              </a:spcBef>
+              <a:spcAft>
+                <a:spcPts val="0"/>
+              </a:spcAft>
+              <a:buClrTx/>
+              <a:buSzTx/>
+              <a:buFontTx/>
+              <a:buNone/>
+              <a:tabLst/>
+              <a:defRPr/>
+            </a:pPr>
+            <a:endParaRPr kumimoji="0" lang="en-US" sz="1800" b="0" i="0" u="none" strike="noStrike" kern="1200" cap="none" spc="0" normalizeH="0" baseline="0" noProof="0">
+              <a:ln>
+                <a:noFill/>
+              </a:ln>
+              <a:solidFill>
+                <a:prstClr val="black"/>
+              </a:solidFill>
+              <a:effectLst/>
+              <a:uLnTx/>
+              <a:uFillTx/>
+              <a:latin typeface="Calibri" panose="020F0502020204030204"/>
+              <a:ea typeface="+mn-ea"/>
+              <a:cs typeface="+mn-cs"/>
+            </a:endParaRPr>
+          </a:p>
+        </p:txBody>
+      </p:sp>
+      <p:sp>
+        <p:nvSpPr>
+          <p:cNvPr id="20" name="Rectangle 19">
+            <a:extLst>
+              <a:ext uri="{FF2B5EF4-FFF2-40B4-BE49-F238E27FC236}">
+                <a16:creationId xmlns:a16="http://schemas.microsoft.com/office/drawing/2014/main" id="{6BA4CF46-E210-4322-91D1-2A41779F64E4}"/>
+              </a:ext>
+            </a:extLst>
+          </p:cNvPr>
+          <p:cNvSpPr/>
+          <p:nvPr/>
+        </p:nvSpPr>
+        <p:spPr>
+          <a:xfrm>
+            <a:off x="2987437" y="3134063"/>
+            <a:ext cx="3878819" cy="1486689"/>
+          </a:xfrm>
+          <a:prstGeom prst="rect">
+            <a:avLst/>
+          </a:prstGeom>
+        </p:spPr>
+        <p:txBody>
+          <a:bodyPr wrap="none">
+            <a:spAutoFit/>
+          </a:bodyPr>
+          <a:lstStyle/>
+          <a:p>
+            <a:pPr marL="0" marR="0" lvl="0" indent="0" algn="l" defTabSz="457200" rtl="0" eaLnBrk="1" fontAlgn="auto" latinLnBrk="0" hangingPunct="1">
+              <a:lnSpc>
+                <a:spcPct val="120000"/>
+              </a:lnSpc>
+              <a:spcBef>
+                <a:spcPts val="0"/>
+              </a:spcBef>
+              <a:spcAft>
+                <a:spcPts val="0"/>
+              </a:spcAft>
+              <a:buClrTx/>
+              <a:buSzTx/>
+              <a:buFontTx/>
+              <a:buNone/>
+              <a:tabLst/>
+              <a:defRPr/>
+            </a:pPr>
+            <a:r>
+              <a:rPr kumimoji="0" lang="en-US" sz="3600" b="0" i="0" u="none" strike="noStrike" kern="1200" cap="none" spc="0" normalizeH="0" baseline="0" noProof="0" dirty="0">
+                <a:ln>
+                  <a:noFill/>
+                </a:ln>
+                <a:solidFill>
+                  <a:prstClr val="white">
+                    <a:lumMod val="50000"/>
+                  </a:prstClr>
+                </a:solidFill>
+                <a:effectLst/>
+                <a:uLnTx/>
+                <a:uFillTx/>
+                <a:latin typeface="Lato" panose="020F0502020204030203" pitchFamily="34" charset="0"/>
+                <a:ea typeface="+mn-ea"/>
+                <a:cs typeface="Segoe UI" panose="020B0502040204020203" pitchFamily="34" charset="0"/>
+              </a:rPr>
+              <a:t>PRESENTER:</a:t>
+            </a:r>
+            <a:r>
+              <a:rPr kumimoji="0" lang="en-US" sz="3600" b="1" i="0" u="none" strike="noStrike" kern="1200" cap="none" spc="0" normalizeH="0" baseline="0" noProof="0" dirty="0">
+                <a:ln>
+                  <a:noFill/>
+                </a:ln>
+                <a:solidFill>
+                  <a:prstClr val="black"/>
+                </a:solidFill>
+                <a:effectLst/>
+                <a:uLnTx/>
+                <a:uFillTx/>
+                <a:latin typeface="Lato" panose="020F0502020204030203" pitchFamily="34" charset="0"/>
+                <a:ea typeface="+mn-ea"/>
+                <a:cs typeface="Segoe UI" panose="020B0502040204020203" pitchFamily="34" charset="0"/>
+              </a:rPr>
+              <a:t> </a:t>
+            </a:r>
+          </a:p>
+          <a:p>
+            <a:pPr marL="0" marR="0" lvl="0" indent="0" algn="l" defTabSz="457200" rtl="0" eaLnBrk="1" fontAlgn="auto" latinLnBrk="0" hangingPunct="1">
+              <a:lnSpc>
+                <a:spcPct val="120000"/>
+              </a:lnSpc>
+              <a:spcBef>
+                <a:spcPts val="0"/>
+              </a:spcBef>
+              <a:spcAft>
+                <a:spcPts val="0"/>
+              </a:spcAft>
+              <a:buClrTx/>
+              <a:buSzTx/>
+              <a:buFontTx/>
+              <a:buNone/>
+              <a:tabLst/>
+              <a:defRPr/>
+            </a:pPr>
+            <a:r>
+              <a:rPr kumimoji="0" lang="en-US" sz="4400" b="1" i="0" u="none" strike="noStrike" kern="1200" cap="none" spc="0" normalizeH="0" baseline="0" noProof="0" dirty="0">
+                <a:ln>
+                  <a:noFill/>
+                </a:ln>
+                <a:solidFill>
+                  <a:prstClr val="black"/>
+                </a:solidFill>
+                <a:effectLst/>
+                <a:highlight>
+                  <a:srgbClr val="FFC107"/>
+                </a:highlight>
+                <a:uLnTx/>
+                <a:uFillTx/>
+                <a:latin typeface="Lato" panose="020F0502020204030203" pitchFamily="34" charset="0"/>
+                <a:ea typeface="+mn-ea"/>
+                <a:cs typeface="Segoe UI" panose="020B0502040204020203" pitchFamily="34" charset="0"/>
+              </a:rPr>
+              <a:t>Leeroy</a:t>
+            </a:r>
+            <a:r>
+              <a:rPr kumimoji="0" lang="en-US" sz="4400" b="1" i="0" u="none" strike="noStrike" kern="1200" cap="none" spc="0" normalizeH="0" baseline="0" noProof="0" dirty="0">
+                <a:ln>
+                  <a:noFill/>
+                </a:ln>
+                <a:solidFill>
+                  <a:prstClr val="black"/>
+                </a:solidFill>
+                <a:effectLst/>
+                <a:uLnTx/>
+                <a:uFillTx/>
+                <a:latin typeface="Lato" panose="020F0502020204030203" pitchFamily="34" charset="0"/>
+                <a:ea typeface="+mn-ea"/>
+                <a:cs typeface="Segoe UI" panose="020B0502040204020203" pitchFamily="34" charset="0"/>
+              </a:rPr>
+              <a:t> </a:t>
+            </a:r>
+            <a:r>
+              <a:rPr kumimoji="0" lang="en-US" sz="4400" b="0" i="0" u="none" strike="noStrike" kern="1200" cap="none" spc="0" normalizeH="0" baseline="0" noProof="0" dirty="0">
+                <a:ln>
+                  <a:noFill/>
+                </a:ln>
+                <a:solidFill>
+                  <a:prstClr val="black"/>
+                </a:solidFill>
+                <a:effectLst/>
+                <a:uLnTx/>
+                <a:uFillTx/>
+                <a:latin typeface="Lato" panose="020F0502020204030203" pitchFamily="34" charset="0"/>
+                <a:ea typeface="+mn-ea"/>
+                <a:cs typeface="Segoe UI" panose="020B0502040204020203" pitchFamily="34" charset="0"/>
+              </a:rPr>
+              <a:t>Jenkins</a:t>
+            </a:r>
+            <a:endParaRPr kumimoji="0" lang="en-US" sz="4400" b="1" i="0" u="none" strike="noStrike" kern="1200" cap="none" spc="0" normalizeH="0" baseline="0" noProof="0" dirty="0">
+              <a:ln>
+                <a:noFill/>
+              </a:ln>
+              <a:solidFill>
+                <a:prstClr val="black"/>
+              </a:solidFill>
+              <a:effectLst/>
+              <a:uLnTx/>
+              <a:uFillTx/>
+              <a:latin typeface="Lato" panose="020F0502020204030203" pitchFamily="34" charset="0"/>
+              <a:ea typeface="+mn-ea"/>
+              <a:cs typeface="Segoe UI" panose="020B0502040204020203" pitchFamily="34" charset="0"/>
+            </a:endParaRPr>
+          </a:p>
+        </p:txBody>
+      </p:sp>
+      <p:sp>
+        <p:nvSpPr>
+          <p:cNvPr id="21" name="TextBox 20">
+            <a:extLst>
+              <a:ext uri="{FF2B5EF4-FFF2-40B4-BE49-F238E27FC236}">
+                <a16:creationId xmlns:a16="http://schemas.microsoft.com/office/drawing/2014/main" id="{CAC155C6-7E35-4156-B9B3-271571AF60CC}"/>
+              </a:ext>
+            </a:extLst>
+          </p:cNvPr>
+          <p:cNvSpPr txBox="1"/>
+          <p:nvPr/>
+        </p:nvSpPr>
+        <p:spPr>
+          <a:xfrm>
+            <a:off x="1022513" y="1085789"/>
+            <a:ext cx="7662037" cy="1754326"/>
+          </a:xfrm>
+          <a:prstGeom prst="rect">
+            <a:avLst/>
+          </a:prstGeom>
+          <a:noFill/>
+        </p:spPr>
+        <p:txBody>
+          <a:bodyPr wrap="square" rtlCol="0">
+            <a:spAutoFit/>
+          </a:bodyPr>
+          <a:lstStyle/>
+          <a:p>
+            <a:pPr marL="0" marR="0" lvl="0" indent="0" algn="l" defTabSz="457200" rtl="0" eaLnBrk="1" fontAlgn="auto" latinLnBrk="0" hangingPunct="1">
+              <a:lnSpc>
+                <a:spcPct val="100000"/>
+              </a:lnSpc>
+              <a:spcBef>
+                <a:spcPts val="0"/>
+              </a:spcBef>
+              <a:spcAft>
+                <a:spcPts val="0"/>
+              </a:spcAft>
+              <a:buClrTx/>
+              <a:buSzTx/>
+              <a:buFontTx/>
+              <a:buNone/>
+              <a:tabLst/>
+              <a:defRPr/>
+            </a:pPr>
+            <a:r>
+              <a:rPr kumimoji="0" lang="en-US" sz="5400" b="1" i="1" u="none" strike="noStrike" kern="1200" cap="none" spc="0" normalizeH="0" baseline="0" noProof="0" dirty="0">
+                <a:ln>
+                  <a:noFill/>
+                </a:ln>
+                <a:solidFill>
+                  <a:prstClr val="black"/>
+                </a:solidFill>
+                <a:effectLst/>
+                <a:uLnTx/>
+                <a:uFillTx/>
+                <a:latin typeface="Lato" panose="020F0502020204030203" pitchFamily="34" charset="0"/>
+                <a:ea typeface="+mn-ea"/>
+                <a:cs typeface="Segoe UI" panose="020B0502040204020203" pitchFamily="34" charset="0"/>
+              </a:rPr>
+              <a:t>Title:</a:t>
+            </a:r>
+            <a:br>
+              <a:rPr kumimoji="0" lang="en-US" sz="5400" b="0" i="1" u="none" strike="noStrike" kern="1200" cap="none" spc="0" normalizeH="0" baseline="0" noProof="0" dirty="0">
+                <a:ln>
+                  <a:noFill/>
+                </a:ln>
+                <a:solidFill>
+                  <a:prstClr val="black"/>
+                </a:solidFill>
+                <a:effectLst/>
+                <a:uLnTx/>
+                <a:uFillTx/>
+                <a:latin typeface="Lato" panose="020F0502020204030203" pitchFamily="34" charset="0"/>
+                <a:ea typeface="+mn-ea"/>
+                <a:cs typeface="Segoe UI" panose="020B0502040204020203" pitchFamily="34" charset="0"/>
+              </a:rPr>
+            </a:br>
+            <a:r>
+              <a:rPr kumimoji="0" lang="en-US" sz="5400" b="0" i="1" u="none" strike="noStrike" kern="1200" cap="none" spc="0" normalizeH="0" baseline="0" noProof="0" dirty="0">
+                <a:ln>
+                  <a:noFill/>
+                </a:ln>
+                <a:solidFill>
+                  <a:prstClr val="black"/>
+                </a:solidFill>
+                <a:effectLst/>
+                <a:uLnTx/>
+                <a:uFillTx/>
+                <a:latin typeface="Lato" panose="020F0502020204030203" pitchFamily="34" charset="0"/>
+                <a:ea typeface="+mn-ea"/>
+                <a:cs typeface="Segoe UI" panose="020B0502040204020203" pitchFamily="34" charset="0"/>
+              </a:rPr>
+              <a:t>Subtitle</a:t>
+            </a:r>
+          </a:p>
+        </p:txBody>
+      </p:sp>
+      <p:sp>
+        <p:nvSpPr>
+          <p:cNvPr id="22" name="TextBox 21">
+            <a:extLst>
+              <a:ext uri="{FF2B5EF4-FFF2-40B4-BE49-F238E27FC236}">
+                <a16:creationId xmlns:a16="http://schemas.microsoft.com/office/drawing/2014/main" id="{C3F61B32-8F5A-4CA2-B549-F3CD26098007}"/>
+              </a:ext>
+            </a:extLst>
+          </p:cNvPr>
+          <p:cNvSpPr txBox="1"/>
+          <p:nvPr/>
+        </p:nvSpPr>
+        <p:spPr>
+          <a:xfrm>
+            <a:off x="41128190" y="25382839"/>
+            <a:ext cx="7517322" cy="2123658"/>
+          </a:xfrm>
+          <a:prstGeom prst="rect">
+            <a:avLst/>
+          </a:prstGeom>
+          <a:noFill/>
+        </p:spPr>
+        <p:txBody>
+          <a:bodyPr wrap="square" rtlCol="0">
+            <a:spAutoFit/>
+          </a:bodyPr>
+          <a:lstStyle/>
+          <a:p>
+            <a:pPr marL="0" marR="0" lvl="0" indent="0" algn="l" defTabSz="457200" rtl="0" eaLnBrk="1" fontAlgn="auto" latinLnBrk="0" hangingPunct="1">
+              <a:lnSpc>
+                <a:spcPct val="100000"/>
+              </a:lnSpc>
+              <a:spcBef>
+                <a:spcPts val="0"/>
+              </a:spcBef>
+              <a:spcAft>
+                <a:spcPts val="0"/>
+              </a:spcAft>
+              <a:buClrTx/>
+              <a:buSzTx/>
+              <a:buFontTx/>
+              <a:buNone/>
+              <a:tabLst/>
+              <a:defRPr/>
+            </a:pPr>
+            <a:r>
+              <a:rPr kumimoji="0" lang="en-US" sz="4400" b="0" i="0" u="none" strike="noStrike" kern="1200" cap="none" spc="0" normalizeH="0" baseline="0" noProof="0" dirty="0">
+                <a:ln>
+                  <a:noFill/>
+                </a:ln>
+                <a:solidFill>
+                  <a:prstClr val="black"/>
+                </a:solidFill>
+                <a:effectLst/>
+                <a:uLnTx/>
+                <a:uFillTx/>
+                <a:latin typeface="Lato" panose="020F0502020204030203" pitchFamily="34" charset="0"/>
+                <a:ea typeface="+mn-ea"/>
+                <a:cs typeface="Segoe UI" panose="020B0502040204020203" pitchFamily="34" charset="0"/>
+              </a:rPr>
+              <a:t>Leeroy</a:t>
+            </a:r>
+            <a:r>
+              <a:rPr kumimoji="0" lang="en-US" sz="4400" b="1" i="0" u="none" strike="noStrike" kern="1200" cap="none" spc="0" normalizeH="0" baseline="0" noProof="0" dirty="0">
+                <a:ln>
+                  <a:noFill/>
+                </a:ln>
+                <a:solidFill>
+                  <a:prstClr val="black"/>
+                </a:solidFill>
+                <a:effectLst/>
+                <a:uLnTx/>
+                <a:uFillTx/>
+                <a:latin typeface="Lato" panose="020F0502020204030203" pitchFamily="34" charset="0"/>
+                <a:ea typeface="+mn-ea"/>
+                <a:cs typeface="Segoe UI" panose="020B0502040204020203" pitchFamily="34" charset="0"/>
+              </a:rPr>
+              <a:t> </a:t>
+            </a:r>
+            <a:r>
+              <a:rPr kumimoji="0" lang="en-US" sz="4400" b="0" i="0" u="none" strike="noStrike" kern="1200" cap="none" spc="0" normalizeH="0" baseline="0" noProof="0" dirty="0">
+                <a:ln>
+                  <a:noFill/>
+                </a:ln>
+                <a:solidFill>
+                  <a:prstClr val="black"/>
+                </a:solidFill>
+                <a:effectLst/>
+                <a:uLnTx/>
+                <a:uFillTx/>
+                <a:latin typeface="Lato" panose="020F0502020204030203" pitchFamily="34" charset="0"/>
+                <a:ea typeface="+mn-ea"/>
+                <a:cs typeface="Segoe UI" panose="020B0502040204020203" pitchFamily="34" charset="0"/>
+              </a:rPr>
+              <a:t>Jenkins, author2, </a:t>
+            </a:r>
+            <a:br>
+              <a:rPr kumimoji="0" lang="en-US" sz="4400" b="0" i="0" u="none" strike="noStrike" kern="1200" cap="none" spc="0" normalizeH="0" baseline="0" noProof="0" dirty="0">
+                <a:ln>
+                  <a:noFill/>
+                </a:ln>
+                <a:solidFill>
+                  <a:prstClr val="black"/>
+                </a:solidFill>
+                <a:effectLst/>
+                <a:uLnTx/>
+                <a:uFillTx/>
+                <a:latin typeface="Lato" panose="020F0502020204030203" pitchFamily="34" charset="0"/>
+                <a:ea typeface="+mn-ea"/>
+                <a:cs typeface="Segoe UI" panose="020B0502040204020203" pitchFamily="34" charset="0"/>
+              </a:rPr>
+            </a:br>
+            <a:r>
+              <a:rPr kumimoji="0" lang="en-US" sz="4400" b="0" i="0" u="none" strike="noStrike" kern="1200" cap="none" spc="0" normalizeH="0" baseline="0" noProof="0" dirty="0">
+                <a:ln>
+                  <a:noFill/>
+                </a:ln>
+                <a:solidFill>
+                  <a:prstClr val="black"/>
+                </a:solidFill>
+                <a:effectLst/>
+                <a:uLnTx/>
+                <a:uFillTx/>
+                <a:latin typeface="Lato" panose="020F0502020204030203" pitchFamily="34" charset="0"/>
+                <a:ea typeface="+mn-ea"/>
+                <a:cs typeface="Segoe UI" panose="020B0502040204020203" pitchFamily="34" charset="0"/>
+              </a:rPr>
+              <a:t>author3, author4, author5, author6, author7, author42</a:t>
+            </a:r>
+            <a:endParaRPr kumimoji="0" lang="en-US" sz="4400" b="1" i="0" u="none" strike="noStrike" kern="1200" cap="none" spc="0" normalizeH="0" baseline="0" noProof="0" dirty="0">
+              <a:ln>
+                <a:noFill/>
+              </a:ln>
+              <a:solidFill>
+                <a:prstClr val="black"/>
+              </a:solidFill>
+              <a:effectLst/>
+              <a:uLnTx/>
+              <a:uFillTx/>
+              <a:latin typeface="Lato" panose="020F0502020204030203" pitchFamily="34" charset="0"/>
+              <a:ea typeface="+mn-ea"/>
+              <a:cs typeface="Segoe UI" panose="020B0502040204020203" pitchFamily="34" charset="0"/>
+            </a:endParaRPr>
+          </a:p>
+        </p:txBody>
+      </p:sp>
+      <p:sp>
+        <p:nvSpPr>
+          <p:cNvPr id="23" name="Graphic 18">
+            <a:extLst>
+              <a:ext uri="{FF2B5EF4-FFF2-40B4-BE49-F238E27FC236}">
+                <a16:creationId xmlns:a16="http://schemas.microsoft.com/office/drawing/2014/main" id="{1B355378-8069-4F41-9F33-76FF52B1D680}"/>
+              </a:ext>
+            </a:extLst>
+          </p:cNvPr>
+          <p:cNvSpPr/>
+          <p:nvPr/>
+        </p:nvSpPr>
+        <p:spPr>
+          <a:xfrm>
+            <a:off x="40636456" y="25584006"/>
+            <a:ext cx="360430" cy="335196"/>
+          </a:xfrm>
+          <a:custGeom>
+            <a:avLst/>
+            <a:gdLst>
+              <a:gd name="connsiteX0" fmla="*/ 310594 w 327663"/>
+              <a:gd name="connsiteY0" fmla="*/ 219906 h 335196"/>
+              <a:gd name="connsiteX1" fmla="*/ 246568 w 327663"/>
+              <a:gd name="connsiteY1" fmla="*/ 176217 h 335196"/>
+              <a:gd name="connsiteX2" fmla="*/ 212295 w 327663"/>
+              <a:gd name="connsiteY2" fmla="*/ 176217 h 335196"/>
+              <a:gd name="connsiteX3" fmla="*/ 165217 w 327663"/>
+              <a:gd name="connsiteY3" fmla="*/ 189022 h 335196"/>
+              <a:gd name="connsiteX4" fmla="*/ 118138 w 327663"/>
+              <a:gd name="connsiteY4" fmla="*/ 176217 h 335196"/>
+              <a:gd name="connsiteX5" fmla="*/ 83866 w 327663"/>
+              <a:gd name="connsiteY5" fmla="*/ 176217 h 335196"/>
+              <a:gd name="connsiteX6" fmla="*/ 19839 w 327663"/>
+              <a:gd name="connsiteY6" fmla="*/ 219906 h 335196"/>
+              <a:gd name="connsiteX7" fmla="*/ 1385 w 327663"/>
+              <a:gd name="connsiteY7" fmla="*/ 299750 h 335196"/>
+              <a:gd name="connsiteX8" fmla="*/ 165970 w 327663"/>
+              <a:gd name="connsiteY8" fmla="*/ 335529 h 335196"/>
+              <a:gd name="connsiteX9" fmla="*/ 329802 w 327663"/>
+              <a:gd name="connsiteY9" fmla="*/ 299750 h 335196"/>
+              <a:gd name="connsiteX10" fmla="*/ 310594 w 327663"/>
+              <a:gd name="connsiteY10" fmla="*/ 219906 h 335196"/>
+              <a:gd name="connsiteX11" fmla="*/ 165593 w 327663"/>
+              <a:gd name="connsiteY11" fmla="*/ 154749 h 335196"/>
+              <a:gd name="connsiteX12" fmla="*/ 242425 w 327663"/>
+              <a:gd name="connsiteY12" fmla="*/ 77918 h 335196"/>
+              <a:gd name="connsiteX13" fmla="*/ 165593 w 327663"/>
+              <a:gd name="connsiteY13" fmla="*/ 1086 h 335196"/>
+              <a:gd name="connsiteX14" fmla="*/ 88762 w 327663"/>
+              <a:gd name="connsiteY14" fmla="*/ 77918 h 335196"/>
+              <a:gd name="connsiteX15" fmla="*/ 165593 w 327663"/>
+              <a:gd name="connsiteY15" fmla="*/ 154749 h 335196"/>
+            </a:gdLst>
+            <a:ahLst/>
+            <a:cxnLst>
+              <a:cxn ang="0">
+                <a:pos x="connsiteX0" y="connsiteY0"/>
+              </a:cxn>
+              <a:cxn ang="0">
+                <a:pos x="connsiteX1" y="connsiteY1"/>
+              </a:cxn>
+              <a:cxn ang="0">
+                <a:pos x="connsiteX2" y="connsiteY2"/>
+              </a:cxn>
+              <a:cxn ang="0">
+                <a:pos x="connsiteX3" y="connsiteY3"/>
+              </a:cxn>
+              <a:cxn ang="0">
+                <a:pos x="connsiteX4" y="connsiteY4"/>
+              </a:cxn>
+              <a:cxn ang="0">
+                <a:pos x="connsiteX5" y="connsiteY5"/>
+              </a:cxn>
+              <a:cxn ang="0">
+                <a:pos x="connsiteX6" y="connsiteY6"/>
+              </a:cxn>
+              <a:cxn ang="0">
+                <a:pos x="connsiteX7" y="connsiteY7"/>
+              </a:cxn>
+              <a:cxn ang="0">
+                <a:pos x="connsiteX8" y="connsiteY8"/>
+              </a:cxn>
+              <a:cxn ang="0">
+                <a:pos x="connsiteX9" y="connsiteY9"/>
+              </a:cxn>
+              <a:cxn ang="0">
+                <a:pos x="connsiteX10" y="connsiteY10"/>
+              </a:cxn>
+              <a:cxn ang="0">
+                <a:pos x="connsiteX11" y="connsiteY11"/>
+              </a:cxn>
+              <a:cxn ang="0">
+                <a:pos x="connsiteX12" y="connsiteY12"/>
+              </a:cxn>
+              <a:cxn ang="0">
+                <a:pos x="connsiteX13" y="connsiteY13"/>
+              </a:cxn>
+              <a:cxn ang="0">
+                <a:pos x="connsiteX14" y="connsiteY14"/>
+              </a:cxn>
+              <a:cxn ang="0">
+                <a:pos x="connsiteX15" y="connsiteY15"/>
+              </a:cxn>
+            </a:cxnLst>
+            <a:rect l="l" t="t" r="r" b="b"/>
+            <a:pathLst>
+              <a:path w="327663" h="335196">
+                <a:moveTo>
+                  <a:pt x="310594" y="219906"/>
+                </a:moveTo>
+                <a:cubicBezTo>
+                  <a:pt x="287243" y="179983"/>
+                  <a:pt x="246568" y="176217"/>
+                  <a:pt x="246568" y="176217"/>
+                </a:cubicBezTo>
+                <a:lnTo>
+                  <a:pt x="212295" y="176217"/>
+                </a:lnTo>
+                <a:cubicBezTo>
+                  <a:pt x="198360" y="184126"/>
+                  <a:pt x="182541" y="189022"/>
+                  <a:pt x="165217" y="189022"/>
+                </a:cubicBezTo>
+                <a:cubicBezTo>
+                  <a:pt x="147892" y="189022"/>
+                  <a:pt x="132074" y="184503"/>
+                  <a:pt x="118138" y="176217"/>
+                </a:cubicBezTo>
+                <a:lnTo>
+                  <a:pt x="83866" y="176217"/>
+                </a:lnTo>
+                <a:cubicBezTo>
+                  <a:pt x="83866" y="176217"/>
+                  <a:pt x="43190" y="179983"/>
+                  <a:pt x="19839" y="219906"/>
+                </a:cubicBezTo>
+                <a:cubicBezTo>
+                  <a:pt x="-2758" y="259828"/>
+                  <a:pt x="1385" y="299750"/>
+                  <a:pt x="1385" y="299750"/>
+                </a:cubicBezTo>
+                <a:cubicBezTo>
+                  <a:pt x="1385" y="299750"/>
+                  <a:pt x="37164" y="335529"/>
+                  <a:pt x="165970" y="335529"/>
+                </a:cubicBezTo>
+                <a:cubicBezTo>
+                  <a:pt x="294776" y="335529"/>
+                  <a:pt x="329802" y="299750"/>
+                  <a:pt x="329802" y="299750"/>
+                </a:cubicBezTo>
+                <a:cubicBezTo>
+                  <a:pt x="329802" y="299750"/>
+                  <a:pt x="333945" y="259828"/>
+                  <a:pt x="310594" y="219906"/>
+                </a:cubicBezTo>
+                <a:close/>
+                <a:moveTo>
+                  <a:pt x="165593" y="154749"/>
+                </a:moveTo>
+                <a:cubicBezTo>
+                  <a:pt x="208152" y="154749"/>
+                  <a:pt x="242425" y="120477"/>
+                  <a:pt x="242425" y="77918"/>
+                </a:cubicBezTo>
+                <a:cubicBezTo>
+                  <a:pt x="242425" y="35359"/>
+                  <a:pt x="208152" y="1086"/>
+                  <a:pt x="165593" y="1086"/>
+                </a:cubicBezTo>
+                <a:cubicBezTo>
+                  <a:pt x="123035" y="1086"/>
+                  <a:pt x="88762" y="35736"/>
+                  <a:pt x="88762" y="77918"/>
+                </a:cubicBezTo>
+                <a:cubicBezTo>
+                  <a:pt x="88762" y="120477"/>
+                  <a:pt x="123035" y="154749"/>
+                  <a:pt x="165593" y="154749"/>
+                </a:cubicBezTo>
+                <a:close/>
+              </a:path>
+            </a:pathLst>
+          </a:custGeom>
+          <a:solidFill>
+            <a:schemeClr val="tx1">
+              <a:lumMod val="50000"/>
+              <a:lumOff val="50000"/>
+            </a:schemeClr>
+          </a:solidFill>
+          <a:ln w="3663" cap="flat">
+            <a:noFill/>
+            <a:prstDash val="solid"/>
+            <a:miter/>
+          </a:ln>
+        </p:spPr>
+        <p:txBody>
+          <a:bodyPr rtlCol="0" anchor="ctr"/>
+          <a:lstStyle/>
+          <a:p>
+            <a:pPr marL="0" marR="0" lvl="0" indent="0" algn="l" defTabSz="457200" rtl="0" eaLnBrk="1" fontAlgn="auto" latinLnBrk="0" hangingPunct="1">
+              <a:lnSpc>
+                <a:spcPct val="100000"/>
+              </a:lnSpc>
+              <a:spcBef>
+                <a:spcPts val="0"/>
+              </a:spcBef>
+              <a:spcAft>
+                <a:spcPts val="0"/>
+              </a:spcAft>
+              <a:buClrTx/>
+              <a:buSzTx/>
+              <a:buFontTx/>
+              <a:buNone/>
+              <a:tabLst/>
+              <a:defRPr/>
+            </a:pPr>
+            <a:endParaRPr kumimoji="0" lang="en-US" sz="1800" b="0" i="0" u="none" strike="noStrike" kern="1200" cap="none" spc="0" normalizeH="0" baseline="0" noProof="0">
+              <a:ln>
+                <a:noFill/>
+              </a:ln>
+              <a:solidFill>
+                <a:prstClr val="black"/>
+              </a:solidFill>
+              <a:effectLst/>
+              <a:uLnTx/>
+              <a:uFillTx/>
+              <a:latin typeface="Calibri" panose="020F0502020204030204"/>
+              <a:ea typeface="+mn-ea"/>
+              <a:cs typeface="+mn-cs"/>
+            </a:endParaRPr>
+          </a:p>
+        </p:txBody>
+      </p:sp>
+      <p:sp>
+        <p:nvSpPr>
+          <p:cNvPr id="2" name="Rectangle 1">
+            <a:extLst>
+              <a:ext uri="{FF2B5EF4-FFF2-40B4-BE49-F238E27FC236}">
+                <a16:creationId xmlns:a16="http://schemas.microsoft.com/office/drawing/2014/main" id="{ADC988AD-FB82-4850-84BE-0F496EB3BDC0}"/>
+              </a:ext>
+            </a:extLst>
+          </p:cNvPr>
+          <p:cNvSpPr/>
+          <p:nvPr/>
+        </p:nvSpPr>
+        <p:spPr>
+          <a:xfrm>
+            <a:off x="18535728" y="22292412"/>
+            <a:ext cx="24688800" cy="1200329"/>
+          </a:xfrm>
+          <a:prstGeom prst="rect">
+            <a:avLst/>
+          </a:prstGeom>
+        </p:spPr>
+        <p:txBody>
+          <a:bodyPr>
+            <a:spAutoFit/>
+          </a:bodyPr>
+          <a:lstStyle/>
+          <a:p>
+            <a:pPr marL="0" marR="0" lvl="0" indent="0" algn="l" defTabSz="457200" rtl="0" eaLnBrk="1" fontAlgn="auto" latinLnBrk="0" hangingPunct="1">
+              <a:lnSpc>
+                <a:spcPct val="100000"/>
+              </a:lnSpc>
+              <a:spcBef>
+                <a:spcPts val="0"/>
+              </a:spcBef>
+              <a:spcAft>
+                <a:spcPts val="0"/>
+              </a:spcAft>
+              <a:buClrTx/>
+              <a:buSzTx/>
+              <a:buFontTx/>
+              <a:buNone/>
+              <a:tabLst/>
+              <a:defRPr/>
+            </a:pPr>
+            <a:r>
+              <a:rPr kumimoji="0" lang="en-US" sz="3600" b="0" i="0" u="none" strike="noStrike" kern="1200" cap="none" spc="0" normalizeH="0" baseline="0" noProof="0" dirty="0">
+                <a:ln>
+                  <a:noFill/>
+                </a:ln>
+                <a:solidFill>
+                  <a:prstClr val="white">
+                    <a:lumMod val="50000"/>
+                  </a:prstClr>
+                </a:solidFill>
+                <a:effectLst/>
+                <a:uLnTx/>
+                <a:uFillTx/>
+                <a:latin typeface="Lato" panose="020F0502020204030203" pitchFamily="34" charset="0"/>
+                <a:ea typeface="+mn-ea"/>
+                <a:cs typeface="Segoe UI" panose="020B0502040204020203" pitchFamily="34" charset="0"/>
+              </a:rPr>
+              <a:t>Visualize your findings with an image, graphic, or a key figure.</a:t>
+            </a:r>
+          </a:p>
+          <a:p>
+            <a:pPr marL="0" marR="0" lvl="0" indent="0" algn="l" defTabSz="457200" rtl="0" eaLnBrk="1" fontAlgn="auto" latinLnBrk="0" hangingPunct="1">
+              <a:lnSpc>
+                <a:spcPct val="100000"/>
+              </a:lnSpc>
+              <a:spcBef>
+                <a:spcPts val="0"/>
+              </a:spcBef>
+              <a:spcAft>
+                <a:spcPts val="0"/>
+              </a:spcAft>
+              <a:buClrTx/>
+              <a:buSzTx/>
+              <a:buFontTx/>
+              <a:buNone/>
+              <a:tabLst/>
+              <a:defRPr/>
+            </a:pPr>
+            <a:endParaRPr kumimoji="0" lang="en-US" sz="3600" b="0" i="0" u="none" strike="noStrike" kern="1200" cap="none" spc="0" normalizeH="0" baseline="0" noProof="0" dirty="0">
+              <a:ln>
+                <a:noFill/>
+              </a:ln>
+              <a:solidFill>
+                <a:prstClr val="white">
+                  <a:lumMod val="50000"/>
+                </a:prstClr>
+              </a:solidFill>
+              <a:effectLst/>
+              <a:uLnTx/>
+              <a:uFillTx/>
+              <a:latin typeface="Lato" panose="020F0502020204030203" pitchFamily="34" charset="0"/>
+              <a:ea typeface="+mn-ea"/>
+              <a:cs typeface="Segoe UI" panose="020B0502040204020203" pitchFamily="34" charset="0"/>
+            </a:endParaRPr>
+          </a:p>
+        </p:txBody>
+      </p:sp>
+      <p:pic>
+        <p:nvPicPr>
+          <p:cNvPr id="14" name="Graphic 13">
+            <a:extLst>
+              <a:ext uri="{FF2B5EF4-FFF2-40B4-BE49-F238E27FC236}">
+                <a16:creationId xmlns:a16="http://schemas.microsoft.com/office/drawing/2014/main" id="{8469FA09-6407-4240-A302-A9681C46F182}"/>
+              </a:ext>
+            </a:extLst>
+          </p:cNvPr>
+          <p:cNvPicPr>
+            <a:picLocks noChangeAspect="1"/>
+          </p:cNvPicPr>
+          <p:nvPr/>
+        </p:nvPicPr>
+        <p:blipFill>
+          <a:blip>
+            <a:extLst>
+              <a:ext uri="{28A0092B-C50C-407E-A947-70E740481C1C}">
+                <a14:useLocalDpi xmlns:a14="http://schemas.microsoft.com/office/drawing/2010/main" val="0"/>
+              </a:ext>
+              <a:ext uri="{96DAC541-7B7A-43D3-8B79-37D633B846F1}">
+                <asvg:svgBlip xmlns:asvg="http://schemas.microsoft.com/office/drawing/2016/SVG/main" r:embed="rId4"/>
+              </a:ext>
+            </a:extLst>
+          </a:blip>
+          <a:stretch>
+            <a:fillRect/>
+          </a:stretch>
+        </p:blipFill>
+        <p:spPr>
+          <a:xfrm>
+            <a:off x="12979201" y="27597921"/>
+            <a:ext cx="3783061" cy="3783061"/>
+          </a:xfrm>
+          <a:prstGeom prst="rect">
+            <a:avLst/>
+          </a:prstGeom>
+        </p:spPr>
+      </p:pic>
+      <p:pic>
+        <p:nvPicPr>
+          <p:cNvPr id="27" name="Graphic 26">
+            <a:extLst>
+              <a:ext uri="{FF2B5EF4-FFF2-40B4-BE49-F238E27FC236}">
+                <a16:creationId xmlns:a16="http://schemas.microsoft.com/office/drawing/2014/main" id="{B62BF9C0-8774-4458-8210-ACA4788001C5}"/>
+              </a:ext>
+            </a:extLst>
+          </p:cNvPr>
+          <p:cNvPicPr>
+            <a:picLocks noChangeAspect="1"/>
+          </p:cNvPicPr>
+          <p:nvPr/>
+        </p:nvPicPr>
+        <p:blipFill>
+          <a:blip>
+            <a:extLst>
+              <a:ext uri="{96DAC541-7B7A-43D3-8B79-37D633B846F1}">
+                <asvg:svgBlip xmlns:asvg="http://schemas.microsoft.com/office/drawing/2016/SVG/main" r:embed="rId5"/>
+              </a:ext>
+            </a:extLst>
+          </a:blip>
+          <a:stretch>
+            <a:fillRect/>
+          </a:stretch>
+        </p:blipFill>
+        <p:spPr>
+          <a:xfrm>
+            <a:off x="18754101" y="13358194"/>
+            <a:ext cx="12223692" cy="8149128"/>
+          </a:xfrm>
+          <a:prstGeom prst="rect">
+            <a:avLst/>
+          </a:prstGeom>
+        </p:spPr>
+      </p:pic>
+    </p:spTree>
+    <p:extLst>
+      <p:ext uri="{BB962C8B-B14F-4D97-AF65-F5344CB8AC3E}">
+        <p14:creationId xmlns:p14="http://schemas.microsoft.com/office/powerpoint/2010/main" val="3338587597"/>
       </p:ext>
     </p:extLst>
   </p:cSld>

</xml_diff>